<commit_message>
Docs: detalhar a leitura da API Prolog (loader Pneus)
- DOCUMENTACAO-TI.md §8: base URL/auth da Prolog, endpoints (/vehicles,
  /tires, /tire-inspections/vehicles), paginação, rate limit e retries,
  14 branch ids, proteção contra snapshot vazio, upsert no Supabase,
  agendamento/secrets do Actions e diagnóstico
- deck técnico: novo slide "Integração Conlog — leitura da API Prolog"

Co-Authored-By: Claude Fable 5 <noreply@anthropic.com>
Claude-Session: https://claude.ai/code/session_01CoPzrx19nUHZqody5fEJUg
</commit_message>
<xml_diff>
--- a/docs/Gestao-em-Movimento_Tecnico-TI.pptx
+++ b/docs/Gestao-em-Movimento_Tecnico-TI.pptx
@@ -20,6 +20,7 @@
     <p:sldId id="268" r:id="rId19"/>
     <p:sldId id="269" r:id="rId20"/>
     <p:sldId id="270" r:id="rId21"/>
+    <p:sldId id="271" r:id="rId22"/>
   </p:sldIdLst>
   <p:sldSz cx="12191695" cy="6858000" type="screen4x3"/>
   <p:notesSz cx="6858000" cy="9144000"/>
@@ -3429,21 +3430,308 @@
                 </a:solidFill>
                 <a:latin typeface="Montserrat"/>
               </a:rPr>
-              <a:t>Módulo FCA — painéis e fluxo de preenchimento</a:t>
-            </a:r>
-          </a:p>
-        </p:txBody>
-      </p:sp>
-      <p:sp>
-        <p:nvSpPr>
-          <p:cNvPr id="5" name="TextBox 4"/>
+              <a:t>Módulo FCA — geração dos desvios</a:t>
+            </a:r>
+          </a:p>
+          <a:p>
+            <a:r>
+              <a:rPr sz="1200" b="0" i="0">
+                <a:solidFill>
+                  <a:srgbClr val="94A3B8"/>
+                </a:solidFill>
+                <a:latin typeface="Montserrat"/>
+              </a:rPr>
+              <a:t>O banco é o dono; planilhas só entram na geração (admin)</a:t>
+            </a:r>
+          </a:p>
+        </p:txBody>
+      </p:sp>
+      <p:sp>
+        <p:nvSpPr>
+          <p:cNvPr id="5" name="Rounded Rectangle 4"/>
+          <p:cNvSpPr/>
+          <p:nvPr/>
+        </p:nvSpPr>
+        <p:spPr>
+          <a:xfrm>
+            <a:off x="548640" y="1508760"/>
+            <a:ext cx="5394960" cy="2286000"/>
+          </a:xfrm>
+          <a:prstGeom prst="roundRect">
+            <a:avLst/>
+          </a:prstGeom>
+          <a:solidFill>
+            <a:srgbClr val="141B26"/>
+          </a:solidFill>
+          <a:ln w="12700">
+            <a:solidFill>
+              <a:srgbClr val="1E2D40"/>
+            </a:solidFill>
+          </a:ln>
+        </p:spPr>
+        <p:style>
+          <a:lnRef idx="1">
+            <a:schemeClr val="accent1"/>
+          </a:lnRef>
+          <a:fillRef idx="3">
+            <a:schemeClr val="accent1"/>
+          </a:fillRef>
+          <a:effectRef idx="2">
+            <a:schemeClr val="accent1"/>
+          </a:effectRef>
+          <a:fontRef idx="minor">
+            <a:schemeClr val="lt1"/>
+          </a:fontRef>
+        </p:style>
+        <p:txBody>
+          <a:bodyPr rtlCol="0" anchor="t" wrap="square" lIns="146304" rIns="128016" tIns="91440" bIns="73152"/>
+          <a:lstStyle/>
+          <a:p>
+            <a:pPr algn="ctr">
+              <a:spcAft>
+                <a:spcPts val="400"/>
+              </a:spcAft>
+            </a:pPr>
+            <a:r>
+              <a:rPr sz="1300" b="1" i="0">
+                <a:solidFill>
+                  <a:srgbClr val="F97316"/>
+                </a:solidFill>
+                <a:latin typeface="Montserrat"/>
+              </a:rPr>
+              <a:t>GERAR CUSTOS  (?gen=all)</a:t>
+            </a:r>
+          </a:p>
+          <a:p>
+            <a:pPr>
+              <a:spcAft>
+                <a:spcPts val="200"/>
+              </a:spcAft>
+            </a:pPr>
+            <a:r>
+              <a:rPr sz="1100" b="0" i="0">
+                <a:solidFill>
+                  <a:srgbClr val="94A3B8"/>
+                </a:solidFill>
+                <a:latin typeface="Montserrat"/>
+              </a:rPr>
+              <a:t>Lê a DRE do último mês fechado (todas as unidades)</a:t>
+            </a:r>
+          </a:p>
+          <a:p>
+            <a:pPr>
+              <a:spcAft>
+                <a:spcPts val="200"/>
+              </a:spcAft>
+            </a:pPr>
+            <a:r>
+              <a:rPr sz="1100" b="0" i="0">
+                <a:solidFill>
+                  <a:srgbClr val="94A3B8"/>
+                </a:solidFill>
+                <a:latin typeface="Montserrat"/>
+              </a:rPr>
+              <a:t>Desvio = gasto acima do remunerado (custos são negativos na DRE)</a:t>
+            </a:r>
+          </a:p>
+          <a:p>
+            <a:pPr>
+              <a:spcAft>
+                <a:spcPts val="200"/>
+              </a:spcAft>
+            </a:pPr>
+            <a:r>
+              <a:rPr sz="1100" b="0" i="0">
+                <a:solidFill>
+                  <a:srgbClr val="94A3B8"/>
+                </a:solidFill>
+                <a:latin typeface="Montserrat"/>
+              </a:rPr>
+              <a:t>Cria fatos VAZIOS p/ as unidades preencherem</a:t>
+            </a:r>
+          </a:p>
+          <a:p>
+            <a:pPr>
+              <a:spcAft>
+                <a:spcPts val="200"/>
+              </a:spcAft>
+            </a:pPr>
+            <a:r>
+              <a:rPr sz="1100" b="0" i="0">
+                <a:solidFill>
+                  <a:srgbClr val="94A3B8"/>
+                </a:solidFill>
+                <a:latin typeface="Montserrat"/>
+              </a:rPr>
+              <a:t>Km/L e R$/L não viram fato — entram como causa do Combustível</a:t>
+            </a:r>
+          </a:p>
+          <a:p>
+            <a:pPr>
+              <a:spcAft>
+                <a:spcPts val="200"/>
+              </a:spcAft>
+            </a:pPr>
+            <a:r>
+              <a:rPr sz="1100" b="0" i="0">
+                <a:solidFill>
+                  <a:srgbClr val="94A3B8"/>
+                </a:solidFill>
+                <a:latin typeface="Montserrat"/>
+              </a:rPr>
+              <a:t>Causas automáticas: piores placas, dispersão de km</a:t>
+            </a:r>
+          </a:p>
+        </p:txBody>
+      </p:sp>
+      <p:sp>
+        <p:nvSpPr>
+          <p:cNvPr id="6" name="Rounded Rectangle 5"/>
+          <p:cNvSpPr/>
+          <p:nvPr/>
+        </p:nvSpPr>
+        <p:spPr>
+          <a:xfrm>
+            <a:off x="6217920" y="1508760"/>
+            <a:ext cx="5394960" cy="2286000"/>
+          </a:xfrm>
+          <a:prstGeom prst="roundRect">
+            <a:avLst/>
+          </a:prstGeom>
+          <a:solidFill>
+            <a:srgbClr val="141B26"/>
+          </a:solidFill>
+          <a:ln w="12700">
+            <a:solidFill>
+              <a:srgbClr val="1E2D40"/>
+            </a:solidFill>
+          </a:ln>
+        </p:spPr>
+        <p:style>
+          <a:lnRef idx="1">
+            <a:schemeClr val="accent1"/>
+          </a:lnRef>
+          <a:fillRef idx="3">
+            <a:schemeClr val="accent1"/>
+          </a:fillRef>
+          <a:effectRef idx="2">
+            <a:schemeClr val="accent1"/>
+          </a:effectRef>
+          <a:fontRef idx="minor">
+            <a:schemeClr val="lt1"/>
+          </a:fontRef>
+        </p:style>
+        <p:txBody>
+          <a:bodyPr rtlCol="0" anchor="t" wrap="square" lIns="146304" rIns="128016" tIns="91440" bIns="73152"/>
+          <a:lstStyle/>
+          <a:p>
+            <a:pPr algn="ctr">
+              <a:spcAft>
+                <a:spcPts val="400"/>
+              </a:spcAft>
+            </a:pPr>
+            <a:r>
+              <a:rPr sz="1300" b="1" i="0">
+                <a:solidFill>
+                  <a:srgbClr val="F97316"/>
+                </a:solidFill>
+                <a:latin typeface="Montserrat"/>
+              </a:rPr>
+              <a:t>GERAR RPM  (?sync=rpm)</a:t>
+            </a:r>
+          </a:p>
+          <a:p>
+            <a:pPr>
+              <a:spcAft>
+                <a:spcPts val="200"/>
+              </a:spcAft>
+            </a:pPr>
+            <a:r>
+              <a:rPr sz="1100" b="0" i="0">
+                <a:solidFill>
+                  <a:srgbClr val="94A3B8"/>
+                </a:solidFill>
+                <a:latin typeface="Montserrat"/>
+              </a:rPr>
+              <a:t>Lê a aba Base RPM do Gerot POR NOME de coluna</a:t>
+            </a:r>
+          </a:p>
+          <a:p>
+            <a:pPr>
+              <a:spcAft>
+                <a:spcPts val="200"/>
+              </a:spcAft>
+            </a:pPr>
+            <a:r>
+              <a:rPr sz="1100" b="0" i="0">
+                <a:solidFill>
+                  <a:srgbClr val="94A3B8"/>
+                </a:solidFill>
+                <a:latin typeface="Montserrat"/>
+              </a:rPr>
+              <a:t>IC/IV com atingimento &lt; 100% viram fato (desvio Meta|Real|Ating)</a:t>
+            </a:r>
+          </a:p>
+          <a:p>
+            <a:pPr>
+              <a:spcAft>
+                <a:spcPts val="200"/>
+              </a:spcAft>
+            </a:pPr>
+            <a:r>
+              <a:rPr sz="1100" b="0" i="0">
+                <a:solidFill>
+                  <a:srgbClr val="94A3B8"/>
+                </a:solidFill>
+                <a:latin typeface="Montserrat"/>
+              </a:rPr>
+              <a:t>Unidade→(código, projeto) fixo no código: RPM_UNIT_MAP</a:t>
+            </a:r>
+          </a:p>
+          <a:p>
+            <a:pPr>
+              <a:spcAft>
+                <a:spcPts val="200"/>
+              </a:spcAft>
+            </a:pPr>
+            <a:r>
+              <a:rPr sz="1100" b="0" i="0">
+                <a:solidFill>
+                  <a:srgbClr val="94A3B8"/>
+                </a:solidFill>
+                <a:latin typeface="Montserrat"/>
+              </a:rPr>
+              <a:t>Corte FILL_UNTIL=202604: ≤mai/26 veio preenchido da aba;</a:t>
+            </a:r>
+          </a:p>
+          <a:p>
+            <a:pPr>
+              <a:spcAft>
+                <a:spcPts val="200"/>
+              </a:spcAft>
+            </a:pPr>
+            <a:r>
+              <a:rPr sz="1100" b="0" i="0">
+                <a:solidFill>
+                  <a:srgbClr val="94A3B8"/>
+                </a:solidFill>
+                <a:latin typeface="Montserrat"/>
+              </a:rPr>
+              <a:t>de jun/26 em diante nasce vazio (preenchimento é no painel)</a:t>
+            </a:r>
+          </a:p>
+        </p:txBody>
+      </p:sp>
+      <p:sp>
+        <p:nvSpPr>
+          <p:cNvPr id="7" name="TextBox 6"/>
           <p:cNvSpPr txBox="1"/>
           <p:nvPr/>
         </p:nvSpPr>
         <p:spPr>
           <a:xfrm>
-            <a:off x="548640" y="1417320"/>
-            <a:ext cx="11064240" cy="5120640"/>
+            <a:off x="548640" y="4069080"/>
+            <a:ext cx="11064240" cy="1828800"/>
           </a:xfrm>
           <a:prstGeom prst="rect">
             <a:avLst/>
@@ -3456,210 +3744,43 @@
           </a:bodyPr>
           <a:lstStyle/>
           <a:p>
-            <a:pPr>
-              <a:spcAft>
-                <a:spcPts val="700"/>
-              </a:spcAft>
-            </a:pPr>
             <a:r>
               <a:rPr sz="1500" b="1" i="0">
                 <a:solidFill>
-                  <a:srgbClr val="F97316"/>
-                </a:solidFill>
-                <a:latin typeface="Montserrat"/>
-              </a:rPr>
-              <a:t>▪  </a:t>
-            </a:r>
-            <a:r>
-              <a:rPr sz="1500" b="1" i="0">
-                <a:solidFill>
-                  <a:srgbClr val="F97316"/>
-                </a:solidFill>
-                <a:latin typeface="Montserrat"/>
-              </a:rPr>
-              <a:t>fca-preenchimento/ — a unidade trata seus desvios:</a:t>
-            </a:r>
-          </a:p>
-          <a:p>
-            <a:pPr>
-              <a:spcAft>
-                <a:spcPts val="400"/>
-              </a:spcAft>
-            </a:pPr>
-            <a:r>
-              <a:rPr sz="1350" b="1" i="0">
+                  <a:srgbClr val="3BB33B"/>
+                </a:solidFill>
+                <a:latin typeface="Montserrat"/>
+              </a:rPr>
+              <a:t>As duas rotinas são ADITIVAS e IDEMPOTENTES:</a:t>
+            </a:r>
+          </a:p>
+          <a:p>
+            <a:r>
+              <a:rPr sz="1300" b="0" i="0">
+                <a:solidFill>
+                  <a:srgbClr val="94A3B8"/>
+                </a:solidFill>
+                <a:latin typeface="Montserrat"/>
+              </a:rPr>
+              <a:t>só inserem o que não existe (chave = vigência+origem+projeto+fato). Nunca apagam nem sobrescrevem o que a unidade preencheu. Clicar 2× não duplica.</a:t>
+            </a:r>
+          </a:p>
+          <a:p>
+            <a:r>
+              <a:rPr sz="1200" b="0" i="0">
                 <a:solidFill>
                   <a:srgbClr val="64748B"/>
                 </a:solidFill>
                 <a:latin typeface="Montserrat"/>
               </a:rPr>
-              <a:t>      –  </a:t>
-            </a:r>
-            <a:r>
-              <a:rPr sz="1350" b="0" i="0">
-                <a:solidFill>
-                  <a:srgbClr val="F1F5F9"/>
-                </a:solidFill>
-                <a:latin typeface="Montserrat"/>
-              </a:rPr>
-              <a:t>preenche Causa · Ação · Responsável · Prazo · Status (+ adicionar ação/causa)</a:t>
-            </a:r>
-          </a:p>
-          <a:p>
-            <a:pPr>
-              <a:spcAft>
-                <a:spcPts val="400"/>
-              </a:spcAft>
-            </a:pPr>
-            <a:r>
-              <a:rPr sz="1350" b="1" i="0">
-                <a:solidFill>
-                  <a:srgbClr val="64748B"/>
-                </a:solidFill>
-                <a:latin typeface="Montserrat"/>
-              </a:rPr>
-              <a:t>      –  </a:t>
-            </a:r>
-            <a:r>
-              <a:rPr sz="1350" b="1" i="0">
-                <a:solidFill>
-                  <a:srgbClr val="FF6666"/>
-                </a:solidFill>
-                <a:latin typeface="Montserrat"/>
-              </a:rPr>
-              <a:t>SÓ GRAVA AO CLICAR SALVAR → vai ao Supabase e TRAVA a ação (só o Acompanhamento segue editável)</a:t>
-            </a:r>
-          </a:p>
-          <a:p>
-            <a:pPr>
-              <a:spcAft>
-                <a:spcPts val="400"/>
-              </a:spcAft>
-            </a:pPr>
-            <a:r>
-              <a:rPr sz="1350" b="1" i="0">
-                <a:solidFill>
-                  <a:srgbClr val="64748B"/>
-                </a:solidFill>
-                <a:latin typeface="Montserrat"/>
-              </a:rPr>
-              <a:t>      –  </a:t>
-            </a:r>
-            <a:r>
-              <a:rPr sz="1350" b="0" i="0">
-                <a:solidFill>
-                  <a:srgbClr val="F1F5F9"/>
-                </a:solidFill>
-                <a:latin typeface="Montserrat"/>
-              </a:rPr>
-              <a:t>sair sem salvar = perde o que digitou (não há autosave)</a:t>
-            </a:r>
-          </a:p>
-          <a:p>
-            <a:pPr>
-              <a:spcAft>
-                <a:spcPts val="700"/>
-              </a:spcAft>
-            </a:pPr>
-            <a:r>
-              <a:rPr sz="1500" b="1" i="0">
-                <a:solidFill>
-                  <a:srgbClr val="F97316"/>
-                </a:solidFill>
-                <a:latin typeface="Montserrat"/>
-              </a:rPr>
-              <a:t>▪  </a:t>
-            </a:r>
-            <a:r>
-              <a:rPr sz="1500" b="0" i="0">
-                <a:solidFill>
-                  <a:srgbClr val="F1F5F9"/>
-                </a:solidFill>
-                <a:latin typeface="Montserrat"/>
-              </a:rPr>
-              <a:t>fca-consolidado/ — Admin: edita tudo, exclui, +ação/+causa, botões Gerar Custos / Gerar RPM.</a:t>
-            </a:r>
-          </a:p>
-          <a:p>
-            <a:pPr>
-              <a:spcAft>
-                <a:spcPts val="700"/>
-              </a:spcAft>
-            </a:pPr>
-            <a:r>
-              <a:rPr sz="1500" b="1" i="0">
-                <a:solidFill>
-                  <a:srgbClr val="F97316"/>
-                </a:solidFill>
-                <a:latin typeface="Montserrat"/>
-              </a:rPr>
-              <a:t>▪  </a:t>
-            </a:r>
-            <a:r>
-              <a:rPr sz="1500" b="0" i="0">
-                <a:solidFill>
-                  <a:srgbClr val="F1F5F9"/>
-                </a:solidFill>
-                <a:latin typeface="Montserrat"/>
-              </a:rPr>
-              <a:t>Visões Tabela e Kanban (Não iniciada / Em andamento / Concluída) com drag-and-drop de status.</a:t>
-            </a:r>
-          </a:p>
-          <a:p>
-            <a:pPr>
-              <a:spcAft>
-                <a:spcPts val="700"/>
-              </a:spcAft>
-            </a:pPr>
-            <a:r>
-              <a:rPr sz="1500" b="1" i="0">
-                <a:solidFill>
-                  <a:srgbClr val="F97316"/>
-                </a:solidFill>
-                <a:latin typeface="Montserrat"/>
-              </a:rPr>
-              <a:t>▪  </a:t>
-            </a:r>
-            <a:r>
-              <a:rPr sz="1500" b="0" i="0">
-                <a:solidFill>
-                  <a:srgbClr val="F1F5F9"/>
-                </a:solidFill>
-                <a:latin typeface="Montserrat"/>
-              </a:rPr>
-              <a:t>fca/ (consolidado leitura) e fca-gerencial/ (Aderência ao FCA) leem a MESMA base com as mesmas regras.</a:t>
-            </a:r>
-          </a:p>
-          <a:p>
-            <a:pPr>
-              <a:spcAft>
-                <a:spcPts val="700"/>
-              </a:spcAft>
-            </a:pPr>
-            <a:r>
-              <a:rPr sz="1500" b="1" i="0">
-                <a:solidFill>
-                  <a:srgbClr val="F97316"/>
-                </a:solidFill>
-                <a:latin typeface="Montserrat"/>
-              </a:rPr>
-              <a:t>▪  </a:t>
-            </a:r>
-            <a:r>
-              <a:rPr sz="1500" b="0" i="0">
-                <a:solidFill>
-                  <a:srgbClr val="F1F5F9"/>
-                </a:solidFill>
-                <a:latin typeface="Montserrat"/>
-              </a:rPr>
-              <a:t>Filtros padrão com “só”; vigência abre no mês mais recente; cache localStorage p/ velocidade.</a:t>
-            </a:r>
-          </a:p>
-        </p:txBody>
-      </p:sp>
-      <p:sp>
-        <p:nvSpPr>
-          <p:cNvPr id="6" name="TextBox 5"/>
+              <a:t>Cutover: o histórico foi importado uma única vez do “FCA Total” (rotina já removida da UI). A planilha FCA Total é LEGADO — não é mais fonte.</a:t>
+            </a:r>
+          </a:p>
+        </p:txBody>
+      </p:sp>
+      <p:sp>
+        <p:nvSpPr>
+          <p:cNvPr id="8" name="TextBox 7"/>
           <p:cNvSpPr txBox="1"/>
           <p:nvPr/>
         </p:nvSpPr>
@@ -3844,7 +3965,7 @@
                 </a:solidFill>
                 <a:latin typeface="Montserrat"/>
               </a:rPr>
-              <a:t>Termômetro e MPR</a:t>
+              <a:t>Módulo FCA — painéis e fluxo de preenchimento</a:t>
             </a:r>
           </a:p>
         </p:txBody>
@@ -3892,7 +4013,7 @@
                 </a:solidFill>
                 <a:latin typeface="Montserrat"/>
               </a:rPr>
-              <a:t>Termômetro (termometro/): pontuação de conformidade por unidade/tier.</a:t>
+              <a:t>fca-preenchimento/ — a unidade trata seus desvios:</a:t>
             </a:r>
           </a:p>
           <a:p>
@@ -3917,7 +4038,7 @@
                 </a:solidFill>
                 <a:latin typeface="Montserrat"/>
               </a:rPr>
-              <a:t>Fonte: planilha do termômetro — abas = tiers (Transportes T1/T2, WH T1/T2) + aba Regras</a:t>
+              <a:t>preenche Causa · Ação · Responsável · Prazo · Status (+ adicionar ação/causa)</a:t>
             </a:r>
           </a:p>
           <a:p>
@@ -3936,38 +4057,63 @@
               <a:t>      –  </a:t>
             </a:r>
             <a:r>
+              <a:rPr sz="1350" b="1" i="0">
+                <a:solidFill>
+                  <a:srgbClr val="FF6666"/>
+                </a:solidFill>
+                <a:latin typeface="Montserrat"/>
+              </a:rPr>
+              <a:t>SÓ GRAVA AO CLICAR SALVAR → vai ao Supabase e TRAVA a ação (só o Acompanhamento segue editável)</a:t>
+            </a:r>
+          </a:p>
+          <a:p>
+            <a:pPr>
+              <a:spcAft>
+                <a:spcPts val="400"/>
+              </a:spcAft>
+            </a:pPr>
+            <a:r>
+              <a:rPr sz="1350" b="1" i="0">
+                <a:solidFill>
+                  <a:srgbClr val="64748B"/>
+                </a:solidFill>
+                <a:latin typeface="Montserrat"/>
+              </a:rPr>
+              <a:t>      –  </a:t>
+            </a:r>
+            <a:r>
               <a:rPr sz="1350" b="0" i="0">
                 <a:solidFill>
                   <a:srgbClr val="F1F5F9"/>
                 </a:solidFill>
                 <a:latin typeface="Montserrat"/>
               </a:rPr>
-              <a:t>Vigência quinzenal (M_Q); FILTRO é por mês e a Q2 REGE (fallback Q1 se o mês não fechou)</a:t>
-            </a:r>
-          </a:p>
-          <a:p>
-            <a:pPr>
-              <a:spcAft>
-                <a:spcPts val="400"/>
-              </a:spcAft>
-            </a:pPr>
-            <a:r>
-              <a:rPr sz="1350" b="1" i="0">
-                <a:solidFill>
-                  <a:srgbClr val="64748B"/>
-                </a:solidFill>
-                <a:latin typeface="Montserrat"/>
-              </a:rPr>
-              <a:t>      –  </a:t>
-            </a:r>
-            <a:r>
-              <a:rPr sz="1350" b="0" i="0">
+              <a:t>sair sem salvar = perde o que digitou (não há autosave)</a:t>
+            </a:r>
+          </a:p>
+          <a:p>
+            <a:pPr>
+              <a:spcAft>
+                <a:spcPts val="700"/>
+              </a:spcAft>
+            </a:pPr>
+            <a:r>
+              <a:rPr sz="1500" b="1" i="0">
+                <a:solidFill>
+                  <a:srgbClr val="F97316"/>
+                </a:solidFill>
+                <a:latin typeface="Montserrat"/>
+              </a:rPr>
+              <a:t>▪  </a:t>
+            </a:r>
+            <a:r>
+              <a:rPr sz="1500" b="0" i="0">
                 <a:solidFill>
                   <a:srgbClr val="F1F5F9"/>
                 </a:solidFill>
                 <a:latin typeface="Montserrat"/>
               </a:rPr>
-              <a:t>Gráfico temporal mostra as 2 quinzenas — Q1 com preenchimento hachurado</a:t>
+              <a:t>fca-consolidado/ — Admin: edita tudo, exclui, +ação/+causa, botões Gerar Custos / Gerar RPM.</a:t>
             </a:r>
           </a:p>
           <a:p>
@@ -3986,138 +4132,63 @@
               <a:t>▪  </a:t>
             </a:r>
             <a:r>
+              <a:rPr sz="1500" b="0" i="0">
+                <a:solidFill>
+                  <a:srgbClr val="F1F5F9"/>
+                </a:solidFill>
+                <a:latin typeface="Montserrat"/>
+              </a:rPr>
+              <a:t>Visões Tabela e Kanban (Não iniciada / Em andamento / Concluída) com drag-and-drop de status.</a:t>
+            </a:r>
+          </a:p>
+          <a:p>
+            <a:pPr>
+              <a:spcAft>
+                <a:spcPts val="700"/>
+              </a:spcAft>
+            </a:pPr>
+            <a:r>
               <a:rPr sz="1500" b="1" i="0">
                 <a:solidFill>
                   <a:srgbClr val="F97316"/>
                 </a:solidFill>
                 <a:latin typeface="Montserrat"/>
               </a:rPr>
-              <a:t>MPR (mpr/): Monthly Performance Review — matriz indicador × GEO/unidade.</a:t>
-            </a:r>
-          </a:p>
-          <a:p>
-            <a:pPr>
-              <a:spcAft>
-                <a:spcPts val="400"/>
-              </a:spcAft>
-            </a:pPr>
-            <a:r>
-              <a:rPr sz="1350" b="1" i="0">
-                <a:solidFill>
-                  <a:srgbClr val="64748B"/>
-                </a:solidFill>
-                <a:latin typeface="Montserrat"/>
-              </a:rPr>
-              <a:t>      –  </a:t>
-            </a:r>
-            <a:r>
-              <a:rPr sz="1350" b="0" i="0">
+              <a:t>▪  </a:t>
+            </a:r>
+            <a:r>
+              <a:rPr sz="1500" b="0" i="0">
                 <a:solidFill>
                   <a:srgbClr val="F1F5F9"/>
                 </a:solidFill>
                 <a:latin typeface="Montserrat"/>
               </a:rPr>
-              <a:t>GEO agrupa unidades (expande no “+”) · linhas 2025 (vazio) e 2026 · coluna Plan = meta da regra</a:t>
-            </a:r>
-          </a:p>
-          <a:p>
-            <a:pPr>
-              <a:spcAft>
-                <a:spcPts val="400"/>
-              </a:spcAft>
-            </a:pPr>
-            <a:r>
-              <a:rPr sz="1350" b="1" i="0">
-                <a:solidFill>
-                  <a:srgbClr val="64748B"/>
-                </a:solidFill>
-                <a:latin typeface="Montserrat"/>
-              </a:rPr>
-              <a:t>      –  </a:t>
-            </a:r>
-            <a:r>
-              <a:rPr sz="1350" b="0" i="0">
+              <a:t>fca/ (consolidado leitura) e fca-gerencial/ (Aderência ao FCA) leem a MESMA base com as mesmas regras.</a:t>
+            </a:r>
+          </a:p>
+          <a:p>
+            <a:pPr>
+              <a:spcAft>
+                <a:spcPts val="700"/>
+              </a:spcAft>
+            </a:pPr>
+            <a:r>
+              <a:rPr sz="1500" b="1" i="0">
+                <a:solidFill>
+                  <a:srgbClr val="F97316"/>
+                </a:solidFill>
+                <a:latin typeface="Montserrat"/>
+              </a:rPr>
+              <a:t>▪  </a:t>
+            </a:r>
+            <a:r>
+              <a:rPr sz="1500" b="0" i="0">
                 <a:solidFill>
                   <a:srgbClr val="F1F5F9"/>
                 </a:solidFill>
                 <a:latin typeface="Montserrat"/>
               </a:rPr>
-              <a:t>Valor do mês = resultado da Q2 · cores = REGRAS do indicador (ex.: Preventiva ≥95 verde/≥90 amarelo)</a:t>
-            </a:r>
-          </a:p>
-          <a:p>
-            <a:pPr>
-              <a:spcAft>
-                <a:spcPts val="400"/>
-              </a:spcAft>
-            </a:pPr>
-            <a:r>
-              <a:rPr sz="1350" b="1" i="0">
-                <a:solidFill>
-                  <a:srgbClr val="64748B"/>
-                </a:solidFill>
-                <a:latin typeface="Montserrat"/>
-              </a:rPr>
-              <a:t>      –  </a:t>
-            </a:r>
-            <a:r>
-              <a:rPr sz="1350" b="0" i="0">
-                <a:solidFill>
-                  <a:srgbClr val="F1F5F9"/>
-                </a:solidFill>
-                <a:latin typeface="Montserrat"/>
-              </a:rPr>
-              <a:t>MTTR/MTBF (regra de quartil) coloridos pela pontuação do termômetro · YTD em pill</a:t>
-            </a:r>
-          </a:p>
-          <a:p>
-            <a:pPr>
-              <a:spcAft>
-                <a:spcPts val="400"/>
-              </a:spcAft>
-            </a:pPr>
-            <a:r>
-              <a:rPr sz="1350" b="1" i="0">
-                <a:solidFill>
-                  <a:srgbClr val="64748B"/>
-                </a:solidFill>
-                <a:latin typeface="Montserrat"/>
-              </a:rPr>
-              <a:t>      –  </a:t>
-            </a:r>
-            <a:r>
-              <a:rPr sz="1350" b="1" i="0">
-                <a:solidFill>
-                  <a:srgbClr val="EAB308"/>
-                </a:solidFill>
-                <a:latin typeface="Montserrat"/>
-              </a:rPr>
-              <a:t>Causa/Ação/Responsável/Prazo = campos livres em localStorage (POR NAVEGADOR — não compartilhado)</a:t>
-            </a:r>
-          </a:p>
-          <a:p>
-            <a:pPr>
-              <a:spcAft>
-                <a:spcPts val="700"/>
-              </a:spcAft>
-            </a:pPr>
-            <a:r>
-              <a:rPr sz="1500" b="1" i="0">
-                <a:solidFill>
-                  <a:srgbClr val="F97316"/>
-                </a:solidFill>
-                <a:latin typeface="Montserrat"/>
-              </a:rPr>
-              <a:t>▪  </a:t>
-            </a:r>
-            <a:r>
-              <a:rPr sz="1500" b="0" i="0">
-                <a:solidFill>
-                  <a:srgbClr val="F1F5F9"/>
-                </a:solidFill>
-                <a:latin typeface="Montserrat"/>
-              </a:rPr>
-              <a:t>Evolução natural: migrar os campos do MPR p/ Supabase (mesmo modelo do FCA) p/ compartilhar entre máquinas.</a:t>
+              <a:t>Filtros padrão com “só”; vigência abre no mês mais recente; cache localStorage p/ velocidade.</a:t>
             </a:r>
           </a:p>
         </p:txBody>
@@ -4309,6 +4380,471 @@
                 </a:solidFill>
                 <a:latin typeface="Montserrat"/>
               </a:rPr>
+              <a:t>Termômetro e MPR</a:t>
+            </a:r>
+          </a:p>
+        </p:txBody>
+      </p:sp>
+      <p:sp>
+        <p:nvSpPr>
+          <p:cNvPr id="5" name="TextBox 4"/>
+          <p:cNvSpPr txBox="1"/>
+          <p:nvPr/>
+        </p:nvSpPr>
+        <p:spPr>
+          <a:xfrm>
+            <a:off x="548640" y="1417320"/>
+            <a:ext cx="11064240" cy="5120640"/>
+          </a:xfrm>
+          <a:prstGeom prst="rect">
+            <a:avLst/>
+          </a:prstGeom>
+          <a:noFill/>
+        </p:spPr>
+        <p:txBody>
+          <a:bodyPr wrap="square">
+            <a:spAutoFit/>
+          </a:bodyPr>
+          <a:lstStyle/>
+          <a:p>
+            <a:pPr>
+              <a:spcAft>
+                <a:spcPts val="700"/>
+              </a:spcAft>
+            </a:pPr>
+            <a:r>
+              <a:rPr sz="1500" b="1" i="0">
+                <a:solidFill>
+                  <a:srgbClr val="F97316"/>
+                </a:solidFill>
+                <a:latin typeface="Montserrat"/>
+              </a:rPr>
+              <a:t>▪  </a:t>
+            </a:r>
+            <a:r>
+              <a:rPr sz="1500" b="1" i="0">
+                <a:solidFill>
+                  <a:srgbClr val="F97316"/>
+                </a:solidFill>
+                <a:latin typeface="Montserrat"/>
+              </a:rPr>
+              <a:t>Termômetro (termometro/): pontuação de conformidade por unidade/tier.</a:t>
+            </a:r>
+          </a:p>
+          <a:p>
+            <a:pPr>
+              <a:spcAft>
+                <a:spcPts val="400"/>
+              </a:spcAft>
+            </a:pPr>
+            <a:r>
+              <a:rPr sz="1350" b="1" i="0">
+                <a:solidFill>
+                  <a:srgbClr val="64748B"/>
+                </a:solidFill>
+                <a:latin typeface="Montserrat"/>
+              </a:rPr>
+              <a:t>      –  </a:t>
+            </a:r>
+            <a:r>
+              <a:rPr sz="1350" b="0" i="0">
+                <a:solidFill>
+                  <a:srgbClr val="F1F5F9"/>
+                </a:solidFill>
+                <a:latin typeface="Montserrat"/>
+              </a:rPr>
+              <a:t>Fonte: planilha do termômetro — abas = tiers (Transportes T1/T2, WH T1/T2) + aba Regras</a:t>
+            </a:r>
+          </a:p>
+          <a:p>
+            <a:pPr>
+              <a:spcAft>
+                <a:spcPts val="400"/>
+              </a:spcAft>
+            </a:pPr>
+            <a:r>
+              <a:rPr sz="1350" b="1" i="0">
+                <a:solidFill>
+                  <a:srgbClr val="64748B"/>
+                </a:solidFill>
+                <a:latin typeface="Montserrat"/>
+              </a:rPr>
+              <a:t>      –  </a:t>
+            </a:r>
+            <a:r>
+              <a:rPr sz="1350" b="0" i="0">
+                <a:solidFill>
+                  <a:srgbClr val="F1F5F9"/>
+                </a:solidFill>
+                <a:latin typeface="Montserrat"/>
+              </a:rPr>
+              <a:t>Vigência quinzenal (M_Q); FILTRO é por mês e a Q2 REGE (fallback Q1 se o mês não fechou)</a:t>
+            </a:r>
+          </a:p>
+          <a:p>
+            <a:pPr>
+              <a:spcAft>
+                <a:spcPts val="400"/>
+              </a:spcAft>
+            </a:pPr>
+            <a:r>
+              <a:rPr sz="1350" b="1" i="0">
+                <a:solidFill>
+                  <a:srgbClr val="64748B"/>
+                </a:solidFill>
+                <a:latin typeface="Montserrat"/>
+              </a:rPr>
+              <a:t>      –  </a:t>
+            </a:r>
+            <a:r>
+              <a:rPr sz="1350" b="0" i="0">
+                <a:solidFill>
+                  <a:srgbClr val="F1F5F9"/>
+                </a:solidFill>
+                <a:latin typeface="Montserrat"/>
+              </a:rPr>
+              <a:t>Gráfico temporal mostra as 2 quinzenas — Q1 com preenchimento hachurado</a:t>
+            </a:r>
+          </a:p>
+          <a:p>
+            <a:pPr>
+              <a:spcAft>
+                <a:spcPts val="700"/>
+              </a:spcAft>
+            </a:pPr>
+            <a:r>
+              <a:rPr sz="1500" b="1" i="0">
+                <a:solidFill>
+                  <a:srgbClr val="F97316"/>
+                </a:solidFill>
+                <a:latin typeface="Montserrat"/>
+              </a:rPr>
+              <a:t>▪  </a:t>
+            </a:r>
+            <a:r>
+              <a:rPr sz="1500" b="1" i="0">
+                <a:solidFill>
+                  <a:srgbClr val="F97316"/>
+                </a:solidFill>
+                <a:latin typeface="Montserrat"/>
+              </a:rPr>
+              <a:t>MPR (mpr/): Monthly Performance Review — matriz indicador × GEO/unidade.</a:t>
+            </a:r>
+          </a:p>
+          <a:p>
+            <a:pPr>
+              <a:spcAft>
+                <a:spcPts val="400"/>
+              </a:spcAft>
+            </a:pPr>
+            <a:r>
+              <a:rPr sz="1350" b="1" i="0">
+                <a:solidFill>
+                  <a:srgbClr val="64748B"/>
+                </a:solidFill>
+                <a:latin typeface="Montserrat"/>
+              </a:rPr>
+              <a:t>      –  </a:t>
+            </a:r>
+            <a:r>
+              <a:rPr sz="1350" b="0" i="0">
+                <a:solidFill>
+                  <a:srgbClr val="F1F5F9"/>
+                </a:solidFill>
+                <a:latin typeface="Montserrat"/>
+              </a:rPr>
+              <a:t>GEO agrupa unidades (expande no “+”) · linhas 2025 (vazio) e 2026 · coluna Plan = meta da regra</a:t>
+            </a:r>
+          </a:p>
+          <a:p>
+            <a:pPr>
+              <a:spcAft>
+                <a:spcPts val="400"/>
+              </a:spcAft>
+            </a:pPr>
+            <a:r>
+              <a:rPr sz="1350" b="1" i="0">
+                <a:solidFill>
+                  <a:srgbClr val="64748B"/>
+                </a:solidFill>
+                <a:latin typeface="Montserrat"/>
+              </a:rPr>
+              <a:t>      –  </a:t>
+            </a:r>
+            <a:r>
+              <a:rPr sz="1350" b="0" i="0">
+                <a:solidFill>
+                  <a:srgbClr val="F1F5F9"/>
+                </a:solidFill>
+                <a:latin typeface="Montserrat"/>
+              </a:rPr>
+              <a:t>Valor do mês = resultado da Q2 · cores = REGRAS do indicador (ex.: Preventiva ≥95 verde/≥90 amarelo)</a:t>
+            </a:r>
+          </a:p>
+          <a:p>
+            <a:pPr>
+              <a:spcAft>
+                <a:spcPts val="400"/>
+              </a:spcAft>
+            </a:pPr>
+            <a:r>
+              <a:rPr sz="1350" b="1" i="0">
+                <a:solidFill>
+                  <a:srgbClr val="64748B"/>
+                </a:solidFill>
+                <a:latin typeface="Montserrat"/>
+              </a:rPr>
+              <a:t>      –  </a:t>
+            </a:r>
+            <a:r>
+              <a:rPr sz="1350" b="0" i="0">
+                <a:solidFill>
+                  <a:srgbClr val="F1F5F9"/>
+                </a:solidFill>
+                <a:latin typeface="Montserrat"/>
+              </a:rPr>
+              <a:t>MTTR/MTBF (regra de quartil) coloridos pela pontuação do termômetro · YTD em pill</a:t>
+            </a:r>
+          </a:p>
+          <a:p>
+            <a:pPr>
+              <a:spcAft>
+                <a:spcPts val="400"/>
+              </a:spcAft>
+            </a:pPr>
+            <a:r>
+              <a:rPr sz="1350" b="1" i="0">
+                <a:solidFill>
+                  <a:srgbClr val="64748B"/>
+                </a:solidFill>
+                <a:latin typeface="Montserrat"/>
+              </a:rPr>
+              <a:t>      –  </a:t>
+            </a:r>
+            <a:r>
+              <a:rPr sz="1350" b="1" i="0">
+                <a:solidFill>
+                  <a:srgbClr val="EAB308"/>
+                </a:solidFill>
+                <a:latin typeface="Montserrat"/>
+              </a:rPr>
+              <a:t>Causa/Ação/Responsável/Prazo = campos livres em localStorage (POR NAVEGADOR — não compartilhado)</a:t>
+            </a:r>
+          </a:p>
+          <a:p>
+            <a:pPr>
+              <a:spcAft>
+                <a:spcPts val="700"/>
+              </a:spcAft>
+            </a:pPr>
+            <a:r>
+              <a:rPr sz="1500" b="1" i="0">
+                <a:solidFill>
+                  <a:srgbClr val="F97316"/>
+                </a:solidFill>
+                <a:latin typeface="Montserrat"/>
+              </a:rPr>
+              <a:t>▪  </a:t>
+            </a:r>
+            <a:r>
+              <a:rPr sz="1500" b="0" i="0">
+                <a:solidFill>
+                  <a:srgbClr val="F1F5F9"/>
+                </a:solidFill>
+                <a:latin typeface="Montserrat"/>
+              </a:rPr>
+              <a:t>Evolução natural: migrar os campos do MPR p/ Supabase (mesmo modelo do FCA) p/ compartilhar entre máquinas.</a:t>
+            </a:r>
+          </a:p>
+        </p:txBody>
+      </p:sp>
+      <p:sp>
+        <p:nvSpPr>
+          <p:cNvPr id="6" name="TextBox 5"/>
+          <p:cNvSpPr txBox="1"/>
+          <p:nvPr/>
+        </p:nvSpPr>
+        <p:spPr>
+          <a:xfrm>
+            <a:off x="548640" y="6473952"/>
+            <a:ext cx="11064240" cy="320040"/>
+          </a:xfrm>
+          <a:prstGeom prst="rect">
+            <a:avLst/>
+          </a:prstGeom>
+          <a:noFill/>
+        </p:spPr>
+        <p:txBody>
+          <a:bodyPr wrap="square">
+            <a:spAutoFit/>
+          </a:bodyPr>
+          <a:lstStyle/>
+          <a:p>
+            <a:pPr algn="r"/>
+            <a:r>
+              <a:rPr sz="900" b="0" i="0">
+                <a:solidFill>
+                  <a:srgbClr val="64748B"/>
+                </a:solidFill>
+                <a:latin typeface="Montserrat"/>
+              </a:rPr>
+              <a:t>Handoff Técnico — TI  ·  12</a:t>
+            </a:r>
+          </a:p>
+        </p:txBody>
+      </p:sp>
+    </p:spTree>
+  </p:cSld>
+  <p:clrMapOvr>
+    <a:masterClrMapping/>
+  </p:clrMapOvr>
+</p:sld>
+</file>
+
+<file path=ppt/slides/slide13.xml><?xml version="1.0" encoding="utf-8"?>
+<p:sld xmlns:a="http://schemas.openxmlformats.org/drawingml/2006/main" xmlns:p="http://schemas.openxmlformats.org/presentationml/2006/main" xmlns:r="http://schemas.openxmlformats.org/officeDocument/2006/relationships">
+  <p:cSld>
+    <p:bg>
+      <p:bgPr>
+        <a:solidFill>
+          <a:srgbClr val="0C1017"/>
+        </a:solidFill>
+        <a:effectLst/>
+      </p:bgPr>
+    </p:bg>
+    <p:spTree>
+      <p:nvGrpSpPr>
+        <p:cNvPr id="1" name=""/>
+        <p:cNvGrpSpPr/>
+        <p:nvPr/>
+      </p:nvGrpSpPr>
+      <p:grpSpPr/>
+      <p:sp>
+        <p:nvSpPr>
+          <p:cNvPr id="2" name="Rectangle 1"/>
+          <p:cNvSpPr/>
+          <p:nvPr/>
+        </p:nvSpPr>
+        <p:spPr>
+          <a:xfrm>
+            <a:off x="0" y="0"/>
+            <a:ext cx="12191695" cy="1170432"/>
+          </a:xfrm>
+          <a:prstGeom prst="rect">
+            <a:avLst/>
+          </a:prstGeom>
+          <a:solidFill>
+            <a:srgbClr val="141B26"/>
+          </a:solidFill>
+          <a:ln>
+            <a:noFill/>
+          </a:ln>
+        </p:spPr>
+        <p:style>
+          <a:lnRef idx="1">
+            <a:schemeClr val="accent1"/>
+          </a:lnRef>
+          <a:fillRef idx="3">
+            <a:schemeClr val="accent1"/>
+          </a:fillRef>
+          <a:effectRef idx="2">
+            <a:schemeClr val="accent1"/>
+          </a:effectRef>
+          <a:fontRef idx="minor">
+            <a:schemeClr val="lt1"/>
+          </a:fontRef>
+        </p:style>
+        <p:txBody>
+          <a:bodyPr rtlCol="0" anchor="ctr"/>
+          <a:lstStyle/>
+          <a:p>
+            <a:pPr algn="ctr"/>
+          </a:p>
+        </p:txBody>
+      </p:sp>
+      <p:sp>
+        <p:nvSpPr>
+          <p:cNvPr id="3" name="Rectangle 2"/>
+          <p:cNvSpPr/>
+          <p:nvPr/>
+        </p:nvSpPr>
+        <p:spPr>
+          <a:xfrm>
+            <a:off x="0" y="1170432"/>
+            <a:ext cx="12191695" cy="27940"/>
+          </a:xfrm>
+          <a:prstGeom prst="rect">
+            <a:avLst/>
+          </a:prstGeom>
+          <a:solidFill>
+            <a:srgbClr val="F97316"/>
+          </a:solidFill>
+          <a:ln>
+            <a:noFill/>
+          </a:ln>
+        </p:spPr>
+        <p:style>
+          <a:lnRef idx="1">
+            <a:schemeClr val="accent1"/>
+          </a:lnRef>
+          <a:fillRef idx="3">
+            <a:schemeClr val="accent1"/>
+          </a:fillRef>
+          <a:effectRef idx="2">
+            <a:schemeClr val="accent1"/>
+          </a:effectRef>
+          <a:fontRef idx="minor">
+            <a:schemeClr val="lt1"/>
+          </a:fontRef>
+        </p:style>
+        <p:txBody>
+          <a:bodyPr rtlCol="0" anchor="ctr"/>
+          <a:lstStyle/>
+          <a:p>
+            <a:pPr algn="ctr"/>
+          </a:p>
+        </p:txBody>
+      </p:sp>
+      <p:sp>
+        <p:nvSpPr>
+          <p:cNvPr id="4" name="TextBox 3"/>
+          <p:cNvSpPr txBox="1"/>
+          <p:nvPr/>
+        </p:nvSpPr>
+        <p:spPr>
+          <a:xfrm>
+            <a:off x="548640" y="109728"/>
+            <a:ext cx="11064240" cy="1005840"/>
+          </a:xfrm>
+          <a:prstGeom prst="rect">
+            <a:avLst/>
+          </a:prstGeom>
+          <a:noFill/>
+        </p:spPr>
+        <p:txBody>
+          <a:bodyPr wrap="square">
+            <a:spAutoFit/>
+          </a:bodyPr>
+          <a:lstStyle/>
+          <a:p>
+            <a:r>
+              <a:rPr sz="1000" b="1" i="0">
+                <a:solidFill>
+                  <a:srgbClr val="64748B"/>
+                </a:solidFill>
+                <a:latin typeface="Montserrat"/>
+              </a:rPr>
+              <a:t>GESTÃO EM MOVIMENTO · BI FROTA</a:t>
+            </a:r>
+          </a:p>
+          <a:p>
+            <a:r>
+              <a:rPr sz="2600" b="1" i="0">
+                <a:solidFill>
+                  <a:srgbClr val="F97316"/>
+                </a:solidFill>
+                <a:latin typeface="Montserrat"/>
+              </a:rPr>
               <a:t>Design system (resumo — íntegra no CLAUDE.md)</a:t>
             </a:r>
           </a:p>
@@ -4841,7 +5377,7 @@
                 </a:solidFill>
                 <a:latin typeface="Montserrat"/>
               </a:rPr>
-              <a:t>Handoff Técnico — TI  ·  12</a:t>
+              <a:t>Handoff Técnico — TI  ·  13</a:t>
             </a:r>
           </a:p>
         </p:txBody>
@@ -4854,7 +5390,7 @@
 </p:sld>
 </file>
 
-<file path=ppt/slides/slide13.xml><?xml version="1.0" encoding="utf-8"?>
+<file path=ppt/slides/slide14.xml><?xml version="1.0" encoding="utf-8"?>
 <p:sld xmlns:a="http://schemas.openxmlformats.org/drawingml/2006/main" xmlns:p="http://schemas.openxmlformats.org/presentationml/2006/main" xmlns:r="http://schemas.openxmlformats.org/officeDocument/2006/relationships">
   <p:cSld>
     <p:bg>
@@ -5381,446 +5917,6 @@
                 </a:solidFill>
                 <a:latin typeface="Montserrat"/>
               </a:rPr>
-              <a:t>Handoff Técnico — TI  ·  13</a:t>
-            </a:r>
-          </a:p>
-        </p:txBody>
-      </p:sp>
-    </p:spTree>
-  </p:cSld>
-  <p:clrMapOvr>
-    <a:masterClrMapping/>
-  </p:clrMapOvr>
-</p:sld>
-</file>
-
-<file path=ppt/slides/slide14.xml><?xml version="1.0" encoding="utf-8"?>
-<p:sld xmlns:a="http://schemas.openxmlformats.org/drawingml/2006/main" xmlns:p="http://schemas.openxmlformats.org/presentationml/2006/main" xmlns:r="http://schemas.openxmlformats.org/officeDocument/2006/relationships">
-  <p:cSld>
-    <p:bg>
-      <p:bgPr>
-        <a:solidFill>
-          <a:srgbClr val="0C1017"/>
-        </a:solidFill>
-        <a:effectLst/>
-      </p:bgPr>
-    </p:bg>
-    <p:spTree>
-      <p:nvGrpSpPr>
-        <p:cNvPr id="1" name=""/>
-        <p:cNvGrpSpPr/>
-        <p:nvPr/>
-      </p:nvGrpSpPr>
-      <p:grpSpPr/>
-      <p:sp>
-        <p:nvSpPr>
-          <p:cNvPr id="2" name="Rectangle 1"/>
-          <p:cNvSpPr/>
-          <p:nvPr/>
-        </p:nvSpPr>
-        <p:spPr>
-          <a:xfrm>
-            <a:off x="0" y="0"/>
-            <a:ext cx="12191695" cy="1170432"/>
-          </a:xfrm>
-          <a:prstGeom prst="rect">
-            <a:avLst/>
-          </a:prstGeom>
-          <a:solidFill>
-            <a:srgbClr val="141B26"/>
-          </a:solidFill>
-          <a:ln>
-            <a:noFill/>
-          </a:ln>
-        </p:spPr>
-        <p:style>
-          <a:lnRef idx="1">
-            <a:schemeClr val="accent1"/>
-          </a:lnRef>
-          <a:fillRef idx="3">
-            <a:schemeClr val="accent1"/>
-          </a:fillRef>
-          <a:effectRef idx="2">
-            <a:schemeClr val="accent1"/>
-          </a:effectRef>
-          <a:fontRef idx="minor">
-            <a:schemeClr val="lt1"/>
-          </a:fontRef>
-        </p:style>
-        <p:txBody>
-          <a:bodyPr rtlCol="0" anchor="ctr"/>
-          <a:lstStyle/>
-          <a:p>
-            <a:pPr algn="ctr"/>
-          </a:p>
-        </p:txBody>
-      </p:sp>
-      <p:sp>
-        <p:nvSpPr>
-          <p:cNvPr id="3" name="Rectangle 2"/>
-          <p:cNvSpPr/>
-          <p:nvPr/>
-        </p:nvSpPr>
-        <p:spPr>
-          <a:xfrm>
-            <a:off x="0" y="1170432"/>
-            <a:ext cx="12191695" cy="27940"/>
-          </a:xfrm>
-          <a:prstGeom prst="rect">
-            <a:avLst/>
-          </a:prstGeom>
-          <a:solidFill>
-            <a:srgbClr val="F97316"/>
-          </a:solidFill>
-          <a:ln>
-            <a:noFill/>
-          </a:ln>
-        </p:spPr>
-        <p:style>
-          <a:lnRef idx="1">
-            <a:schemeClr val="accent1"/>
-          </a:lnRef>
-          <a:fillRef idx="3">
-            <a:schemeClr val="accent1"/>
-          </a:fillRef>
-          <a:effectRef idx="2">
-            <a:schemeClr val="accent1"/>
-          </a:effectRef>
-          <a:fontRef idx="minor">
-            <a:schemeClr val="lt1"/>
-          </a:fontRef>
-        </p:style>
-        <p:txBody>
-          <a:bodyPr rtlCol="0" anchor="ctr"/>
-          <a:lstStyle/>
-          <a:p>
-            <a:pPr algn="ctr"/>
-          </a:p>
-        </p:txBody>
-      </p:sp>
-      <p:sp>
-        <p:nvSpPr>
-          <p:cNvPr id="4" name="TextBox 3"/>
-          <p:cNvSpPr txBox="1"/>
-          <p:nvPr/>
-        </p:nvSpPr>
-        <p:spPr>
-          <a:xfrm>
-            <a:off x="548640" y="109728"/>
-            <a:ext cx="11064240" cy="1005840"/>
-          </a:xfrm>
-          <a:prstGeom prst="rect">
-            <a:avLst/>
-          </a:prstGeom>
-          <a:noFill/>
-        </p:spPr>
-        <p:txBody>
-          <a:bodyPr wrap="square">
-            <a:spAutoFit/>
-          </a:bodyPr>
-          <a:lstStyle/>
-          <a:p>
-            <a:r>
-              <a:rPr sz="1000" b="1" i="0">
-                <a:solidFill>
-                  <a:srgbClr val="64748B"/>
-                </a:solidFill>
-                <a:latin typeface="Montserrat"/>
-              </a:rPr>
-              <a:t>GESTÃO EM MOVIMENTO · BI FROTA</a:t>
-            </a:r>
-          </a:p>
-          <a:p>
-            <a:r>
-              <a:rPr sz="2600" b="1" i="0">
-                <a:solidFill>
-                  <a:srgbClr val="F97316"/>
-                </a:solidFill>
-                <a:latin typeface="Montserrat"/>
-              </a:rPr>
-              <a:t>Manutenção — receitas rápidas</a:t>
-            </a:r>
-          </a:p>
-        </p:txBody>
-      </p:sp>
-      <p:sp>
-        <p:nvSpPr>
-          <p:cNvPr id="5" name="TextBox 4"/>
-          <p:cNvSpPr txBox="1"/>
-          <p:nvPr/>
-        </p:nvSpPr>
-        <p:spPr>
-          <a:xfrm>
-            <a:off x="548640" y="1417320"/>
-            <a:ext cx="11064240" cy="5120640"/>
-          </a:xfrm>
-          <a:prstGeom prst="rect">
-            <a:avLst/>
-          </a:prstGeom>
-          <a:noFill/>
-        </p:spPr>
-        <p:txBody>
-          <a:bodyPr wrap="square">
-            <a:spAutoFit/>
-          </a:bodyPr>
-          <a:lstStyle/>
-          <a:p>
-            <a:pPr>
-              <a:spcAft>
-                <a:spcPts val="700"/>
-              </a:spcAft>
-            </a:pPr>
-            <a:r>
-              <a:rPr sz="1500" b="1" i="0">
-                <a:solidFill>
-                  <a:srgbClr val="F97316"/>
-                </a:solidFill>
-                <a:latin typeface="Montserrat"/>
-              </a:rPr>
-              <a:t>▪  </a:t>
-            </a:r>
-            <a:r>
-              <a:rPr sz="1500" b="1" i="0">
-                <a:solidFill>
-                  <a:srgbClr val="F97316"/>
-                </a:solidFill>
-                <a:latin typeface="Montserrat"/>
-              </a:rPr>
-              <a:t>Criar um painel novo:</a:t>
-            </a:r>
-          </a:p>
-          <a:p>
-            <a:pPr>
-              <a:spcAft>
-                <a:spcPts val="400"/>
-              </a:spcAft>
-            </a:pPr>
-            <a:r>
-              <a:rPr sz="1350" b="1" i="0">
-                <a:solidFill>
-                  <a:srgbClr val="64748B"/>
-                </a:solidFill>
-                <a:latin typeface="Montserrat"/>
-              </a:rPr>
-              <a:t>      –  </a:t>
-            </a:r>
-            <a:r>
-              <a:rPr sz="1350" b="0" i="0">
-                <a:solidFill>
-                  <a:srgbClr val="F1F5F9"/>
-                </a:solidFill>
-                <a:latin typeface="Montserrat"/>
-              </a:rPr>
-              <a:t>copiar visao-financeira/index.html (ou _template/) p/ nova pasta · ajustar título/fonte de dados</a:t>
-            </a:r>
-          </a:p>
-          <a:p>
-            <a:pPr>
-              <a:spcAft>
-                <a:spcPts val="400"/>
-              </a:spcAft>
-            </a:pPr>
-            <a:r>
-              <a:rPr sz="1350" b="1" i="0">
-                <a:solidFill>
-                  <a:srgbClr val="64748B"/>
-                </a:solidFill>
-                <a:latin typeface="Montserrat"/>
-              </a:rPr>
-              <a:t>      –  </a:t>
-            </a:r>
-            <a:r>
-              <a:rPr sz="1350" b="0" i="0">
-                <a:solidFill>
-                  <a:srgbClr val="F1F5F9"/>
-                </a:solidFill>
-                <a:latin typeface="Montserrat"/>
-              </a:rPr>
-              <a:t>adicionar o card no hub (index.html raiz, cluster certo) · push em main</a:t>
-            </a:r>
-          </a:p>
-          <a:p>
-            <a:pPr>
-              <a:spcAft>
-                <a:spcPts val="700"/>
-              </a:spcAft>
-            </a:pPr>
-            <a:r>
-              <a:rPr sz="1500" b="1" i="0">
-                <a:solidFill>
-                  <a:srgbClr val="F97316"/>
-                </a:solidFill>
-                <a:latin typeface="Montserrat"/>
-              </a:rPr>
-              <a:t>▪  </a:t>
-            </a:r>
-            <a:r>
-              <a:rPr sz="1500" b="0" i="0">
-                <a:solidFill>
-                  <a:srgbClr val="F1F5F9"/>
-                </a:solidFill>
-                <a:latin typeface="Montserrat"/>
-              </a:rPr>
-              <a:t>Virada de mês (FCA): admin clica Gerar Custos + Gerar RPM. Aditivo — sem risco de duplicar.</a:t>
-            </a:r>
-          </a:p>
-          <a:p>
-            <a:pPr>
-              <a:spcAft>
-                <a:spcPts val="700"/>
-              </a:spcAft>
-            </a:pPr>
-            <a:r>
-              <a:rPr sz="1500" b="1" i="0">
-                <a:solidFill>
-                  <a:srgbClr val="F97316"/>
-                </a:solidFill>
-                <a:latin typeface="Montserrat"/>
-              </a:rPr>
-              <a:t>▪  </a:t>
-            </a:r>
-            <a:r>
-              <a:rPr sz="1500" b="0" i="0">
-                <a:solidFill>
-                  <a:srgbClr val="F1F5F9"/>
-                </a:solidFill>
-                <a:latin typeface="Montserrat"/>
-              </a:rPr>
-              <a:t>Novo usuário: cadastro no hub → admin aprova em Gerenciar Acessos → definir unidade/is_admin.</a:t>
-            </a:r>
-          </a:p>
-          <a:p>
-            <a:pPr>
-              <a:spcAft>
-                <a:spcPts val="700"/>
-              </a:spcAft>
-            </a:pPr>
-            <a:r>
-              <a:rPr sz="1500" b="1" i="0">
-                <a:solidFill>
-                  <a:srgbClr val="F97316"/>
-                </a:solidFill>
-                <a:latin typeface="Montserrat"/>
-              </a:rPr>
-              <a:t>▪  </a:t>
-            </a:r>
-            <a:r>
-              <a:rPr sz="1500" b="0" i="0">
-                <a:solidFill>
-                  <a:srgbClr val="F1F5F9"/>
-                </a:solidFill>
-                <a:latin typeface="Montserrat"/>
-              </a:rPr>
-              <a:t>Nova unidade na RPM: incluir no RPM_UNIT_MAP (fca-preenchimento/index.html) e no DEPARA.</a:t>
-            </a:r>
-          </a:p>
-          <a:p>
-            <a:pPr>
-              <a:spcAft>
-                <a:spcPts val="700"/>
-              </a:spcAft>
-            </a:pPr>
-            <a:r>
-              <a:rPr sz="1500" b="1" i="0">
-                <a:solidFill>
-                  <a:srgbClr val="F97316"/>
-                </a:solidFill>
-                <a:latin typeface="Montserrat"/>
-              </a:rPr>
-              <a:t>▪  </a:t>
-            </a:r>
-            <a:r>
-              <a:rPr sz="1500" b="0" i="0">
-                <a:solidFill>
-                  <a:srgbClr val="F1F5F9"/>
-                </a:solidFill>
-                <a:latin typeface="Montserrat"/>
-              </a:rPr>
-              <a:t>Painel Pneus sem dados: checar execução do workflow “Pneus Loader (Conlog)” na aba Actions.</a:t>
-            </a:r>
-          </a:p>
-          <a:p>
-            <a:pPr>
-              <a:spcAft>
-                <a:spcPts val="700"/>
-              </a:spcAft>
-            </a:pPr>
-            <a:r>
-              <a:rPr sz="1500" b="1" i="0">
-                <a:solidFill>
-                  <a:srgbClr val="F97316"/>
-                </a:solidFill>
-                <a:latin typeface="Montserrat"/>
-              </a:rPr>
-              <a:t>▪  </a:t>
-            </a:r>
-            <a:r>
-              <a:rPr sz="1500" b="0" i="0">
-                <a:solidFill>
-                  <a:srgbClr val="F1F5F9"/>
-                </a:solidFill>
-                <a:latin typeface="Montserrat"/>
-              </a:rPr>
-              <a:t>Site “não atualizou”: conferir se o build do Pages concluiu + Ctrl+Shift+R.</a:t>
-            </a:r>
-          </a:p>
-          <a:p>
-            <a:pPr>
-              <a:spcAft>
-                <a:spcPts val="700"/>
-              </a:spcAft>
-            </a:pPr>
-            <a:r>
-              <a:rPr sz="1500" b="1" i="0">
-                <a:solidFill>
-                  <a:srgbClr val="F97316"/>
-                </a:solidFill>
-                <a:latin typeface="Montserrat"/>
-              </a:rPr>
-              <a:t>▪  </a:t>
-            </a:r>
-            <a:r>
-              <a:rPr sz="1500" b="0" i="0">
-                <a:solidFill>
-                  <a:srgbClr val="F1F5F9"/>
-                </a:solidFill>
-                <a:latin typeface="Montserrat"/>
-              </a:rPr>
-              <a:t>Antes de mexer no visual: ler CLAUDE.md (paleta, componentes, mobile).</a:t>
-            </a:r>
-          </a:p>
-        </p:txBody>
-      </p:sp>
-      <p:sp>
-        <p:nvSpPr>
-          <p:cNvPr id="6" name="TextBox 5"/>
-          <p:cNvSpPr txBox="1"/>
-          <p:nvPr/>
-        </p:nvSpPr>
-        <p:spPr>
-          <a:xfrm>
-            <a:off x="548640" y="6473952"/>
-            <a:ext cx="11064240" cy="320040"/>
-          </a:xfrm>
-          <a:prstGeom prst="rect">
-            <a:avLst/>
-          </a:prstGeom>
-          <a:noFill/>
-        </p:spPr>
-        <p:txBody>
-          <a:bodyPr wrap="square">
-            <a:spAutoFit/>
-          </a:bodyPr>
-          <a:lstStyle/>
-          <a:p>
-            <a:pPr algn="r"/>
-            <a:r>
-              <a:rPr sz="900" b="0" i="0">
-                <a:solidFill>
-                  <a:srgbClr val="64748B"/>
-                </a:solidFill>
-                <a:latin typeface="Montserrat"/>
-              </a:rPr>
               <a:t>Handoff Técnico — TI  ·  14</a:t>
             </a:r>
           </a:p>
@@ -5978,7 +6074,7 @@
                 </a:solidFill>
                 <a:latin typeface="Montserrat"/>
               </a:rPr>
-              <a:t>Links e rotina operacional</a:t>
+              <a:t>Manutenção — receitas rápidas</a:t>
             </a:r>
           </a:p>
         </p:txBody>
@@ -6020,13 +6116,88 @@
               <a:t>▪  </a:t>
             </a:r>
             <a:r>
+              <a:rPr sz="1500" b="1" i="0">
+                <a:solidFill>
+                  <a:srgbClr val="F97316"/>
+                </a:solidFill>
+                <a:latin typeface="Montserrat"/>
+              </a:rPr>
+              <a:t>Criar um painel novo:</a:t>
+            </a:r>
+          </a:p>
+          <a:p>
+            <a:pPr>
+              <a:spcAft>
+                <a:spcPts val="400"/>
+              </a:spcAft>
+            </a:pPr>
+            <a:r>
+              <a:rPr sz="1350" b="1" i="0">
+                <a:solidFill>
+                  <a:srgbClr val="64748B"/>
+                </a:solidFill>
+                <a:latin typeface="Montserrat"/>
+              </a:rPr>
+              <a:t>      –  </a:t>
+            </a:r>
+            <a:r>
+              <a:rPr sz="1350" b="0" i="0">
+                <a:solidFill>
+                  <a:srgbClr val="F1F5F9"/>
+                </a:solidFill>
+                <a:latin typeface="Montserrat"/>
+              </a:rPr>
+              <a:t>copiar visao-financeira/index.html (ou _template/) p/ nova pasta · ajustar título/fonte de dados</a:t>
+            </a:r>
+          </a:p>
+          <a:p>
+            <a:pPr>
+              <a:spcAft>
+                <a:spcPts val="400"/>
+              </a:spcAft>
+            </a:pPr>
+            <a:r>
+              <a:rPr sz="1350" b="1" i="0">
+                <a:solidFill>
+                  <a:srgbClr val="64748B"/>
+                </a:solidFill>
+                <a:latin typeface="Montserrat"/>
+              </a:rPr>
+              <a:t>      –  </a:t>
+            </a:r>
+            <a:r>
+              <a:rPr sz="1350" b="0" i="0">
+                <a:solidFill>
+                  <a:srgbClr val="F1F5F9"/>
+                </a:solidFill>
+                <a:latin typeface="Montserrat"/>
+              </a:rPr>
+              <a:t>adicionar o card no hub (index.html raiz, cluster certo) · push em main</a:t>
+            </a:r>
+          </a:p>
+          <a:p>
+            <a:pPr>
+              <a:spcAft>
+                <a:spcPts val="700"/>
+              </a:spcAft>
+            </a:pPr>
+            <a:r>
+              <a:rPr sz="1500" b="1" i="0">
+                <a:solidFill>
+                  <a:srgbClr val="F97316"/>
+                </a:solidFill>
+                <a:latin typeface="Montserrat"/>
+              </a:rPr>
+              <a:t>▪  </a:t>
+            </a:r>
+            <a:r>
               <a:rPr sz="1500" b="0" i="0">
                 <a:solidFill>
                   <a:srgbClr val="F1F5F9"/>
                 </a:solidFill>
                 <a:latin typeface="Montserrat"/>
               </a:rPr>
-              <a:t>Produção: https://fortesindicadores-byte.github.io/gestao-em-movimento/</a:t>
+              <a:t>Virada de mês (FCA): admin clica Gerar Custos + Gerar RPM. Aditivo — sem risco de duplicar.</a:t>
             </a:r>
           </a:p>
           <a:p>
@@ -6051,7 +6222,7 @@
                 </a:solidFill>
                 <a:latin typeface="Montserrat"/>
               </a:rPr>
-              <a:t>Repositório: github.com/fortesindicadores-byte/gestao-em-movimento</a:t>
+              <a:t>Novo usuário: cadastro no hub → admin aprova em Gerenciar Acessos → definir unidade/is_admin.</a:t>
             </a:r>
           </a:p>
           <a:p>
@@ -6076,7 +6247,7 @@
                 </a:solidFill>
                 <a:latin typeface="Montserrat"/>
               </a:rPr>
-              <a:t>Docs no repo: DOCUMENTACAO-TI.md (completo) · CLAUDE.md · PAINEIS.md · HANDOFF.md</a:t>
+              <a:t>Nova unidade na RPM: incluir no RPM_UNIT_MAP (fca-preenchimento/index.html) e no DEPARA.</a:t>
             </a:r>
           </a:p>
           <a:p>
@@ -6101,7 +6272,7 @@
                 </a:solidFill>
                 <a:latin typeface="Montserrat"/>
               </a:rPr>
-              <a:t>Supabase (auth/FCA): lozwipoeacpvplgkrxkq.supabase.co · Conlog (Pneus): ewbzeqsneeylwkxtcpme.supabase.co</a:t>
+              <a:t>Painel Pneus sem dados: checar execução do workflow “Pneus Loader (Conlog)” na aba Actions.</a:t>
             </a:r>
           </a:p>
           <a:p>
@@ -6120,138 +6291,38 @@
               <a:t>▪  </a:t>
             </a:r>
             <a:r>
+              <a:rPr sz="1500" b="0" i="0">
+                <a:solidFill>
+                  <a:srgbClr val="F1F5F9"/>
+                </a:solidFill>
+                <a:latin typeface="Montserrat"/>
+              </a:rPr>
+              <a:t>Site “não atualizou”: conferir se o build do Pages concluiu + Ctrl+Shift+R.</a:t>
+            </a:r>
+          </a:p>
+          <a:p>
+            <a:pPr>
+              <a:spcAft>
+                <a:spcPts val="700"/>
+              </a:spcAft>
+            </a:pPr>
+            <a:r>
               <a:rPr sz="1500" b="1" i="0">
                 <a:solidFill>
                   <a:srgbClr val="F97316"/>
                 </a:solidFill>
                 <a:latin typeface="Montserrat"/>
               </a:rPr>
-              <a:t>Rotina mensal em 5 passos:</a:t>
-            </a:r>
-          </a:p>
-          <a:p>
-            <a:pPr>
-              <a:spcAft>
-                <a:spcPts val="400"/>
-              </a:spcAft>
-            </a:pPr>
-            <a:r>
-              <a:rPr sz="1350" b="1" i="0">
-                <a:solidFill>
-                  <a:srgbClr val="64748B"/>
-                </a:solidFill>
-                <a:latin typeface="Montserrat"/>
-              </a:rPr>
-              <a:t>      –  </a:t>
-            </a:r>
-            <a:r>
-              <a:rPr sz="1350" b="0" i="0">
+              <a:t>▪  </a:t>
+            </a:r>
+            <a:r>
+              <a:rPr sz="1500" b="0" i="0">
                 <a:solidFill>
                   <a:srgbClr val="F1F5F9"/>
                 </a:solidFill>
                 <a:latin typeface="Montserrat"/>
               </a:rPr>
-              <a:t>1. Mês fecha → planilhas de origem atualizadas (DRE, Base RPM, termômetro)</a:t>
-            </a:r>
-          </a:p>
-          <a:p>
-            <a:pPr>
-              <a:spcAft>
-                <a:spcPts val="400"/>
-              </a:spcAft>
-            </a:pPr>
-            <a:r>
-              <a:rPr sz="1350" b="1" i="0">
-                <a:solidFill>
-                  <a:srgbClr val="64748B"/>
-                </a:solidFill>
-                <a:latin typeface="Montserrat"/>
-              </a:rPr>
-              <a:t>      –  </a:t>
-            </a:r>
-            <a:r>
-              <a:rPr sz="1350" b="0" i="0">
-                <a:solidFill>
-                  <a:srgbClr val="F1F5F9"/>
-                </a:solidFill>
-                <a:latin typeface="Montserrat"/>
-              </a:rPr>
-              <a:t>2. Admin: FCA · Admin → Gerar Custos + Gerar RPM</a:t>
-            </a:r>
-          </a:p>
-          <a:p>
-            <a:pPr>
-              <a:spcAft>
-                <a:spcPts val="400"/>
-              </a:spcAft>
-            </a:pPr>
-            <a:r>
-              <a:rPr sz="1350" b="1" i="0">
-                <a:solidFill>
-                  <a:srgbClr val="64748B"/>
-                </a:solidFill>
-                <a:latin typeface="Montserrat"/>
-              </a:rPr>
-              <a:t>      –  </a:t>
-            </a:r>
-            <a:r>
-              <a:rPr sz="1350" b="0" i="0">
-                <a:solidFill>
-                  <a:srgbClr val="F1F5F9"/>
-                </a:solidFill>
-                <a:latin typeface="Montserrat"/>
-              </a:rPr>
-              <a:t>3. Unidades: FCA · Preenchimento → tratar desvios → SALVAR</a:t>
-            </a:r>
-          </a:p>
-          <a:p>
-            <a:pPr>
-              <a:spcAft>
-                <a:spcPts val="400"/>
-              </a:spcAft>
-            </a:pPr>
-            <a:r>
-              <a:rPr sz="1350" b="1" i="0">
-                <a:solidFill>
-                  <a:srgbClr val="64748B"/>
-                </a:solidFill>
-                <a:latin typeface="Montserrat"/>
-              </a:rPr>
-              <a:t>      –  </a:t>
-            </a:r>
-            <a:r>
-              <a:rPr sz="1350" b="0" i="0">
-                <a:solidFill>
-                  <a:srgbClr val="F1F5F9"/>
-                </a:solidFill>
-                <a:latin typeface="Montserrat"/>
-              </a:rPr>
-              <a:t>4. Gestão: FCA consolidado · Aderência · Termômetro · MPR</a:t>
-            </a:r>
-          </a:p>
-          <a:p>
-            <a:pPr>
-              <a:spcAft>
-                <a:spcPts val="400"/>
-              </a:spcAft>
-            </a:pPr>
-            <a:r>
-              <a:rPr sz="1350" b="1" i="0">
-                <a:solidFill>
-                  <a:srgbClr val="64748B"/>
-                </a:solidFill>
-                <a:latin typeface="Montserrat"/>
-              </a:rPr>
-              <a:t>      –  </a:t>
-            </a:r>
-            <a:r>
-              <a:rPr sz="1350" b="0" i="0">
-                <a:solidFill>
-                  <a:srgbClr val="F1F5F9"/>
-                </a:solidFill>
-                <a:latin typeface="Montserrat"/>
-              </a:rPr>
-              <a:t>5. Pneus atualiza sozinho (Actions 2×/dia); demais painéis leem as fontes ao abrir</a:t>
+              <a:t>Antes de mexer no visual: ler CLAUDE.md (paleta, componentes, mobile).</a:t>
             </a:r>
           </a:p>
         </p:txBody>
@@ -6287,6 +6358,471 @@
                 <a:latin typeface="Montserrat"/>
               </a:rPr>
               <a:t>Handoff Técnico — TI  ·  15</a:t>
+            </a:r>
+          </a:p>
+        </p:txBody>
+      </p:sp>
+    </p:spTree>
+  </p:cSld>
+  <p:clrMapOvr>
+    <a:masterClrMapping/>
+  </p:clrMapOvr>
+</p:sld>
+</file>
+
+<file path=ppt/slides/slide16.xml><?xml version="1.0" encoding="utf-8"?>
+<p:sld xmlns:a="http://schemas.openxmlformats.org/drawingml/2006/main" xmlns:p="http://schemas.openxmlformats.org/presentationml/2006/main" xmlns:r="http://schemas.openxmlformats.org/officeDocument/2006/relationships">
+  <p:cSld>
+    <p:bg>
+      <p:bgPr>
+        <a:solidFill>
+          <a:srgbClr val="0C1017"/>
+        </a:solidFill>
+        <a:effectLst/>
+      </p:bgPr>
+    </p:bg>
+    <p:spTree>
+      <p:nvGrpSpPr>
+        <p:cNvPr id="1" name=""/>
+        <p:cNvGrpSpPr/>
+        <p:nvPr/>
+      </p:nvGrpSpPr>
+      <p:grpSpPr/>
+      <p:sp>
+        <p:nvSpPr>
+          <p:cNvPr id="2" name="Rectangle 1"/>
+          <p:cNvSpPr/>
+          <p:nvPr/>
+        </p:nvSpPr>
+        <p:spPr>
+          <a:xfrm>
+            <a:off x="0" y="0"/>
+            <a:ext cx="12191695" cy="1170432"/>
+          </a:xfrm>
+          <a:prstGeom prst="rect">
+            <a:avLst/>
+          </a:prstGeom>
+          <a:solidFill>
+            <a:srgbClr val="141B26"/>
+          </a:solidFill>
+          <a:ln>
+            <a:noFill/>
+          </a:ln>
+        </p:spPr>
+        <p:style>
+          <a:lnRef idx="1">
+            <a:schemeClr val="accent1"/>
+          </a:lnRef>
+          <a:fillRef idx="3">
+            <a:schemeClr val="accent1"/>
+          </a:fillRef>
+          <a:effectRef idx="2">
+            <a:schemeClr val="accent1"/>
+          </a:effectRef>
+          <a:fontRef idx="minor">
+            <a:schemeClr val="lt1"/>
+          </a:fontRef>
+        </p:style>
+        <p:txBody>
+          <a:bodyPr rtlCol="0" anchor="ctr"/>
+          <a:lstStyle/>
+          <a:p>
+            <a:pPr algn="ctr"/>
+          </a:p>
+        </p:txBody>
+      </p:sp>
+      <p:sp>
+        <p:nvSpPr>
+          <p:cNvPr id="3" name="Rectangle 2"/>
+          <p:cNvSpPr/>
+          <p:nvPr/>
+        </p:nvSpPr>
+        <p:spPr>
+          <a:xfrm>
+            <a:off x="0" y="1170432"/>
+            <a:ext cx="12191695" cy="27940"/>
+          </a:xfrm>
+          <a:prstGeom prst="rect">
+            <a:avLst/>
+          </a:prstGeom>
+          <a:solidFill>
+            <a:srgbClr val="F97316"/>
+          </a:solidFill>
+          <a:ln>
+            <a:noFill/>
+          </a:ln>
+        </p:spPr>
+        <p:style>
+          <a:lnRef idx="1">
+            <a:schemeClr val="accent1"/>
+          </a:lnRef>
+          <a:fillRef idx="3">
+            <a:schemeClr val="accent1"/>
+          </a:fillRef>
+          <a:effectRef idx="2">
+            <a:schemeClr val="accent1"/>
+          </a:effectRef>
+          <a:fontRef idx="minor">
+            <a:schemeClr val="lt1"/>
+          </a:fontRef>
+        </p:style>
+        <p:txBody>
+          <a:bodyPr rtlCol="0" anchor="ctr"/>
+          <a:lstStyle/>
+          <a:p>
+            <a:pPr algn="ctr"/>
+          </a:p>
+        </p:txBody>
+      </p:sp>
+      <p:sp>
+        <p:nvSpPr>
+          <p:cNvPr id="4" name="TextBox 3"/>
+          <p:cNvSpPr txBox="1"/>
+          <p:nvPr/>
+        </p:nvSpPr>
+        <p:spPr>
+          <a:xfrm>
+            <a:off x="548640" y="109728"/>
+            <a:ext cx="11064240" cy="1005840"/>
+          </a:xfrm>
+          <a:prstGeom prst="rect">
+            <a:avLst/>
+          </a:prstGeom>
+          <a:noFill/>
+        </p:spPr>
+        <p:txBody>
+          <a:bodyPr wrap="square">
+            <a:spAutoFit/>
+          </a:bodyPr>
+          <a:lstStyle/>
+          <a:p>
+            <a:r>
+              <a:rPr sz="1000" b="1" i="0">
+                <a:solidFill>
+                  <a:srgbClr val="64748B"/>
+                </a:solidFill>
+                <a:latin typeface="Montserrat"/>
+              </a:rPr>
+              <a:t>GESTÃO EM MOVIMENTO · BI FROTA</a:t>
+            </a:r>
+          </a:p>
+          <a:p>
+            <a:r>
+              <a:rPr sz="2600" b="1" i="0">
+                <a:solidFill>
+                  <a:srgbClr val="F97316"/>
+                </a:solidFill>
+                <a:latin typeface="Montserrat"/>
+              </a:rPr>
+              <a:t>Links e rotina operacional</a:t>
+            </a:r>
+          </a:p>
+        </p:txBody>
+      </p:sp>
+      <p:sp>
+        <p:nvSpPr>
+          <p:cNvPr id="5" name="TextBox 4"/>
+          <p:cNvSpPr txBox="1"/>
+          <p:nvPr/>
+        </p:nvSpPr>
+        <p:spPr>
+          <a:xfrm>
+            <a:off x="548640" y="1417320"/>
+            <a:ext cx="11064240" cy="5120640"/>
+          </a:xfrm>
+          <a:prstGeom prst="rect">
+            <a:avLst/>
+          </a:prstGeom>
+          <a:noFill/>
+        </p:spPr>
+        <p:txBody>
+          <a:bodyPr wrap="square">
+            <a:spAutoFit/>
+          </a:bodyPr>
+          <a:lstStyle/>
+          <a:p>
+            <a:pPr>
+              <a:spcAft>
+                <a:spcPts val="700"/>
+              </a:spcAft>
+            </a:pPr>
+            <a:r>
+              <a:rPr sz="1500" b="1" i="0">
+                <a:solidFill>
+                  <a:srgbClr val="F97316"/>
+                </a:solidFill>
+                <a:latin typeface="Montserrat"/>
+              </a:rPr>
+              <a:t>▪  </a:t>
+            </a:r>
+            <a:r>
+              <a:rPr sz="1500" b="0" i="0">
+                <a:solidFill>
+                  <a:srgbClr val="F1F5F9"/>
+                </a:solidFill>
+                <a:latin typeface="Montserrat"/>
+              </a:rPr>
+              <a:t>Produção: https://fortesindicadores-byte.github.io/gestao-em-movimento/</a:t>
+            </a:r>
+          </a:p>
+          <a:p>
+            <a:pPr>
+              <a:spcAft>
+                <a:spcPts val="700"/>
+              </a:spcAft>
+            </a:pPr>
+            <a:r>
+              <a:rPr sz="1500" b="1" i="0">
+                <a:solidFill>
+                  <a:srgbClr val="F97316"/>
+                </a:solidFill>
+                <a:latin typeface="Montserrat"/>
+              </a:rPr>
+              <a:t>▪  </a:t>
+            </a:r>
+            <a:r>
+              <a:rPr sz="1500" b="0" i="0">
+                <a:solidFill>
+                  <a:srgbClr val="F1F5F9"/>
+                </a:solidFill>
+                <a:latin typeface="Montserrat"/>
+              </a:rPr>
+              <a:t>Repositório: github.com/fortesindicadores-byte/gestao-em-movimento</a:t>
+            </a:r>
+          </a:p>
+          <a:p>
+            <a:pPr>
+              <a:spcAft>
+                <a:spcPts val="700"/>
+              </a:spcAft>
+            </a:pPr>
+            <a:r>
+              <a:rPr sz="1500" b="1" i="0">
+                <a:solidFill>
+                  <a:srgbClr val="F97316"/>
+                </a:solidFill>
+                <a:latin typeface="Montserrat"/>
+              </a:rPr>
+              <a:t>▪  </a:t>
+            </a:r>
+            <a:r>
+              <a:rPr sz="1500" b="0" i="0">
+                <a:solidFill>
+                  <a:srgbClr val="F1F5F9"/>
+                </a:solidFill>
+                <a:latin typeface="Montserrat"/>
+              </a:rPr>
+              <a:t>Docs no repo: DOCUMENTACAO-TI.md (completo) · CLAUDE.md · PAINEIS.md · HANDOFF.md</a:t>
+            </a:r>
+          </a:p>
+          <a:p>
+            <a:pPr>
+              <a:spcAft>
+                <a:spcPts val="700"/>
+              </a:spcAft>
+            </a:pPr>
+            <a:r>
+              <a:rPr sz="1500" b="1" i="0">
+                <a:solidFill>
+                  <a:srgbClr val="F97316"/>
+                </a:solidFill>
+                <a:latin typeface="Montserrat"/>
+              </a:rPr>
+              <a:t>▪  </a:t>
+            </a:r>
+            <a:r>
+              <a:rPr sz="1500" b="0" i="0">
+                <a:solidFill>
+                  <a:srgbClr val="F1F5F9"/>
+                </a:solidFill>
+                <a:latin typeface="Montserrat"/>
+              </a:rPr>
+              <a:t>Supabase (auth/FCA): lozwipoeacpvplgkrxkq.supabase.co · Conlog (Pneus): ewbzeqsneeylwkxtcpme.supabase.co</a:t>
+            </a:r>
+          </a:p>
+          <a:p>
+            <a:pPr>
+              <a:spcAft>
+                <a:spcPts val="700"/>
+              </a:spcAft>
+            </a:pPr>
+            <a:r>
+              <a:rPr sz="1500" b="1" i="0">
+                <a:solidFill>
+                  <a:srgbClr val="F97316"/>
+                </a:solidFill>
+                <a:latin typeface="Montserrat"/>
+              </a:rPr>
+              <a:t>▪  </a:t>
+            </a:r>
+            <a:r>
+              <a:rPr sz="1500" b="1" i="0">
+                <a:solidFill>
+                  <a:srgbClr val="F97316"/>
+                </a:solidFill>
+                <a:latin typeface="Montserrat"/>
+              </a:rPr>
+              <a:t>Rotina mensal em 5 passos:</a:t>
+            </a:r>
+          </a:p>
+          <a:p>
+            <a:pPr>
+              <a:spcAft>
+                <a:spcPts val="400"/>
+              </a:spcAft>
+            </a:pPr>
+            <a:r>
+              <a:rPr sz="1350" b="1" i="0">
+                <a:solidFill>
+                  <a:srgbClr val="64748B"/>
+                </a:solidFill>
+                <a:latin typeface="Montserrat"/>
+              </a:rPr>
+              <a:t>      –  </a:t>
+            </a:r>
+            <a:r>
+              <a:rPr sz="1350" b="0" i="0">
+                <a:solidFill>
+                  <a:srgbClr val="F1F5F9"/>
+                </a:solidFill>
+                <a:latin typeface="Montserrat"/>
+              </a:rPr>
+              <a:t>1. Mês fecha → planilhas de origem atualizadas (DRE, Base RPM, termômetro)</a:t>
+            </a:r>
+          </a:p>
+          <a:p>
+            <a:pPr>
+              <a:spcAft>
+                <a:spcPts val="400"/>
+              </a:spcAft>
+            </a:pPr>
+            <a:r>
+              <a:rPr sz="1350" b="1" i="0">
+                <a:solidFill>
+                  <a:srgbClr val="64748B"/>
+                </a:solidFill>
+                <a:latin typeface="Montserrat"/>
+              </a:rPr>
+              <a:t>      –  </a:t>
+            </a:r>
+            <a:r>
+              <a:rPr sz="1350" b="0" i="0">
+                <a:solidFill>
+                  <a:srgbClr val="F1F5F9"/>
+                </a:solidFill>
+                <a:latin typeface="Montserrat"/>
+              </a:rPr>
+              <a:t>2. Admin: FCA · Admin → Gerar Custos + Gerar RPM</a:t>
+            </a:r>
+          </a:p>
+          <a:p>
+            <a:pPr>
+              <a:spcAft>
+                <a:spcPts val="400"/>
+              </a:spcAft>
+            </a:pPr>
+            <a:r>
+              <a:rPr sz="1350" b="1" i="0">
+                <a:solidFill>
+                  <a:srgbClr val="64748B"/>
+                </a:solidFill>
+                <a:latin typeface="Montserrat"/>
+              </a:rPr>
+              <a:t>      –  </a:t>
+            </a:r>
+            <a:r>
+              <a:rPr sz="1350" b="0" i="0">
+                <a:solidFill>
+                  <a:srgbClr val="F1F5F9"/>
+                </a:solidFill>
+                <a:latin typeface="Montserrat"/>
+              </a:rPr>
+              <a:t>3. Unidades: FCA · Preenchimento → tratar desvios → SALVAR</a:t>
+            </a:r>
+          </a:p>
+          <a:p>
+            <a:pPr>
+              <a:spcAft>
+                <a:spcPts val="400"/>
+              </a:spcAft>
+            </a:pPr>
+            <a:r>
+              <a:rPr sz="1350" b="1" i="0">
+                <a:solidFill>
+                  <a:srgbClr val="64748B"/>
+                </a:solidFill>
+                <a:latin typeface="Montserrat"/>
+              </a:rPr>
+              <a:t>      –  </a:t>
+            </a:r>
+            <a:r>
+              <a:rPr sz="1350" b="0" i="0">
+                <a:solidFill>
+                  <a:srgbClr val="F1F5F9"/>
+                </a:solidFill>
+                <a:latin typeface="Montserrat"/>
+              </a:rPr>
+              <a:t>4. Gestão: FCA consolidado · Aderência · Termômetro · MPR</a:t>
+            </a:r>
+          </a:p>
+          <a:p>
+            <a:pPr>
+              <a:spcAft>
+                <a:spcPts val="400"/>
+              </a:spcAft>
+            </a:pPr>
+            <a:r>
+              <a:rPr sz="1350" b="1" i="0">
+                <a:solidFill>
+                  <a:srgbClr val="64748B"/>
+                </a:solidFill>
+                <a:latin typeface="Montserrat"/>
+              </a:rPr>
+              <a:t>      –  </a:t>
+            </a:r>
+            <a:r>
+              <a:rPr sz="1350" b="0" i="0">
+                <a:solidFill>
+                  <a:srgbClr val="F1F5F9"/>
+                </a:solidFill>
+                <a:latin typeface="Montserrat"/>
+              </a:rPr>
+              <a:t>5. Pneus atualiza sozinho (Actions 2×/dia); demais painéis leem as fontes ao abrir</a:t>
+            </a:r>
+          </a:p>
+        </p:txBody>
+      </p:sp>
+      <p:sp>
+        <p:nvSpPr>
+          <p:cNvPr id="6" name="TextBox 5"/>
+          <p:cNvSpPr txBox="1"/>
+          <p:nvPr/>
+        </p:nvSpPr>
+        <p:spPr>
+          <a:xfrm>
+            <a:off x="548640" y="6473952"/>
+            <a:ext cx="11064240" cy="320040"/>
+          </a:xfrm>
+          <a:prstGeom prst="rect">
+            <a:avLst/>
+          </a:prstGeom>
+          <a:noFill/>
+        </p:spPr>
+        <p:txBody>
+          <a:bodyPr wrap="square">
+            <a:spAutoFit/>
+          </a:bodyPr>
+          <a:lstStyle/>
+          <a:p>
+            <a:pPr algn="r"/>
+            <a:r>
+              <a:rPr sz="900" b="0" i="0">
+                <a:solidFill>
+                  <a:srgbClr val="64748B"/>
+                </a:solidFill>
+                <a:latin typeface="Montserrat"/>
+              </a:rPr>
+              <a:t>Handoff Técnico — TI  ·  16</a:t>
             </a:r>
           </a:p>
         </p:txBody>
@@ -10187,7 +10723,7 @@
                 </a:solidFill>
                 <a:latin typeface="Montserrat"/>
               </a:rPr>
-              <a:t>tabela snapshot: PK endpoint+branch_id, payload jsonb (vehicles, tires, inspections)</a:t>
+              <a:t>tabela snapshot: 1 linha por (endpoint, filial), payload jsonb já transformado</a:t>
             </a:r>
           </a:p>
           <a:p>
@@ -10212,32 +10748,7 @@
                 </a:solidFill>
                 <a:latin typeface="Montserrat"/>
               </a:rPr>
-              <a:t>carga: GitHub Actions pneus-loader.yml → scripts/pneus-loader.mjs (Prolog API), 2×/dia</a:t>
-            </a:r>
-          </a:p>
-          <a:p>
-            <a:pPr>
-              <a:spcAft>
-                <a:spcPts val="400"/>
-              </a:spcAft>
-            </a:pPr>
-            <a:r>
-              <a:rPr sz="1350" b="1" i="0">
-                <a:solidFill>
-                  <a:srgbClr val="64748B"/>
-                </a:solidFill>
-                <a:latin typeface="Montserrat"/>
-              </a:rPr>
-              <a:t>      –  </a:t>
-            </a:r>
-            <a:r>
-              <a:rPr sz="1350" b="0" i="0">
-                <a:solidFill>
-                  <a:srgbClr val="F1F5F9"/>
-                </a:solidFill>
-                <a:latin typeface="Montserrat"/>
-              </a:rPr>
-              <a:t>credenciais só em secrets do Actions</a:t>
+              <a:t>front lê com chave anon; carga é feita pelo loader (próximo slide)</a:t>
             </a:r>
           </a:p>
           <a:p>
@@ -10454,7 +10965,7 @@
                 </a:solidFill>
                 <a:latin typeface="Montserrat"/>
               </a:rPr>
-              <a:t>Módulo FCA — geração dos desvios</a:t>
+              <a:t>Integração Conlog — leitura da API Prolog</a:t>
             </a:r>
           </a:p>
           <a:p>
@@ -10465,297 +10976,21 @@
                 </a:solidFill>
                 <a:latin typeface="Montserrat"/>
               </a:rPr>
-              <a:t>O banco é o dono; planilhas só entram na geração (admin)</a:t>
-            </a:r>
-          </a:p>
-        </p:txBody>
-      </p:sp>
-      <p:sp>
-        <p:nvSpPr>
-          <p:cNvPr id="5" name="Rounded Rectangle 4"/>
-          <p:cNvSpPr/>
-          <p:nvPr/>
-        </p:nvSpPr>
-        <p:spPr>
-          <a:xfrm>
-            <a:off x="548640" y="1508760"/>
-            <a:ext cx="5394960" cy="2286000"/>
-          </a:xfrm>
-          <a:prstGeom prst="roundRect">
-            <a:avLst/>
-          </a:prstGeom>
-          <a:solidFill>
-            <a:srgbClr val="141B26"/>
-          </a:solidFill>
-          <a:ln w="12700">
-            <a:solidFill>
-              <a:srgbClr val="1E2D40"/>
-            </a:solidFill>
-          </a:ln>
-        </p:spPr>
-        <p:style>
-          <a:lnRef idx="1">
-            <a:schemeClr val="accent1"/>
-          </a:lnRef>
-          <a:fillRef idx="3">
-            <a:schemeClr val="accent1"/>
-          </a:fillRef>
-          <a:effectRef idx="2">
-            <a:schemeClr val="accent1"/>
-          </a:effectRef>
-          <a:fontRef idx="minor">
-            <a:schemeClr val="lt1"/>
-          </a:fontRef>
-        </p:style>
-        <p:txBody>
-          <a:bodyPr rtlCol="0" anchor="t" wrap="square" lIns="146304" rIns="128016" tIns="91440" bIns="73152"/>
-          <a:lstStyle/>
-          <a:p>
-            <a:pPr algn="ctr">
-              <a:spcAft>
-                <a:spcPts val="400"/>
-              </a:spcAft>
-            </a:pPr>
-            <a:r>
-              <a:rPr sz="1300" b="1" i="0">
-                <a:solidFill>
-                  <a:srgbClr val="F97316"/>
-                </a:solidFill>
-                <a:latin typeface="Montserrat"/>
-              </a:rPr>
-              <a:t>GERAR CUSTOS  (?gen=all)</a:t>
-            </a:r>
-          </a:p>
-          <a:p>
-            <a:pPr>
-              <a:spcAft>
-                <a:spcPts val="200"/>
-              </a:spcAft>
-            </a:pPr>
-            <a:r>
-              <a:rPr sz="1100" b="0" i="0">
-                <a:solidFill>
-                  <a:srgbClr val="94A3B8"/>
-                </a:solidFill>
-                <a:latin typeface="Montserrat"/>
-              </a:rPr>
-              <a:t>Lê a DRE do último mês fechado (todas as unidades)</a:t>
-            </a:r>
-          </a:p>
-          <a:p>
-            <a:pPr>
-              <a:spcAft>
-                <a:spcPts val="200"/>
-              </a:spcAft>
-            </a:pPr>
-            <a:r>
-              <a:rPr sz="1100" b="0" i="0">
-                <a:solidFill>
-                  <a:srgbClr val="94A3B8"/>
-                </a:solidFill>
-                <a:latin typeface="Montserrat"/>
-              </a:rPr>
-              <a:t>Desvio = gasto acima do remunerado (custos são negativos na DRE)</a:t>
-            </a:r>
-          </a:p>
-          <a:p>
-            <a:pPr>
-              <a:spcAft>
-                <a:spcPts val="200"/>
-              </a:spcAft>
-            </a:pPr>
-            <a:r>
-              <a:rPr sz="1100" b="0" i="0">
-                <a:solidFill>
-                  <a:srgbClr val="94A3B8"/>
-                </a:solidFill>
-                <a:latin typeface="Montserrat"/>
-              </a:rPr>
-              <a:t>Cria fatos VAZIOS p/ as unidades preencherem</a:t>
-            </a:r>
-          </a:p>
-          <a:p>
-            <a:pPr>
-              <a:spcAft>
-                <a:spcPts val="200"/>
-              </a:spcAft>
-            </a:pPr>
-            <a:r>
-              <a:rPr sz="1100" b="0" i="0">
-                <a:solidFill>
-                  <a:srgbClr val="94A3B8"/>
-                </a:solidFill>
-                <a:latin typeface="Montserrat"/>
-              </a:rPr>
-              <a:t>Km/L e R$/L não viram fato — entram como causa do Combustível</a:t>
-            </a:r>
-          </a:p>
-          <a:p>
-            <a:pPr>
-              <a:spcAft>
-                <a:spcPts val="200"/>
-              </a:spcAft>
-            </a:pPr>
-            <a:r>
-              <a:rPr sz="1100" b="0" i="0">
-                <a:solidFill>
-                  <a:srgbClr val="94A3B8"/>
-                </a:solidFill>
-                <a:latin typeface="Montserrat"/>
-              </a:rPr>
-              <a:t>Causas automáticas: piores placas, dispersão de km</a:t>
-            </a:r>
-          </a:p>
-        </p:txBody>
-      </p:sp>
-      <p:sp>
-        <p:nvSpPr>
-          <p:cNvPr id="6" name="Rounded Rectangle 5"/>
-          <p:cNvSpPr/>
-          <p:nvPr/>
-        </p:nvSpPr>
-        <p:spPr>
-          <a:xfrm>
-            <a:off x="6217920" y="1508760"/>
-            <a:ext cx="5394960" cy="2286000"/>
-          </a:xfrm>
-          <a:prstGeom prst="roundRect">
-            <a:avLst/>
-          </a:prstGeom>
-          <a:solidFill>
-            <a:srgbClr val="141B26"/>
-          </a:solidFill>
-          <a:ln w="12700">
-            <a:solidFill>
-              <a:srgbClr val="1E2D40"/>
-            </a:solidFill>
-          </a:ln>
-        </p:spPr>
-        <p:style>
-          <a:lnRef idx="1">
-            <a:schemeClr val="accent1"/>
-          </a:lnRef>
-          <a:fillRef idx="3">
-            <a:schemeClr val="accent1"/>
-          </a:fillRef>
-          <a:effectRef idx="2">
-            <a:schemeClr val="accent1"/>
-          </a:effectRef>
-          <a:fontRef idx="minor">
-            <a:schemeClr val="lt1"/>
-          </a:fontRef>
-        </p:style>
-        <p:txBody>
-          <a:bodyPr rtlCol="0" anchor="t" wrap="square" lIns="146304" rIns="128016" tIns="91440" bIns="73152"/>
-          <a:lstStyle/>
-          <a:p>
-            <a:pPr algn="ctr">
-              <a:spcAft>
-                <a:spcPts val="400"/>
-              </a:spcAft>
-            </a:pPr>
-            <a:r>
-              <a:rPr sz="1300" b="1" i="0">
-                <a:solidFill>
-                  <a:srgbClr val="F97316"/>
-                </a:solidFill>
-                <a:latin typeface="Montserrat"/>
-              </a:rPr>
-              <a:t>GERAR RPM  (?sync=rpm)</a:t>
-            </a:r>
-          </a:p>
-          <a:p>
-            <a:pPr>
-              <a:spcAft>
-                <a:spcPts val="200"/>
-              </a:spcAft>
-            </a:pPr>
-            <a:r>
-              <a:rPr sz="1100" b="0" i="0">
-                <a:solidFill>
-                  <a:srgbClr val="94A3B8"/>
-                </a:solidFill>
-                <a:latin typeface="Montserrat"/>
-              </a:rPr>
-              <a:t>Lê a aba Base RPM do Gerot POR NOME de coluna</a:t>
-            </a:r>
-          </a:p>
-          <a:p>
-            <a:pPr>
-              <a:spcAft>
-                <a:spcPts val="200"/>
-              </a:spcAft>
-            </a:pPr>
-            <a:r>
-              <a:rPr sz="1100" b="0" i="0">
-                <a:solidFill>
-                  <a:srgbClr val="94A3B8"/>
-                </a:solidFill>
-                <a:latin typeface="Montserrat"/>
-              </a:rPr>
-              <a:t>IC/IV com atingimento &lt; 100% viram fato (desvio Meta|Real|Ating)</a:t>
-            </a:r>
-          </a:p>
-          <a:p>
-            <a:pPr>
-              <a:spcAft>
-                <a:spcPts val="200"/>
-              </a:spcAft>
-            </a:pPr>
-            <a:r>
-              <a:rPr sz="1100" b="0" i="0">
-                <a:solidFill>
-                  <a:srgbClr val="94A3B8"/>
-                </a:solidFill>
-                <a:latin typeface="Montserrat"/>
-              </a:rPr>
-              <a:t>Unidade→(código, projeto) fixo no código: RPM_UNIT_MAP</a:t>
-            </a:r>
-          </a:p>
-          <a:p>
-            <a:pPr>
-              <a:spcAft>
-                <a:spcPts val="200"/>
-              </a:spcAft>
-            </a:pPr>
-            <a:r>
-              <a:rPr sz="1100" b="0" i="0">
-                <a:solidFill>
-                  <a:srgbClr val="94A3B8"/>
-                </a:solidFill>
-                <a:latin typeface="Montserrat"/>
-              </a:rPr>
-              <a:t>Corte FILL_UNTIL=202604: ≤mai/26 veio preenchido da aba;</a:t>
-            </a:r>
-          </a:p>
-          <a:p>
-            <a:pPr>
-              <a:spcAft>
-                <a:spcPts val="200"/>
-              </a:spcAft>
-            </a:pPr>
-            <a:r>
-              <a:rPr sz="1100" b="0" i="0">
-                <a:solidFill>
-                  <a:srgbClr val="94A3B8"/>
-                </a:solidFill>
-                <a:latin typeface="Montserrat"/>
-              </a:rPr>
-              <a:t>de jun/26 em diante nasce vazio (preenchimento é no painel)</a:t>
-            </a:r>
-          </a:p>
-        </p:txBody>
-      </p:sp>
-      <p:sp>
-        <p:nvSpPr>
-          <p:cNvPr id="7" name="TextBox 6"/>
+              <a:t>Único ETL do projeto: scripts/pneus-loader.mjs (Node) via GitHub Actions</a:t>
+            </a:r>
+          </a:p>
+        </p:txBody>
+      </p:sp>
+      <p:sp>
+        <p:nvSpPr>
+          <p:cNvPr id="5" name="TextBox 4"/>
           <p:cNvSpPr txBox="1"/>
           <p:nvPr/>
         </p:nvSpPr>
         <p:spPr>
           <a:xfrm>
-            <a:off x="548640" y="4069080"/>
-            <a:ext cx="11064240" cy="1828800"/>
+            <a:off x="548640" y="1417320"/>
+            <a:ext cx="11064240" cy="5120640"/>
           </a:xfrm>
           <a:prstGeom prst="rect">
             <a:avLst/>
@@ -10768,43 +11003,260 @@
           </a:bodyPr>
           <a:lstStyle/>
           <a:p>
+            <a:pPr>
+              <a:spcAft>
+                <a:spcPts val="700"/>
+              </a:spcAft>
+            </a:pPr>
             <a:r>
               <a:rPr sz="1500" b="1" i="0">
                 <a:solidFill>
-                  <a:srgbClr val="3BB33B"/>
-                </a:solidFill>
-                <a:latin typeface="Montserrat"/>
-              </a:rPr>
-              <a:t>As duas rotinas são ADITIVAS e IDEMPOTENTES:</a:t>
-            </a:r>
-          </a:p>
-          <a:p>
-            <a:r>
-              <a:rPr sz="1300" b="0" i="0">
-                <a:solidFill>
-                  <a:srgbClr val="94A3B8"/>
-                </a:solidFill>
-                <a:latin typeface="Montserrat"/>
-              </a:rPr>
-              <a:t>só inserem o que não existe (chave = vigência+origem+projeto+fato). Nunca apagam nem sobrescrevem o que a unidade preencheu. Clicar 2× não duplica.</a:t>
-            </a:r>
-          </a:p>
-          <a:p>
-            <a:r>
-              <a:rPr sz="1200" b="0" i="0">
+                  <a:srgbClr val="F97316"/>
+                </a:solidFill>
+                <a:latin typeface="Montserrat"/>
+              </a:rPr>
+              <a:t>▪  </a:t>
+            </a:r>
+            <a:r>
+              <a:rPr sz="1500" b="0" i="0">
+                <a:solidFill>
+                  <a:srgbClr val="F1F5F9"/>
+                </a:solidFill>
+                <a:latin typeface="Montserrat"/>
+              </a:rPr>
+              <a:t>API: https://prologapp.com/prolog/api/v3 · auth por header x-prolog-api-token (secret PROLOG_TOKEN).</a:t>
+            </a:r>
+          </a:p>
+          <a:p>
+            <a:pPr>
+              <a:spcAft>
+                <a:spcPts val="700"/>
+              </a:spcAft>
+            </a:pPr>
+            <a:r>
+              <a:rPr sz="1500" b="1" i="0">
+                <a:solidFill>
+                  <a:srgbClr val="F97316"/>
+                </a:solidFill>
+                <a:latin typeface="Montserrat"/>
+              </a:rPr>
+              <a:t>▪  </a:t>
+            </a:r>
+            <a:r>
+              <a:rPr sz="1500" b="0" i="0">
+                <a:solidFill>
+                  <a:srgbClr val="F1F5F9"/>
+                </a:solidFill>
+                <a:latin typeface="Montserrat"/>
+              </a:rPr>
+              <a:t>Endpoints lidos por unidade (branchOfficesId — 14 filiais fixas no script):</a:t>
+            </a:r>
+          </a:p>
+          <a:p>
+            <a:pPr>
+              <a:spcAft>
+                <a:spcPts val="400"/>
+              </a:spcAft>
+            </a:pPr>
+            <a:r>
+              <a:rPr sz="1350" b="1" i="0">
                 <a:solidFill>
                   <a:srgbClr val="64748B"/>
                 </a:solidFill>
                 <a:latin typeface="Montserrat"/>
               </a:rPr>
-              <a:t>Cutover: o histórico foi importado uma única vez do “FCA Total” (rotina já removida da UI). A planilha FCA Total é LEGADO — não é mais fonte.</a:t>
-            </a:r>
-          </a:p>
-        </p:txBody>
-      </p:sp>
-      <p:sp>
-        <p:nvSpPr>
-          <p:cNvPr id="8" name="TextBox 7"/>
+              <a:t>      –  </a:t>
+            </a:r>
+            <a:r>
+              <a:rPr sz="1350" b="0" i="0">
+                <a:solidFill>
+                  <a:srgbClr val="F1F5F9"/>
+                </a:solidFill>
+                <a:latin typeface="Montserrat"/>
+              </a:rPr>
+              <a:t>GET /vehicles (includeInactive=false) → frota ativa</a:t>
+            </a:r>
+          </a:p>
+          <a:p>
+            <a:pPr>
+              <a:spcAft>
+                <a:spcPts val="400"/>
+              </a:spcAft>
+            </a:pPr>
+            <a:r>
+              <a:rPr sz="1350" b="1" i="0">
+                <a:solidFill>
+                  <a:srgbClr val="64748B"/>
+                </a:solidFill>
+                <a:latin typeface="Montserrat"/>
+              </a:rPr>
+              <a:t>      –  </a:t>
+            </a:r>
+            <a:r>
+              <a:rPr sz="1350" b="0" i="0">
+                <a:solidFill>
+                  <a:srgbClr val="F1F5F9"/>
+                </a:solidFill>
+                <a:latin typeface="Montserrat"/>
+              </a:rPr>
+              <a:t>GET /tires → sulcos, menor sulco, amplitude, pressão atual × recomendada (% desvio), recapagens</a:t>
+            </a:r>
+          </a:p>
+          <a:p>
+            <a:pPr>
+              <a:spcAft>
+                <a:spcPts val="400"/>
+              </a:spcAft>
+            </a:pPr>
+            <a:r>
+              <a:rPr sz="1350" b="1" i="0">
+                <a:solidFill>
+                  <a:srgbClr val="64748B"/>
+                </a:solidFill>
+                <a:latin typeface="Montserrat"/>
+              </a:rPr>
+              <a:t>      –  </a:t>
+            </a:r>
+            <a:r>
+              <a:rPr sz="1350" b="0" i="0">
+                <a:solidFill>
+                  <a:srgbClr val="F1F5F9"/>
+                </a:solidFill>
+                <a:latin typeface="Montserrat"/>
+              </a:rPr>
+              <a:t>GET /tire-inspections/vehicles → aferições, janela de 01/01 do ano corrente até hoje</a:t>
+            </a:r>
+          </a:p>
+          <a:p>
+            <a:pPr>
+              <a:spcAft>
+                <a:spcPts val="700"/>
+              </a:spcAft>
+            </a:pPr>
+            <a:r>
+              <a:rPr sz="1500" b="1" i="0">
+                <a:solidFill>
+                  <a:srgbClr val="F97316"/>
+                </a:solidFill>
+                <a:latin typeface="Montserrat"/>
+              </a:rPr>
+              <a:t>▪  </a:t>
+            </a:r>
+            <a:r>
+              <a:rPr sz="1500" b="0" i="0">
+                <a:solidFill>
+                  <a:srgbClr val="F1F5F9"/>
+                </a:solidFill>
+                <a:latin typeface="Montserrat"/>
+              </a:rPr>
+              <a:t>Paginação pageSize=100 · rate limit ~10 req/min → 6,5 s entre chamadas; 429 → espera 61 s; até 6 retries/página.</a:t>
+            </a:r>
+          </a:p>
+          <a:p>
+            <a:pPr>
+              <a:spcAft>
+                <a:spcPts val="700"/>
+              </a:spcAft>
+            </a:pPr>
+            <a:r>
+              <a:rPr sz="1500" b="1" i="0">
+                <a:solidFill>
+                  <a:srgbClr val="F97316"/>
+                </a:solidFill>
+                <a:latin typeface="Montserrat"/>
+              </a:rPr>
+              <a:t>▪  </a:t>
+            </a:r>
+            <a:r>
+              <a:rPr sz="1500" b="0" i="0">
+                <a:solidFill>
+                  <a:srgbClr val="F1F5F9"/>
+                </a:solidFill>
+                <a:latin typeface="Montserrat"/>
+              </a:rPr>
+              <a:t>Proteção: unidade com 0 veículos é PULADA (mantém o snapshot anterior — nunca grava vazio).</a:t>
+            </a:r>
+          </a:p>
+          <a:p>
+            <a:pPr>
+              <a:spcAft>
+                <a:spcPts val="700"/>
+              </a:spcAft>
+            </a:pPr>
+            <a:r>
+              <a:rPr sz="1500" b="1" i="0">
+                <a:solidFill>
+                  <a:srgbClr val="F97316"/>
+                </a:solidFill>
+                <a:latin typeface="Montserrat"/>
+              </a:rPr>
+              <a:t>▪  </a:t>
+            </a:r>
+            <a:r>
+              <a:rPr sz="1500" b="0" i="0">
+                <a:solidFill>
+                  <a:srgbClr val="F1F5F9"/>
+                </a:solidFill>
+                <a:latin typeface="Montserrat"/>
+              </a:rPr>
+              <a:t>Gravação: upsert REST no Supabase Conlog (on_conflict=endpoint,branch_id) com service key — só no Actions.</a:t>
+            </a:r>
+          </a:p>
+          <a:p>
+            <a:pPr>
+              <a:spcAft>
+                <a:spcPts val="700"/>
+              </a:spcAft>
+            </a:pPr>
+            <a:r>
+              <a:rPr sz="1500" b="1" i="0">
+                <a:solidFill>
+                  <a:srgbClr val="F97316"/>
+                </a:solidFill>
+                <a:latin typeface="Montserrat"/>
+              </a:rPr>
+              <a:t>▪  </a:t>
+            </a:r>
+            <a:r>
+              <a:rPr sz="1500" b="0" i="0">
+                <a:solidFill>
+                  <a:srgbClr val="F1F5F9"/>
+                </a:solidFill>
+                <a:latin typeface="Montserrat"/>
+              </a:rPr>
+              <a:t>Agendamento: cron 06h/18h BRT + botão Run workflow · concurrency (1 carga por vez) · timeout 350 min.</a:t>
+            </a:r>
+          </a:p>
+          <a:p>
+            <a:pPr>
+              <a:spcAft>
+                <a:spcPts val="700"/>
+              </a:spcAft>
+            </a:pPr>
+            <a:r>
+              <a:rPr sz="1500" b="1" i="0">
+                <a:solidFill>
+                  <a:srgbClr val="F97316"/>
+                </a:solidFill>
+                <a:latin typeface="Montserrat"/>
+              </a:rPr>
+              <a:t>▪  </a:t>
+            </a:r>
+            <a:r>
+              <a:rPr sz="1500" b="1" i="0">
+                <a:solidFill>
+                  <a:srgbClr val="EAB308"/>
+                </a:solidFill>
+                <a:latin typeface="Montserrat"/>
+              </a:rPr>
+              <a:t>Diagnóstico “Pneus sem dados”: aba Actions → Pneus Loader (Conlog) → logs do último run.</a:t>
+            </a:r>
+          </a:p>
+        </p:txBody>
+      </p:sp>
+      <p:sp>
+        <p:nvSpPr>
+          <p:cNvPr id="6" name="TextBox 5"/>
           <p:cNvSpPr txBox="1"/>
           <p:nvPr/>
         </p:nvSpPr>

</xml_diff>

<commit_message>
Docs: detalhar a leitura da API Prolog (loader Pneus) (#31)
- DOCUMENTACAO-TI.md §8: base URL/auth da Prolog, endpoints (/vehicles,
  /tires, /tire-inspections/vehicles), paginação, rate limit e retries,
  14 branch ids, proteção contra snapshot vazio, upsert no Supabase,
  agendamento/secrets do Actions e diagnóstico
- deck técnico: novo slide "Integração Conlog — leitura da API Prolog"


Claude-Session: https://claude.ai/code/session_01CoPzrx19nUHZqody5fEJUg

Co-authored-by: Claude <noreply@anthropic.com>
</commit_message>
<xml_diff>
--- a/docs/Gestao-em-Movimento_Tecnico-TI.pptx
+++ b/docs/Gestao-em-Movimento_Tecnico-TI.pptx
@@ -20,6 +20,7 @@
     <p:sldId id="268" r:id="rId19"/>
     <p:sldId id="269" r:id="rId20"/>
     <p:sldId id="270" r:id="rId21"/>
+    <p:sldId id="271" r:id="rId22"/>
   </p:sldIdLst>
   <p:sldSz cx="12191695" cy="6858000" type="screen4x3"/>
   <p:notesSz cx="6858000" cy="9144000"/>
@@ -3429,21 +3430,308 @@
                 </a:solidFill>
                 <a:latin typeface="Montserrat"/>
               </a:rPr>
-              <a:t>Módulo FCA — painéis e fluxo de preenchimento</a:t>
-            </a:r>
-          </a:p>
-        </p:txBody>
-      </p:sp>
-      <p:sp>
-        <p:nvSpPr>
-          <p:cNvPr id="5" name="TextBox 4"/>
+              <a:t>Módulo FCA — geração dos desvios</a:t>
+            </a:r>
+          </a:p>
+          <a:p>
+            <a:r>
+              <a:rPr sz="1200" b="0" i="0">
+                <a:solidFill>
+                  <a:srgbClr val="94A3B8"/>
+                </a:solidFill>
+                <a:latin typeface="Montserrat"/>
+              </a:rPr>
+              <a:t>O banco é o dono; planilhas só entram na geração (admin)</a:t>
+            </a:r>
+          </a:p>
+        </p:txBody>
+      </p:sp>
+      <p:sp>
+        <p:nvSpPr>
+          <p:cNvPr id="5" name="Rounded Rectangle 4"/>
+          <p:cNvSpPr/>
+          <p:nvPr/>
+        </p:nvSpPr>
+        <p:spPr>
+          <a:xfrm>
+            <a:off x="548640" y="1508760"/>
+            <a:ext cx="5394960" cy="2286000"/>
+          </a:xfrm>
+          <a:prstGeom prst="roundRect">
+            <a:avLst/>
+          </a:prstGeom>
+          <a:solidFill>
+            <a:srgbClr val="141B26"/>
+          </a:solidFill>
+          <a:ln w="12700">
+            <a:solidFill>
+              <a:srgbClr val="1E2D40"/>
+            </a:solidFill>
+          </a:ln>
+        </p:spPr>
+        <p:style>
+          <a:lnRef idx="1">
+            <a:schemeClr val="accent1"/>
+          </a:lnRef>
+          <a:fillRef idx="3">
+            <a:schemeClr val="accent1"/>
+          </a:fillRef>
+          <a:effectRef idx="2">
+            <a:schemeClr val="accent1"/>
+          </a:effectRef>
+          <a:fontRef idx="minor">
+            <a:schemeClr val="lt1"/>
+          </a:fontRef>
+        </p:style>
+        <p:txBody>
+          <a:bodyPr rtlCol="0" anchor="t" wrap="square" lIns="146304" rIns="128016" tIns="91440" bIns="73152"/>
+          <a:lstStyle/>
+          <a:p>
+            <a:pPr algn="ctr">
+              <a:spcAft>
+                <a:spcPts val="400"/>
+              </a:spcAft>
+            </a:pPr>
+            <a:r>
+              <a:rPr sz="1300" b="1" i="0">
+                <a:solidFill>
+                  <a:srgbClr val="F97316"/>
+                </a:solidFill>
+                <a:latin typeface="Montserrat"/>
+              </a:rPr>
+              <a:t>GERAR CUSTOS  (?gen=all)</a:t>
+            </a:r>
+          </a:p>
+          <a:p>
+            <a:pPr>
+              <a:spcAft>
+                <a:spcPts val="200"/>
+              </a:spcAft>
+            </a:pPr>
+            <a:r>
+              <a:rPr sz="1100" b="0" i="0">
+                <a:solidFill>
+                  <a:srgbClr val="94A3B8"/>
+                </a:solidFill>
+                <a:latin typeface="Montserrat"/>
+              </a:rPr>
+              <a:t>Lê a DRE do último mês fechado (todas as unidades)</a:t>
+            </a:r>
+          </a:p>
+          <a:p>
+            <a:pPr>
+              <a:spcAft>
+                <a:spcPts val="200"/>
+              </a:spcAft>
+            </a:pPr>
+            <a:r>
+              <a:rPr sz="1100" b="0" i="0">
+                <a:solidFill>
+                  <a:srgbClr val="94A3B8"/>
+                </a:solidFill>
+                <a:latin typeface="Montserrat"/>
+              </a:rPr>
+              <a:t>Desvio = gasto acima do remunerado (custos são negativos na DRE)</a:t>
+            </a:r>
+          </a:p>
+          <a:p>
+            <a:pPr>
+              <a:spcAft>
+                <a:spcPts val="200"/>
+              </a:spcAft>
+            </a:pPr>
+            <a:r>
+              <a:rPr sz="1100" b="0" i="0">
+                <a:solidFill>
+                  <a:srgbClr val="94A3B8"/>
+                </a:solidFill>
+                <a:latin typeface="Montserrat"/>
+              </a:rPr>
+              <a:t>Cria fatos VAZIOS p/ as unidades preencherem</a:t>
+            </a:r>
+          </a:p>
+          <a:p>
+            <a:pPr>
+              <a:spcAft>
+                <a:spcPts val="200"/>
+              </a:spcAft>
+            </a:pPr>
+            <a:r>
+              <a:rPr sz="1100" b="0" i="0">
+                <a:solidFill>
+                  <a:srgbClr val="94A3B8"/>
+                </a:solidFill>
+                <a:latin typeface="Montserrat"/>
+              </a:rPr>
+              <a:t>Km/L e R$/L não viram fato — entram como causa do Combustível</a:t>
+            </a:r>
+          </a:p>
+          <a:p>
+            <a:pPr>
+              <a:spcAft>
+                <a:spcPts val="200"/>
+              </a:spcAft>
+            </a:pPr>
+            <a:r>
+              <a:rPr sz="1100" b="0" i="0">
+                <a:solidFill>
+                  <a:srgbClr val="94A3B8"/>
+                </a:solidFill>
+                <a:latin typeface="Montserrat"/>
+              </a:rPr>
+              <a:t>Causas automáticas: piores placas, dispersão de km</a:t>
+            </a:r>
+          </a:p>
+        </p:txBody>
+      </p:sp>
+      <p:sp>
+        <p:nvSpPr>
+          <p:cNvPr id="6" name="Rounded Rectangle 5"/>
+          <p:cNvSpPr/>
+          <p:nvPr/>
+        </p:nvSpPr>
+        <p:spPr>
+          <a:xfrm>
+            <a:off x="6217920" y="1508760"/>
+            <a:ext cx="5394960" cy="2286000"/>
+          </a:xfrm>
+          <a:prstGeom prst="roundRect">
+            <a:avLst/>
+          </a:prstGeom>
+          <a:solidFill>
+            <a:srgbClr val="141B26"/>
+          </a:solidFill>
+          <a:ln w="12700">
+            <a:solidFill>
+              <a:srgbClr val="1E2D40"/>
+            </a:solidFill>
+          </a:ln>
+        </p:spPr>
+        <p:style>
+          <a:lnRef idx="1">
+            <a:schemeClr val="accent1"/>
+          </a:lnRef>
+          <a:fillRef idx="3">
+            <a:schemeClr val="accent1"/>
+          </a:fillRef>
+          <a:effectRef idx="2">
+            <a:schemeClr val="accent1"/>
+          </a:effectRef>
+          <a:fontRef idx="minor">
+            <a:schemeClr val="lt1"/>
+          </a:fontRef>
+        </p:style>
+        <p:txBody>
+          <a:bodyPr rtlCol="0" anchor="t" wrap="square" lIns="146304" rIns="128016" tIns="91440" bIns="73152"/>
+          <a:lstStyle/>
+          <a:p>
+            <a:pPr algn="ctr">
+              <a:spcAft>
+                <a:spcPts val="400"/>
+              </a:spcAft>
+            </a:pPr>
+            <a:r>
+              <a:rPr sz="1300" b="1" i="0">
+                <a:solidFill>
+                  <a:srgbClr val="F97316"/>
+                </a:solidFill>
+                <a:latin typeface="Montserrat"/>
+              </a:rPr>
+              <a:t>GERAR RPM  (?sync=rpm)</a:t>
+            </a:r>
+          </a:p>
+          <a:p>
+            <a:pPr>
+              <a:spcAft>
+                <a:spcPts val="200"/>
+              </a:spcAft>
+            </a:pPr>
+            <a:r>
+              <a:rPr sz="1100" b="0" i="0">
+                <a:solidFill>
+                  <a:srgbClr val="94A3B8"/>
+                </a:solidFill>
+                <a:latin typeface="Montserrat"/>
+              </a:rPr>
+              <a:t>Lê a aba Base RPM do Gerot POR NOME de coluna</a:t>
+            </a:r>
+          </a:p>
+          <a:p>
+            <a:pPr>
+              <a:spcAft>
+                <a:spcPts val="200"/>
+              </a:spcAft>
+            </a:pPr>
+            <a:r>
+              <a:rPr sz="1100" b="0" i="0">
+                <a:solidFill>
+                  <a:srgbClr val="94A3B8"/>
+                </a:solidFill>
+                <a:latin typeface="Montserrat"/>
+              </a:rPr>
+              <a:t>IC/IV com atingimento &lt; 100% viram fato (desvio Meta|Real|Ating)</a:t>
+            </a:r>
+          </a:p>
+          <a:p>
+            <a:pPr>
+              <a:spcAft>
+                <a:spcPts val="200"/>
+              </a:spcAft>
+            </a:pPr>
+            <a:r>
+              <a:rPr sz="1100" b="0" i="0">
+                <a:solidFill>
+                  <a:srgbClr val="94A3B8"/>
+                </a:solidFill>
+                <a:latin typeface="Montserrat"/>
+              </a:rPr>
+              <a:t>Unidade→(código, projeto) fixo no código: RPM_UNIT_MAP</a:t>
+            </a:r>
+          </a:p>
+          <a:p>
+            <a:pPr>
+              <a:spcAft>
+                <a:spcPts val="200"/>
+              </a:spcAft>
+            </a:pPr>
+            <a:r>
+              <a:rPr sz="1100" b="0" i="0">
+                <a:solidFill>
+                  <a:srgbClr val="94A3B8"/>
+                </a:solidFill>
+                <a:latin typeface="Montserrat"/>
+              </a:rPr>
+              <a:t>Corte FILL_UNTIL=202604: ≤mai/26 veio preenchido da aba;</a:t>
+            </a:r>
+          </a:p>
+          <a:p>
+            <a:pPr>
+              <a:spcAft>
+                <a:spcPts val="200"/>
+              </a:spcAft>
+            </a:pPr>
+            <a:r>
+              <a:rPr sz="1100" b="0" i="0">
+                <a:solidFill>
+                  <a:srgbClr val="94A3B8"/>
+                </a:solidFill>
+                <a:latin typeface="Montserrat"/>
+              </a:rPr>
+              <a:t>de jun/26 em diante nasce vazio (preenchimento é no painel)</a:t>
+            </a:r>
+          </a:p>
+        </p:txBody>
+      </p:sp>
+      <p:sp>
+        <p:nvSpPr>
+          <p:cNvPr id="7" name="TextBox 6"/>
           <p:cNvSpPr txBox="1"/>
           <p:nvPr/>
         </p:nvSpPr>
         <p:spPr>
           <a:xfrm>
-            <a:off x="548640" y="1417320"/>
-            <a:ext cx="11064240" cy="5120640"/>
+            <a:off x="548640" y="4069080"/>
+            <a:ext cx="11064240" cy="1828800"/>
           </a:xfrm>
           <a:prstGeom prst="rect">
             <a:avLst/>
@@ -3456,210 +3744,43 @@
           </a:bodyPr>
           <a:lstStyle/>
           <a:p>
-            <a:pPr>
-              <a:spcAft>
-                <a:spcPts val="700"/>
-              </a:spcAft>
-            </a:pPr>
             <a:r>
               <a:rPr sz="1500" b="1" i="0">
                 <a:solidFill>
-                  <a:srgbClr val="F97316"/>
-                </a:solidFill>
-                <a:latin typeface="Montserrat"/>
-              </a:rPr>
-              <a:t>▪  </a:t>
-            </a:r>
-            <a:r>
-              <a:rPr sz="1500" b="1" i="0">
-                <a:solidFill>
-                  <a:srgbClr val="F97316"/>
-                </a:solidFill>
-                <a:latin typeface="Montserrat"/>
-              </a:rPr>
-              <a:t>fca-preenchimento/ — a unidade trata seus desvios:</a:t>
-            </a:r>
-          </a:p>
-          <a:p>
-            <a:pPr>
-              <a:spcAft>
-                <a:spcPts val="400"/>
-              </a:spcAft>
-            </a:pPr>
-            <a:r>
-              <a:rPr sz="1350" b="1" i="0">
+                  <a:srgbClr val="3BB33B"/>
+                </a:solidFill>
+                <a:latin typeface="Montserrat"/>
+              </a:rPr>
+              <a:t>As duas rotinas são ADITIVAS e IDEMPOTENTES:</a:t>
+            </a:r>
+          </a:p>
+          <a:p>
+            <a:r>
+              <a:rPr sz="1300" b="0" i="0">
+                <a:solidFill>
+                  <a:srgbClr val="94A3B8"/>
+                </a:solidFill>
+                <a:latin typeface="Montserrat"/>
+              </a:rPr>
+              <a:t>só inserem o que não existe (chave = vigência+origem+projeto+fato). Nunca apagam nem sobrescrevem o que a unidade preencheu. Clicar 2× não duplica.</a:t>
+            </a:r>
+          </a:p>
+          <a:p>
+            <a:r>
+              <a:rPr sz="1200" b="0" i="0">
                 <a:solidFill>
                   <a:srgbClr val="64748B"/>
                 </a:solidFill>
                 <a:latin typeface="Montserrat"/>
               </a:rPr>
-              <a:t>      –  </a:t>
-            </a:r>
-            <a:r>
-              <a:rPr sz="1350" b="0" i="0">
-                <a:solidFill>
-                  <a:srgbClr val="F1F5F9"/>
-                </a:solidFill>
-                <a:latin typeface="Montserrat"/>
-              </a:rPr>
-              <a:t>preenche Causa · Ação · Responsável · Prazo · Status (+ adicionar ação/causa)</a:t>
-            </a:r>
-          </a:p>
-          <a:p>
-            <a:pPr>
-              <a:spcAft>
-                <a:spcPts val="400"/>
-              </a:spcAft>
-            </a:pPr>
-            <a:r>
-              <a:rPr sz="1350" b="1" i="0">
-                <a:solidFill>
-                  <a:srgbClr val="64748B"/>
-                </a:solidFill>
-                <a:latin typeface="Montserrat"/>
-              </a:rPr>
-              <a:t>      –  </a:t>
-            </a:r>
-            <a:r>
-              <a:rPr sz="1350" b="1" i="0">
-                <a:solidFill>
-                  <a:srgbClr val="FF6666"/>
-                </a:solidFill>
-                <a:latin typeface="Montserrat"/>
-              </a:rPr>
-              <a:t>SÓ GRAVA AO CLICAR SALVAR → vai ao Supabase e TRAVA a ação (só o Acompanhamento segue editável)</a:t>
-            </a:r>
-          </a:p>
-          <a:p>
-            <a:pPr>
-              <a:spcAft>
-                <a:spcPts val="400"/>
-              </a:spcAft>
-            </a:pPr>
-            <a:r>
-              <a:rPr sz="1350" b="1" i="0">
-                <a:solidFill>
-                  <a:srgbClr val="64748B"/>
-                </a:solidFill>
-                <a:latin typeface="Montserrat"/>
-              </a:rPr>
-              <a:t>      –  </a:t>
-            </a:r>
-            <a:r>
-              <a:rPr sz="1350" b="0" i="0">
-                <a:solidFill>
-                  <a:srgbClr val="F1F5F9"/>
-                </a:solidFill>
-                <a:latin typeface="Montserrat"/>
-              </a:rPr>
-              <a:t>sair sem salvar = perde o que digitou (não há autosave)</a:t>
-            </a:r>
-          </a:p>
-          <a:p>
-            <a:pPr>
-              <a:spcAft>
-                <a:spcPts val="700"/>
-              </a:spcAft>
-            </a:pPr>
-            <a:r>
-              <a:rPr sz="1500" b="1" i="0">
-                <a:solidFill>
-                  <a:srgbClr val="F97316"/>
-                </a:solidFill>
-                <a:latin typeface="Montserrat"/>
-              </a:rPr>
-              <a:t>▪  </a:t>
-            </a:r>
-            <a:r>
-              <a:rPr sz="1500" b="0" i="0">
-                <a:solidFill>
-                  <a:srgbClr val="F1F5F9"/>
-                </a:solidFill>
-                <a:latin typeface="Montserrat"/>
-              </a:rPr>
-              <a:t>fca-consolidado/ — Admin: edita tudo, exclui, +ação/+causa, botões Gerar Custos / Gerar RPM.</a:t>
-            </a:r>
-          </a:p>
-          <a:p>
-            <a:pPr>
-              <a:spcAft>
-                <a:spcPts val="700"/>
-              </a:spcAft>
-            </a:pPr>
-            <a:r>
-              <a:rPr sz="1500" b="1" i="0">
-                <a:solidFill>
-                  <a:srgbClr val="F97316"/>
-                </a:solidFill>
-                <a:latin typeface="Montserrat"/>
-              </a:rPr>
-              <a:t>▪  </a:t>
-            </a:r>
-            <a:r>
-              <a:rPr sz="1500" b="0" i="0">
-                <a:solidFill>
-                  <a:srgbClr val="F1F5F9"/>
-                </a:solidFill>
-                <a:latin typeface="Montserrat"/>
-              </a:rPr>
-              <a:t>Visões Tabela e Kanban (Não iniciada / Em andamento / Concluída) com drag-and-drop de status.</a:t>
-            </a:r>
-          </a:p>
-          <a:p>
-            <a:pPr>
-              <a:spcAft>
-                <a:spcPts val="700"/>
-              </a:spcAft>
-            </a:pPr>
-            <a:r>
-              <a:rPr sz="1500" b="1" i="0">
-                <a:solidFill>
-                  <a:srgbClr val="F97316"/>
-                </a:solidFill>
-                <a:latin typeface="Montserrat"/>
-              </a:rPr>
-              <a:t>▪  </a:t>
-            </a:r>
-            <a:r>
-              <a:rPr sz="1500" b="0" i="0">
-                <a:solidFill>
-                  <a:srgbClr val="F1F5F9"/>
-                </a:solidFill>
-                <a:latin typeface="Montserrat"/>
-              </a:rPr>
-              <a:t>fca/ (consolidado leitura) e fca-gerencial/ (Aderência ao FCA) leem a MESMA base com as mesmas regras.</a:t>
-            </a:r>
-          </a:p>
-          <a:p>
-            <a:pPr>
-              <a:spcAft>
-                <a:spcPts val="700"/>
-              </a:spcAft>
-            </a:pPr>
-            <a:r>
-              <a:rPr sz="1500" b="1" i="0">
-                <a:solidFill>
-                  <a:srgbClr val="F97316"/>
-                </a:solidFill>
-                <a:latin typeface="Montserrat"/>
-              </a:rPr>
-              <a:t>▪  </a:t>
-            </a:r>
-            <a:r>
-              <a:rPr sz="1500" b="0" i="0">
-                <a:solidFill>
-                  <a:srgbClr val="F1F5F9"/>
-                </a:solidFill>
-                <a:latin typeface="Montserrat"/>
-              </a:rPr>
-              <a:t>Filtros padrão com “só”; vigência abre no mês mais recente; cache localStorage p/ velocidade.</a:t>
-            </a:r>
-          </a:p>
-        </p:txBody>
-      </p:sp>
-      <p:sp>
-        <p:nvSpPr>
-          <p:cNvPr id="6" name="TextBox 5"/>
+              <a:t>Cutover: o histórico foi importado uma única vez do “FCA Total” (rotina já removida da UI). A planilha FCA Total é LEGADO — não é mais fonte.</a:t>
+            </a:r>
+          </a:p>
+        </p:txBody>
+      </p:sp>
+      <p:sp>
+        <p:nvSpPr>
+          <p:cNvPr id="8" name="TextBox 7"/>
           <p:cNvSpPr txBox="1"/>
           <p:nvPr/>
         </p:nvSpPr>
@@ -3844,7 +3965,7 @@
                 </a:solidFill>
                 <a:latin typeface="Montserrat"/>
               </a:rPr>
-              <a:t>Termômetro e MPR</a:t>
+              <a:t>Módulo FCA — painéis e fluxo de preenchimento</a:t>
             </a:r>
           </a:p>
         </p:txBody>
@@ -3892,7 +4013,7 @@
                 </a:solidFill>
                 <a:latin typeface="Montserrat"/>
               </a:rPr>
-              <a:t>Termômetro (termometro/): pontuação de conformidade por unidade/tier.</a:t>
+              <a:t>fca-preenchimento/ — a unidade trata seus desvios:</a:t>
             </a:r>
           </a:p>
           <a:p>
@@ -3917,7 +4038,7 @@
                 </a:solidFill>
                 <a:latin typeface="Montserrat"/>
               </a:rPr>
-              <a:t>Fonte: planilha do termômetro — abas = tiers (Transportes T1/T2, WH T1/T2) + aba Regras</a:t>
+              <a:t>preenche Causa · Ação · Responsável · Prazo · Status (+ adicionar ação/causa)</a:t>
             </a:r>
           </a:p>
           <a:p>
@@ -3936,38 +4057,63 @@
               <a:t>      –  </a:t>
             </a:r>
             <a:r>
+              <a:rPr sz="1350" b="1" i="0">
+                <a:solidFill>
+                  <a:srgbClr val="FF6666"/>
+                </a:solidFill>
+                <a:latin typeface="Montserrat"/>
+              </a:rPr>
+              <a:t>SÓ GRAVA AO CLICAR SALVAR → vai ao Supabase e TRAVA a ação (só o Acompanhamento segue editável)</a:t>
+            </a:r>
+          </a:p>
+          <a:p>
+            <a:pPr>
+              <a:spcAft>
+                <a:spcPts val="400"/>
+              </a:spcAft>
+            </a:pPr>
+            <a:r>
+              <a:rPr sz="1350" b="1" i="0">
+                <a:solidFill>
+                  <a:srgbClr val="64748B"/>
+                </a:solidFill>
+                <a:latin typeface="Montserrat"/>
+              </a:rPr>
+              <a:t>      –  </a:t>
+            </a:r>
+            <a:r>
               <a:rPr sz="1350" b="0" i="0">
                 <a:solidFill>
                   <a:srgbClr val="F1F5F9"/>
                 </a:solidFill>
                 <a:latin typeface="Montserrat"/>
               </a:rPr>
-              <a:t>Vigência quinzenal (M_Q); FILTRO é por mês e a Q2 REGE (fallback Q1 se o mês não fechou)</a:t>
-            </a:r>
-          </a:p>
-          <a:p>
-            <a:pPr>
-              <a:spcAft>
-                <a:spcPts val="400"/>
-              </a:spcAft>
-            </a:pPr>
-            <a:r>
-              <a:rPr sz="1350" b="1" i="0">
-                <a:solidFill>
-                  <a:srgbClr val="64748B"/>
-                </a:solidFill>
-                <a:latin typeface="Montserrat"/>
-              </a:rPr>
-              <a:t>      –  </a:t>
-            </a:r>
-            <a:r>
-              <a:rPr sz="1350" b="0" i="0">
+              <a:t>sair sem salvar = perde o que digitou (não há autosave)</a:t>
+            </a:r>
+          </a:p>
+          <a:p>
+            <a:pPr>
+              <a:spcAft>
+                <a:spcPts val="700"/>
+              </a:spcAft>
+            </a:pPr>
+            <a:r>
+              <a:rPr sz="1500" b="1" i="0">
+                <a:solidFill>
+                  <a:srgbClr val="F97316"/>
+                </a:solidFill>
+                <a:latin typeface="Montserrat"/>
+              </a:rPr>
+              <a:t>▪  </a:t>
+            </a:r>
+            <a:r>
+              <a:rPr sz="1500" b="0" i="0">
                 <a:solidFill>
                   <a:srgbClr val="F1F5F9"/>
                 </a:solidFill>
                 <a:latin typeface="Montserrat"/>
               </a:rPr>
-              <a:t>Gráfico temporal mostra as 2 quinzenas — Q1 com preenchimento hachurado</a:t>
+              <a:t>fca-consolidado/ — Admin: edita tudo, exclui, +ação/+causa, botões Gerar Custos / Gerar RPM.</a:t>
             </a:r>
           </a:p>
           <a:p>
@@ -3986,138 +4132,63 @@
               <a:t>▪  </a:t>
             </a:r>
             <a:r>
+              <a:rPr sz="1500" b="0" i="0">
+                <a:solidFill>
+                  <a:srgbClr val="F1F5F9"/>
+                </a:solidFill>
+                <a:latin typeface="Montserrat"/>
+              </a:rPr>
+              <a:t>Visões Tabela e Kanban (Não iniciada / Em andamento / Concluída) com drag-and-drop de status.</a:t>
+            </a:r>
+          </a:p>
+          <a:p>
+            <a:pPr>
+              <a:spcAft>
+                <a:spcPts val="700"/>
+              </a:spcAft>
+            </a:pPr>
+            <a:r>
               <a:rPr sz="1500" b="1" i="0">
                 <a:solidFill>
                   <a:srgbClr val="F97316"/>
                 </a:solidFill>
                 <a:latin typeface="Montserrat"/>
               </a:rPr>
-              <a:t>MPR (mpr/): Monthly Performance Review — matriz indicador × GEO/unidade.</a:t>
-            </a:r>
-          </a:p>
-          <a:p>
-            <a:pPr>
-              <a:spcAft>
-                <a:spcPts val="400"/>
-              </a:spcAft>
-            </a:pPr>
-            <a:r>
-              <a:rPr sz="1350" b="1" i="0">
-                <a:solidFill>
-                  <a:srgbClr val="64748B"/>
-                </a:solidFill>
-                <a:latin typeface="Montserrat"/>
-              </a:rPr>
-              <a:t>      –  </a:t>
-            </a:r>
-            <a:r>
-              <a:rPr sz="1350" b="0" i="0">
+              <a:t>▪  </a:t>
+            </a:r>
+            <a:r>
+              <a:rPr sz="1500" b="0" i="0">
                 <a:solidFill>
                   <a:srgbClr val="F1F5F9"/>
                 </a:solidFill>
                 <a:latin typeface="Montserrat"/>
               </a:rPr>
-              <a:t>GEO agrupa unidades (expande no “+”) · linhas 2025 (vazio) e 2026 · coluna Plan = meta da regra</a:t>
-            </a:r>
-          </a:p>
-          <a:p>
-            <a:pPr>
-              <a:spcAft>
-                <a:spcPts val="400"/>
-              </a:spcAft>
-            </a:pPr>
-            <a:r>
-              <a:rPr sz="1350" b="1" i="0">
-                <a:solidFill>
-                  <a:srgbClr val="64748B"/>
-                </a:solidFill>
-                <a:latin typeface="Montserrat"/>
-              </a:rPr>
-              <a:t>      –  </a:t>
-            </a:r>
-            <a:r>
-              <a:rPr sz="1350" b="0" i="0">
+              <a:t>fca/ (consolidado leitura) e fca-gerencial/ (Aderência ao FCA) leem a MESMA base com as mesmas regras.</a:t>
+            </a:r>
+          </a:p>
+          <a:p>
+            <a:pPr>
+              <a:spcAft>
+                <a:spcPts val="700"/>
+              </a:spcAft>
+            </a:pPr>
+            <a:r>
+              <a:rPr sz="1500" b="1" i="0">
+                <a:solidFill>
+                  <a:srgbClr val="F97316"/>
+                </a:solidFill>
+                <a:latin typeface="Montserrat"/>
+              </a:rPr>
+              <a:t>▪  </a:t>
+            </a:r>
+            <a:r>
+              <a:rPr sz="1500" b="0" i="0">
                 <a:solidFill>
                   <a:srgbClr val="F1F5F9"/>
                 </a:solidFill>
                 <a:latin typeface="Montserrat"/>
               </a:rPr>
-              <a:t>Valor do mês = resultado da Q2 · cores = REGRAS do indicador (ex.: Preventiva ≥95 verde/≥90 amarelo)</a:t>
-            </a:r>
-          </a:p>
-          <a:p>
-            <a:pPr>
-              <a:spcAft>
-                <a:spcPts val="400"/>
-              </a:spcAft>
-            </a:pPr>
-            <a:r>
-              <a:rPr sz="1350" b="1" i="0">
-                <a:solidFill>
-                  <a:srgbClr val="64748B"/>
-                </a:solidFill>
-                <a:latin typeface="Montserrat"/>
-              </a:rPr>
-              <a:t>      –  </a:t>
-            </a:r>
-            <a:r>
-              <a:rPr sz="1350" b="0" i="0">
-                <a:solidFill>
-                  <a:srgbClr val="F1F5F9"/>
-                </a:solidFill>
-                <a:latin typeface="Montserrat"/>
-              </a:rPr>
-              <a:t>MTTR/MTBF (regra de quartil) coloridos pela pontuação do termômetro · YTD em pill</a:t>
-            </a:r>
-          </a:p>
-          <a:p>
-            <a:pPr>
-              <a:spcAft>
-                <a:spcPts val="400"/>
-              </a:spcAft>
-            </a:pPr>
-            <a:r>
-              <a:rPr sz="1350" b="1" i="0">
-                <a:solidFill>
-                  <a:srgbClr val="64748B"/>
-                </a:solidFill>
-                <a:latin typeface="Montserrat"/>
-              </a:rPr>
-              <a:t>      –  </a:t>
-            </a:r>
-            <a:r>
-              <a:rPr sz="1350" b="1" i="0">
-                <a:solidFill>
-                  <a:srgbClr val="EAB308"/>
-                </a:solidFill>
-                <a:latin typeface="Montserrat"/>
-              </a:rPr>
-              <a:t>Causa/Ação/Responsável/Prazo = campos livres em localStorage (POR NAVEGADOR — não compartilhado)</a:t>
-            </a:r>
-          </a:p>
-          <a:p>
-            <a:pPr>
-              <a:spcAft>
-                <a:spcPts val="700"/>
-              </a:spcAft>
-            </a:pPr>
-            <a:r>
-              <a:rPr sz="1500" b="1" i="0">
-                <a:solidFill>
-                  <a:srgbClr val="F97316"/>
-                </a:solidFill>
-                <a:latin typeface="Montserrat"/>
-              </a:rPr>
-              <a:t>▪  </a:t>
-            </a:r>
-            <a:r>
-              <a:rPr sz="1500" b="0" i="0">
-                <a:solidFill>
-                  <a:srgbClr val="F1F5F9"/>
-                </a:solidFill>
-                <a:latin typeface="Montserrat"/>
-              </a:rPr>
-              <a:t>Evolução natural: migrar os campos do MPR p/ Supabase (mesmo modelo do FCA) p/ compartilhar entre máquinas.</a:t>
+              <a:t>Filtros padrão com “só”; vigência abre no mês mais recente; cache localStorage p/ velocidade.</a:t>
             </a:r>
           </a:p>
         </p:txBody>
@@ -4309,6 +4380,471 @@
                 </a:solidFill>
                 <a:latin typeface="Montserrat"/>
               </a:rPr>
+              <a:t>Termômetro e MPR</a:t>
+            </a:r>
+          </a:p>
+        </p:txBody>
+      </p:sp>
+      <p:sp>
+        <p:nvSpPr>
+          <p:cNvPr id="5" name="TextBox 4"/>
+          <p:cNvSpPr txBox="1"/>
+          <p:nvPr/>
+        </p:nvSpPr>
+        <p:spPr>
+          <a:xfrm>
+            <a:off x="548640" y="1417320"/>
+            <a:ext cx="11064240" cy="5120640"/>
+          </a:xfrm>
+          <a:prstGeom prst="rect">
+            <a:avLst/>
+          </a:prstGeom>
+          <a:noFill/>
+        </p:spPr>
+        <p:txBody>
+          <a:bodyPr wrap="square">
+            <a:spAutoFit/>
+          </a:bodyPr>
+          <a:lstStyle/>
+          <a:p>
+            <a:pPr>
+              <a:spcAft>
+                <a:spcPts val="700"/>
+              </a:spcAft>
+            </a:pPr>
+            <a:r>
+              <a:rPr sz="1500" b="1" i="0">
+                <a:solidFill>
+                  <a:srgbClr val="F97316"/>
+                </a:solidFill>
+                <a:latin typeface="Montserrat"/>
+              </a:rPr>
+              <a:t>▪  </a:t>
+            </a:r>
+            <a:r>
+              <a:rPr sz="1500" b="1" i="0">
+                <a:solidFill>
+                  <a:srgbClr val="F97316"/>
+                </a:solidFill>
+                <a:latin typeface="Montserrat"/>
+              </a:rPr>
+              <a:t>Termômetro (termometro/): pontuação de conformidade por unidade/tier.</a:t>
+            </a:r>
+          </a:p>
+          <a:p>
+            <a:pPr>
+              <a:spcAft>
+                <a:spcPts val="400"/>
+              </a:spcAft>
+            </a:pPr>
+            <a:r>
+              <a:rPr sz="1350" b="1" i="0">
+                <a:solidFill>
+                  <a:srgbClr val="64748B"/>
+                </a:solidFill>
+                <a:latin typeface="Montserrat"/>
+              </a:rPr>
+              <a:t>      –  </a:t>
+            </a:r>
+            <a:r>
+              <a:rPr sz="1350" b="0" i="0">
+                <a:solidFill>
+                  <a:srgbClr val="F1F5F9"/>
+                </a:solidFill>
+                <a:latin typeface="Montserrat"/>
+              </a:rPr>
+              <a:t>Fonte: planilha do termômetro — abas = tiers (Transportes T1/T2, WH T1/T2) + aba Regras</a:t>
+            </a:r>
+          </a:p>
+          <a:p>
+            <a:pPr>
+              <a:spcAft>
+                <a:spcPts val="400"/>
+              </a:spcAft>
+            </a:pPr>
+            <a:r>
+              <a:rPr sz="1350" b="1" i="0">
+                <a:solidFill>
+                  <a:srgbClr val="64748B"/>
+                </a:solidFill>
+                <a:latin typeface="Montserrat"/>
+              </a:rPr>
+              <a:t>      –  </a:t>
+            </a:r>
+            <a:r>
+              <a:rPr sz="1350" b="0" i="0">
+                <a:solidFill>
+                  <a:srgbClr val="F1F5F9"/>
+                </a:solidFill>
+                <a:latin typeface="Montserrat"/>
+              </a:rPr>
+              <a:t>Vigência quinzenal (M_Q); FILTRO é por mês e a Q2 REGE (fallback Q1 se o mês não fechou)</a:t>
+            </a:r>
+          </a:p>
+          <a:p>
+            <a:pPr>
+              <a:spcAft>
+                <a:spcPts val="400"/>
+              </a:spcAft>
+            </a:pPr>
+            <a:r>
+              <a:rPr sz="1350" b="1" i="0">
+                <a:solidFill>
+                  <a:srgbClr val="64748B"/>
+                </a:solidFill>
+                <a:latin typeface="Montserrat"/>
+              </a:rPr>
+              <a:t>      –  </a:t>
+            </a:r>
+            <a:r>
+              <a:rPr sz="1350" b="0" i="0">
+                <a:solidFill>
+                  <a:srgbClr val="F1F5F9"/>
+                </a:solidFill>
+                <a:latin typeface="Montserrat"/>
+              </a:rPr>
+              <a:t>Gráfico temporal mostra as 2 quinzenas — Q1 com preenchimento hachurado</a:t>
+            </a:r>
+          </a:p>
+          <a:p>
+            <a:pPr>
+              <a:spcAft>
+                <a:spcPts val="700"/>
+              </a:spcAft>
+            </a:pPr>
+            <a:r>
+              <a:rPr sz="1500" b="1" i="0">
+                <a:solidFill>
+                  <a:srgbClr val="F97316"/>
+                </a:solidFill>
+                <a:latin typeface="Montserrat"/>
+              </a:rPr>
+              <a:t>▪  </a:t>
+            </a:r>
+            <a:r>
+              <a:rPr sz="1500" b="1" i="0">
+                <a:solidFill>
+                  <a:srgbClr val="F97316"/>
+                </a:solidFill>
+                <a:latin typeface="Montserrat"/>
+              </a:rPr>
+              <a:t>MPR (mpr/): Monthly Performance Review — matriz indicador × GEO/unidade.</a:t>
+            </a:r>
+          </a:p>
+          <a:p>
+            <a:pPr>
+              <a:spcAft>
+                <a:spcPts val="400"/>
+              </a:spcAft>
+            </a:pPr>
+            <a:r>
+              <a:rPr sz="1350" b="1" i="0">
+                <a:solidFill>
+                  <a:srgbClr val="64748B"/>
+                </a:solidFill>
+                <a:latin typeface="Montserrat"/>
+              </a:rPr>
+              <a:t>      –  </a:t>
+            </a:r>
+            <a:r>
+              <a:rPr sz="1350" b="0" i="0">
+                <a:solidFill>
+                  <a:srgbClr val="F1F5F9"/>
+                </a:solidFill>
+                <a:latin typeface="Montserrat"/>
+              </a:rPr>
+              <a:t>GEO agrupa unidades (expande no “+”) · linhas 2025 (vazio) e 2026 · coluna Plan = meta da regra</a:t>
+            </a:r>
+          </a:p>
+          <a:p>
+            <a:pPr>
+              <a:spcAft>
+                <a:spcPts val="400"/>
+              </a:spcAft>
+            </a:pPr>
+            <a:r>
+              <a:rPr sz="1350" b="1" i="0">
+                <a:solidFill>
+                  <a:srgbClr val="64748B"/>
+                </a:solidFill>
+                <a:latin typeface="Montserrat"/>
+              </a:rPr>
+              <a:t>      –  </a:t>
+            </a:r>
+            <a:r>
+              <a:rPr sz="1350" b="0" i="0">
+                <a:solidFill>
+                  <a:srgbClr val="F1F5F9"/>
+                </a:solidFill>
+                <a:latin typeface="Montserrat"/>
+              </a:rPr>
+              <a:t>Valor do mês = resultado da Q2 · cores = REGRAS do indicador (ex.: Preventiva ≥95 verde/≥90 amarelo)</a:t>
+            </a:r>
+          </a:p>
+          <a:p>
+            <a:pPr>
+              <a:spcAft>
+                <a:spcPts val="400"/>
+              </a:spcAft>
+            </a:pPr>
+            <a:r>
+              <a:rPr sz="1350" b="1" i="0">
+                <a:solidFill>
+                  <a:srgbClr val="64748B"/>
+                </a:solidFill>
+                <a:latin typeface="Montserrat"/>
+              </a:rPr>
+              <a:t>      –  </a:t>
+            </a:r>
+            <a:r>
+              <a:rPr sz="1350" b="0" i="0">
+                <a:solidFill>
+                  <a:srgbClr val="F1F5F9"/>
+                </a:solidFill>
+                <a:latin typeface="Montserrat"/>
+              </a:rPr>
+              <a:t>MTTR/MTBF (regra de quartil) coloridos pela pontuação do termômetro · YTD em pill</a:t>
+            </a:r>
+          </a:p>
+          <a:p>
+            <a:pPr>
+              <a:spcAft>
+                <a:spcPts val="400"/>
+              </a:spcAft>
+            </a:pPr>
+            <a:r>
+              <a:rPr sz="1350" b="1" i="0">
+                <a:solidFill>
+                  <a:srgbClr val="64748B"/>
+                </a:solidFill>
+                <a:latin typeface="Montserrat"/>
+              </a:rPr>
+              <a:t>      –  </a:t>
+            </a:r>
+            <a:r>
+              <a:rPr sz="1350" b="1" i="0">
+                <a:solidFill>
+                  <a:srgbClr val="EAB308"/>
+                </a:solidFill>
+                <a:latin typeface="Montserrat"/>
+              </a:rPr>
+              <a:t>Causa/Ação/Responsável/Prazo = campos livres em localStorage (POR NAVEGADOR — não compartilhado)</a:t>
+            </a:r>
+          </a:p>
+          <a:p>
+            <a:pPr>
+              <a:spcAft>
+                <a:spcPts val="700"/>
+              </a:spcAft>
+            </a:pPr>
+            <a:r>
+              <a:rPr sz="1500" b="1" i="0">
+                <a:solidFill>
+                  <a:srgbClr val="F97316"/>
+                </a:solidFill>
+                <a:latin typeface="Montserrat"/>
+              </a:rPr>
+              <a:t>▪  </a:t>
+            </a:r>
+            <a:r>
+              <a:rPr sz="1500" b="0" i="0">
+                <a:solidFill>
+                  <a:srgbClr val="F1F5F9"/>
+                </a:solidFill>
+                <a:latin typeface="Montserrat"/>
+              </a:rPr>
+              <a:t>Evolução natural: migrar os campos do MPR p/ Supabase (mesmo modelo do FCA) p/ compartilhar entre máquinas.</a:t>
+            </a:r>
+          </a:p>
+        </p:txBody>
+      </p:sp>
+      <p:sp>
+        <p:nvSpPr>
+          <p:cNvPr id="6" name="TextBox 5"/>
+          <p:cNvSpPr txBox="1"/>
+          <p:nvPr/>
+        </p:nvSpPr>
+        <p:spPr>
+          <a:xfrm>
+            <a:off x="548640" y="6473952"/>
+            <a:ext cx="11064240" cy="320040"/>
+          </a:xfrm>
+          <a:prstGeom prst="rect">
+            <a:avLst/>
+          </a:prstGeom>
+          <a:noFill/>
+        </p:spPr>
+        <p:txBody>
+          <a:bodyPr wrap="square">
+            <a:spAutoFit/>
+          </a:bodyPr>
+          <a:lstStyle/>
+          <a:p>
+            <a:pPr algn="r"/>
+            <a:r>
+              <a:rPr sz="900" b="0" i="0">
+                <a:solidFill>
+                  <a:srgbClr val="64748B"/>
+                </a:solidFill>
+                <a:latin typeface="Montserrat"/>
+              </a:rPr>
+              <a:t>Handoff Técnico — TI  ·  12</a:t>
+            </a:r>
+          </a:p>
+        </p:txBody>
+      </p:sp>
+    </p:spTree>
+  </p:cSld>
+  <p:clrMapOvr>
+    <a:masterClrMapping/>
+  </p:clrMapOvr>
+</p:sld>
+</file>
+
+<file path=ppt/slides/slide13.xml><?xml version="1.0" encoding="utf-8"?>
+<p:sld xmlns:a="http://schemas.openxmlformats.org/drawingml/2006/main" xmlns:p="http://schemas.openxmlformats.org/presentationml/2006/main" xmlns:r="http://schemas.openxmlformats.org/officeDocument/2006/relationships">
+  <p:cSld>
+    <p:bg>
+      <p:bgPr>
+        <a:solidFill>
+          <a:srgbClr val="0C1017"/>
+        </a:solidFill>
+        <a:effectLst/>
+      </p:bgPr>
+    </p:bg>
+    <p:spTree>
+      <p:nvGrpSpPr>
+        <p:cNvPr id="1" name=""/>
+        <p:cNvGrpSpPr/>
+        <p:nvPr/>
+      </p:nvGrpSpPr>
+      <p:grpSpPr/>
+      <p:sp>
+        <p:nvSpPr>
+          <p:cNvPr id="2" name="Rectangle 1"/>
+          <p:cNvSpPr/>
+          <p:nvPr/>
+        </p:nvSpPr>
+        <p:spPr>
+          <a:xfrm>
+            <a:off x="0" y="0"/>
+            <a:ext cx="12191695" cy="1170432"/>
+          </a:xfrm>
+          <a:prstGeom prst="rect">
+            <a:avLst/>
+          </a:prstGeom>
+          <a:solidFill>
+            <a:srgbClr val="141B26"/>
+          </a:solidFill>
+          <a:ln>
+            <a:noFill/>
+          </a:ln>
+        </p:spPr>
+        <p:style>
+          <a:lnRef idx="1">
+            <a:schemeClr val="accent1"/>
+          </a:lnRef>
+          <a:fillRef idx="3">
+            <a:schemeClr val="accent1"/>
+          </a:fillRef>
+          <a:effectRef idx="2">
+            <a:schemeClr val="accent1"/>
+          </a:effectRef>
+          <a:fontRef idx="minor">
+            <a:schemeClr val="lt1"/>
+          </a:fontRef>
+        </p:style>
+        <p:txBody>
+          <a:bodyPr rtlCol="0" anchor="ctr"/>
+          <a:lstStyle/>
+          <a:p>
+            <a:pPr algn="ctr"/>
+          </a:p>
+        </p:txBody>
+      </p:sp>
+      <p:sp>
+        <p:nvSpPr>
+          <p:cNvPr id="3" name="Rectangle 2"/>
+          <p:cNvSpPr/>
+          <p:nvPr/>
+        </p:nvSpPr>
+        <p:spPr>
+          <a:xfrm>
+            <a:off x="0" y="1170432"/>
+            <a:ext cx="12191695" cy="27940"/>
+          </a:xfrm>
+          <a:prstGeom prst="rect">
+            <a:avLst/>
+          </a:prstGeom>
+          <a:solidFill>
+            <a:srgbClr val="F97316"/>
+          </a:solidFill>
+          <a:ln>
+            <a:noFill/>
+          </a:ln>
+        </p:spPr>
+        <p:style>
+          <a:lnRef idx="1">
+            <a:schemeClr val="accent1"/>
+          </a:lnRef>
+          <a:fillRef idx="3">
+            <a:schemeClr val="accent1"/>
+          </a:fillRef>
+          <a:effectRef idx="2">
+            <a:schemeClr val="accent1"/>
+          </a:effectRef>
+          <a:fontRef idx="minor">
+            <a:schemeClr val="lt1"/>
+          </a:fontRef>
+        </p:style>
+        <p:txBody>
+          <a:bodyPr rtlCol="0" anchor="ctr"/>
+          <a:lstStyle/>
+          <a:p>
+            <a:pPr algn="ctr"/>
+          </a:p>
+        </p:txBody>
+      </p:sp>
+      <p:sp>
+        <p:nvSpPr>
+          <p:cNvPr id="4" name="TextBox 3"/>
+          <p:cNvSpPr txBox="1"/>
+          <p:nvPr/>
+        </p:nvSpPr>
+        <p:spPr>
+          <a:xfrm>
+            <a:off x="548640" y="109728"/>
+            <a:ext cx="11064240" cy="1005840"/>
+          </a:xfrm>
+          <a:prstGeom prst="rect">
+            <a:avLst/>
+          </a:prstGeom>
+          <a:noFill/>
+        </p:spPr>
+        <p:txBody>
+          <a:bodyPr wrap="square">
+            <a:spAutoFit/>
+          </a:bodyPr>
+          <a:lstStyle/>
+          <a:p>
+            <a:r>
+              <a:rPr sz="1000" b="1" i="0">
+                <a:solidFill>
+                  <a:srgbClr val="64748B"/>
+                </a:solidFill>
+                <a:latin typeface="Montserrat"/>
+              </a:rPr>
+              <a:t>GESTÃO EM MOVIMENTO · BI FROTA</a:t>
+            </a:r>
+          </a:p>
+          <a:p>
+            <a:r>
+              <a:rPr sz="2600" b="1" i="0">
+                <a:solidFill>
+                  <a:srgbClr val="F97316"/>
+                </a:solidFill>
+                <a:latin typeface="Montserrat"/>
+              </a:rPr>
               <a:t>Design system (resumo — íntegra no CLAUDE.md)</a:t>
             </a:r>
           </a:p>
@@ -4841,7 +5377,7 @@
                 </a:solidFill>
                 <a:latin typeface="Montserrat"/>
               </a:rPr>
-              <a:t>Handoff Técnico — TI  ·  12</a:t>
+              <a:t>Handoff Técnico — TI  ·  13</a:t>
             </a:r>
           </a:p>
         </p:txBody>
@@ -4854,7 +5390,7 @@
 </p:sld>
 </file>
 
-<file path=ppt/slides/slide13.xml><?xml version="1.0" encoding="utf-8"?>
+<file path=ppt/slides/slide14.xml><?xml version="1.0" encoding="utf-8"?>
 <p:sld xmlns:a="http://schemas.openxmlformats.org/drawingml/2006/main" xmlns:p="http://schemas.openxmlformats.org/presentationml/2006/main" xmlns:r="http://schemas.openxmlformats.org/officeDocument/2006/relationships">
   <p:cSld>
     <p:bg>
@@ -5381,446 +5917,6 @@
                 </a:solidFill>
                 <a:latin typeface="Montserrat"/>
               </a:rPr>
-              <a:t>Handoff Técnico — TI  ·  13</a:t>
-            </a:r>
-          </a:p>
-        </p:txBody>
-      </p:sp>
-    </p:spTree>
-  </p:cSld>
-  <p:clrMapOvr>
-    <a:masterClrMapping/>
-  </p:clrMapOvr>
-</p:sld>
-</file>
-
-<file path=ppt/slides/slide14.xml><?xml version="1.0" encoding="utf-8"?>
-<p:sld xmlns:a="http://schemas.openxmlformats.org/drawingml/2006/main" xmlns:p="http://schemas.openxmlformats.org/presentationml/2006/main" xmlns:r="http://schemas.openxmlformats.org/officeDocument/2006/relationships">
-  <p:cSld>
-    <p:bg>
-      <p:bgPr>
-        <a:solidFill>
-          <a:srgbClr val="0C1017"/>
-        </a:solidFill>
-        <a:effectLst/>
-      </p:bgPr>
-    </p:bg>
-    <p:spTree>
-      <p:nvGrpSpPr>
-        <p:cNvPr id="1" name=""/>
-        <p:cNvGrpSpPr/>
-        <p:nvPr/>
-      </p:nvGrpSpPr>
-      <p:grpSpPr/>
-      <p:sp>
-        <p:nvSpPr>
-          <p:cNvPr id="2" name="Rectangle 1"/>
-          <p:cNvSpPr/>
-          <p:nvPr/>
-        </p:nvSpPr>
-        <p:spPr>
-          <a:xfrm>
-            <a:off x="0" y="0"/>
-            <a:ext cx="12191695" cy="1170432"/>
-          </a:xfrm>
-          <a:prstGeom prst="rect">
-            <a:avLst/>
-          </a:prstGeom>
-          <a:solidFill>
-            <a:srgbClr val="141B26"/>
-          </a:solidFill>
-          <a:ln>
-            <a:noFill/>
-          </a:ln>
-        </p:spPr>
-        <p:style>
-          <a:lnRef idx="1">
-            <a:schemeClr val="accent1"/>
-          </a:lnRef>
-          <a:fillRef idx="3">
-            <a:schemeClr val="accent1"/>
-          </a:fillRef>
-          <a:effectRef idx="2">
-            <a:schemeClr val="accent1"/>
-          </a:effectRef>
-          <a:fontRef idx="minor">
-            <a:schemeClr val="lt1"/>
-          </a:fontRef>
-        </p:style>
-        <p:txBody>
-          <a:bodyPr rtlCol="0" anchor="ctr"/>
-          <a:lstStyle/>
-          <a:p>
-            <a:pPr algn="ctr"/>
-          </a:p>
-        </p:txBody>
-      </p:sp>
-      <p:sp>
-        <p:nvSpPr>
-          <p:cNvPr id="3" name="Rectangle 2"/>
-          <p:cNvSpPr/>
-          <p:nvPr/>
-        </p:nvSpPr>
-        <p:spPr>
-          <a:xfrm>
-            <a:off x="0" y="1170432"/>
-            <a:ext cx="12191695" cy="27940"/>
-          </a:xfrm>
-          <a:prstGeom prst="rect">
-            <a:avLst/>
-          </a:prstGeom>
-          <a:solidFill>
-            <a:srgbClr val="F97316"/>
-          </a:solidFill>
-          <a:ln>
-            <a:noFill/>
-          </a:ln>
-        </p:spPr>
-        <p:style>
-          <a:lnRef idx="1">
-            <a:schemeClr val="accent1"/>
-          </a:lnRef>
-          <a:fillRef idx="3">
-            <a:schemeClr val="accent1"/>
-          </a:fillRef>
-          <a:effectRef idx="2">
-            <a:schemeClr val="accent1"/>
-          </a:effectRef>
-          <a:fontRef idx="minor">
-            <a:schemeClr val="lt1"/>
-          </a:fontRef>
-        </p:style>
-        <p:txBody>
-          <a:bodyPr rtlCol="0" anchor="ctr"/>
-          <a:lstStyle/>
-          <a:p>
-            <a:pPr algn="ctr"/>
-          </a:p>
-        </p:txBody>
-      </p:sp>
-      <p:sp>
-        <p:nvSpPr>
-          <p:cNvPr id="4" name="TextBox 3"/>
-          <p:cNvSpPr txBox="1"/>
-          <p:nvPr/>
-        </p:nvSpPr>
-        <p:spPr>
-          <a:xfrm>
-            <a:off x="548640" y="109728"/>
-            <a:ext cx="11064240" cy="1005840"/>
-          </a:xfrm>
-          <a:prstGeom prst="rect">
-            <a:avLst/>
-          </a:prstGeom>
-          <a:noFill/>
-        </p:spPr>
-        <p:txBody>
-          <a:bodyPr wrap="square">
-            <a:spAutoFit/>
-          </a:bodyPr>
-          <a:lstStyle/>
-          <a:p>
-            <a:r>
-              <a:rPr sz="1000" b="1" i="0">
-                <a:solidFill>
-                  <a:srgbClr val="64748B"/>
-                </a:solidFill>
-                <a:latin typeface="Montserrat"/>
-              </a:rPr>
-              <a:t>GESTÃO EM MOVIMENTO · BI FROTA</a:t>
-            </a:r>
-          </a:p>
-          <a:p>
-            <a:r>
-              <a:rPr sz="2600" b="1" i="0">
-                <a:solidFill>
-                  <a:srgbClr val="F97316"/>
-                </a:solidFill>
-                <a:latin typeface="Montserrat"/>
-              </a:rPr>
-              <a:t>Manutenção — receitas rápidas</a:t>
-            </a:r>
-          </a:p>
-        </p:txBody>
-      </p:sp>
-      <p:sp>
-        <p:nvSpPr>
-          <p:cNvPr id="5" name="TextBox 4"/>
-          <p:cNvSpPr txBox="1"/>
-          <p:nvPr/>
-        </p:nvSpPr>
-        <p:spPr>
-          <a:xfrm>
-            <a:off x="548640" y="1417320"/>
-            <a:ext cx="11064240" cy="5120640"/>
-          </a:xfrm>
-          <a:prstGeom prst="rect">
-            <a:avLst/>
-          </a:prstGeom>
-          <a:noFill/>
-        </p:spPr>
-        <p:txBody>
-          <a:bodyPr wrap="square">
-            <a:spAutoFit/>
-          </a:bodyPr>
-          <a:lstStyle/>
-          <a:p>
-            <a:pPr>
-              <a:spcAft>
-                <a:spcPts val="700"/>
-              </a:spcAft>
-            </a:pPr>
-            <a:r>
-              <a:rPr sz="1500" b="1" i="0">
-                <a:solidFill>
-                  <a:srgbClr val="F97316"/>
-                </a:solidFill>
-                <a:latin typeface="Montserrat"/>
-              </a:rPr>
-              <a:t>▪  </a:t>
-            </a:r>
-            <a:r>
-              <a:rPr sz="1500" b="1" i="0">
-                <a:solidFill>
-                  <a:srgbClr val="F97316"/>
-                </a:solidFill>
-                <a:latin typeface="Montserrat"/>
-              </a:rPr>
-              <a:t>Criar um painel novo:</a:t>
-            </a:r>
-          </a:p>
-          <a:p>
-            <a:pPr>
-              <a:spcAft>
-                <a:spcPts val="400"/>
-              </a:spcAft>
-            </a:pPr>
-            <a:r>
-              <a:rPr sz="1350" b="1" i="0">
-                <a:solidFill>
-                  <a:srgbClr val="64748B"/>
-                </a:solidFill>
-                <a:latin typeface="Montserrat"/>
-              </a:rPr>
-              <a:t>      –  </a:t>
-            </a:r>
-            <a:r>
-              <a:rPr sz="1350" b="0" i="0">
-                <a:solidFill>
-                  <a:srgbClr val="F1F5F9"/>
-                </a:solidFill>
-                <a:latin typeface="Montserrat"/>
-              </a:rPr>
-              <a:t>copiar visao-financeira/index.html (ou _template/) p/ nova pasta · ajustar título/fonte de dados</a:t>
-            </a:r>
-          </a:p>
-          <a:p>
-            <a:pPr>
-              <a:spcAft>
-                <a:spcPts val="400"/>
-              </a:spcAft>
-            </a:pPr>
-            <a:r>
-              <a:rPr sz="1350" b="1" i="0">
-                <a:solidFill>
-                  <a:srgbClr val="64748B"/>
-                </a:solidFill>
-                <a:latin typeface="Montserrat"/>
-              </a:rPr>
-              <a:t>      –  </a:t>
-            </a:r>
-            <a:r>
-              <a:rPr sz="1350" b="0" i="0">
-                <a:solidFill>
-                  <a:srgbClr val="F1F5F9"/>
-                </a:solidFill>
-                <a:latin typeface="Montserrat"/>
-              </a:rPr>
-              <a:t>adicionar o card no hub (index.html raiz, cluster certo) · push em main</a:t>
-            </a:r>
-          </a:p>
-          <a:p>
-            <a:pPr>
-              <a:spcAft>
-                <a:spcPts val="700"/>
-              </a:spcAft>
-            </a:pPr>
-            <a:r>
-              <a:rPr sz="1500" b="1" i="0">
-                <a:solidFill>
-                  <a:srgbClr val="F97316"/>
-                </a:solidFill>
-                <a:latin typeface="Montserrat"/>
-              </a:rPr>
-              <a:t>▪  </a:t>
-            </a:r>
-            <a:r>
-              <a:rPr sz="1500" b="0" i="0">
-                <a:solidFill>
-                  <a:srgbClr val="F1F5F9"/>
-                </a:solidFill>
-                <a:latin typeface="Montserrat"/>
-              </a:rPr>
-              <a:t>Virada de mês (FCA): admin clica Gerar Custos + Gerar RPM. Aditivo — sem risco de duplicar.</a:t>
-            </a:r>
-          </a:p>
-          <a:p>
-            <a:pPr>
-              <a:spcAft>
-                <a:spcPts val="700"/>
-              </a:spcAft>
-            </a:pPr>
-            <a:r>
-              <a:rPr sz="1500" b="1" i="0">
-                <a:solidFill>
-                  <a:srgbClr val="F97316"/>
-                </a:solidFill>
-                <a:latin typeface="Montserrat"/>
-              </a:rPr>
-              <a:t>▪  </a:t>
-            </a:r>
-            <a:r>
-              <a:rPr sz="1500" b="0" i="0">
-                <a:solidFill>
-                  <a:srgbClr val="F1F5F9"/>
-                </a:solidFill>
-                <a:latin typeface="Montserrat"/>
-              </a:rPr>
-              <a:t>Novo usuário: cadastro no hub → admin aprova em Gerenciar Acessos → definir unidade/is_admin.</a:t>
-            </a:r>
-          </a:p>
-          <a:p>
-            <a:pPr>
-              <a:spcAft>
-                <a:spcPts val="700"/>
-              </a:spcAft>
-            </a:pPr>
-            <a:r>
-              <a:rPr sz="1500" b="1" i="0">
-                <a:solidFill>
-                  <a:srgbClr val="F97316"/>
-                </a:solidFill>
-                <a:latin typeface="Montserrat"/>
-              </a:rPr>
-              <a:t>▪  </a:t>
-            </a:r>
-            <a:r>
-              <a:rPr sz="1500" b="0" i="0">
-                <a:solidFill>
-                  <a:srgbClr val="F1F5F9"/>
-                </a:solidFill>
-                <a:latin typeface="Montserrat"/>
-              </a:rPr>
-              <a:t>Nova unidade na RPM: incluir no RPM_UNIT_MAP (fca-preenchimento/index.html) e no DEPARA.</a:t>
-            </a:r>
-          </a:p>
-          <a:p>
-            <a:pPr>
-              <a:spcAft>
-                <a:spcPts val="700"/>
-              </a:spcAft>
-            </a:pPr>
-            <a:r>
-              <a:rPr sz="1500" b="1" i="0">
-                <a:solidFill>
-                  <a:srgbClr val="F97316"/>
-                </a:solidFill>
-                <a:latin typeface="Montserrat"/>
-              </a:rPr>
-              <a:t>▪  </a:t>
-            </a:r>
-            <a:r>
-              <a:rPr sz="1500" b="0" i="0">
-                <a:solidFill>
-                  <a:srgbClr val="F1F5F9"/>
-                </a:solidFill>
-                <a:latin typeface="Montserrat"/>
-              </a:rPr>
-              <a:t>Painel Pneus sem dados: checar execução do workflow “Pneus Loader (Conlog)” na aba Actions.</a:t>
-            </a:r>
-          </a:p>
-          <a:p>
-            <a:pPr>
-              <a:spcAft>
-                <a:spcPts val="700"/>
-              </a:spcAft>
-            </a:pPr>
-            <a:r>
-              <a:rPr sz="1500" b="1" i="0">
-                <a:solidFill>
-                  <a:srgbClr val="F97316"/>
-                </a:solidFill>
-                <a:latin typeface="Montserrat"/>
-              </a:rPr>
-              <a:t>▪  </a:t>
-            </a:r>
-            <a:r>
-              <a:rPr sz="1500" b="0" i="0">
-                <a:solidFill>
-                  <a:srgbClr val="F1F5F9"/>
-                </a:solidFill>
-                <a:latin typeface="Montserrat"/>
-              </a:rPr>
-              <a:t>Site “não atualizou”: conferir se o build do Pages concluiu + Ctrl+Shift+R.</a:t>
-            </a:r>
-          </a:p>
-          <a:p>
-            <a:pPr>
-              <a:spcAft>
-                <a:spcPts val="700"/>
-              </a:spcAft>
-            </a:pPr>
-            <a:r>
-              <a:rPr sz="1500" b="1" i="0">
-                <a:solidFill>
-                  <a:srgbClr val="F97316"/>
-                </a:solidFill>
-                <a:latin typeface="Montserrat"/>
-              </a:rPr>
-              <a:t>▪  </a:t>
-            </a:r>
-            <a:r>
-              <a:rPr sz="1500" b="0" i="0">
-                <a:solidFill>
-                  <a:srgbClr val="F1F5F9"/>
-                </a:solidFill>
-                <a:latin typeface="Montserrat"/>
-              </a:rPr>
-              <a:t>Antes de mexer no visual: ler CLAUDE.md (paleta, componentes, mobile).</a:t>
-            </a:r>
-          </a:p>
-        </p:txBody>
-      </p:sp>
-      <p:sp>
-        <p:nvSpPr>
-          <p:cNvPr id="6" name="TextBox 5"/>
-          <p:cNvSpPr txBox="1"/>
-          <p:nvPr/>
-        </p:nvSpPr>
-        <p:spPr>
-          <a:xfrm>
-            <a:off x="548640" y="6473952"/>
-            <a:ext cx="11064240" cy="320040"/>
-          </a:xfrm>
-          <a:prstGeom prst="rect">
-            <a:avLst/>
-          </a:prstGeom>
-          <a:noFill/>
-        </p:spPr>
-        <p:txBody>
-          <a:bodyPr wrap="square">
-            <a:spAutoFit/>
-          </a:bodyPr>
-          <a:lstStyle/>
-          <a:p>
-            <a:pPr algn="r"/>
-            <a:r>
-              <a:rPr sz="900" b="0" i="0">
-                <a:solidFill>
-                  <a:srgbClr val="64748B"/>
-                </a:solidFill>
-                <a:latin typeface="Montserrat"/>
-              </a:rPr>
               <a:t>Handoff Técnico — TI  ·  14</a:t>
             </a:r>
           </a:p>
@@ -5978,7 +6074,7 @@
                 </a:solidFill>
                 <a:latin typeface="Montserrat"/>
               </a:rPr>
-              <a:t>Links e rotina operacional</a:t>
+              <a:t>Manutenção — receitas rápidas</a:t>
             </a:r>
           </a:p>
         </p:txBody>
@@ -6020,13 +6116,88 @@
               <a:t>▪  </a:t>
             </a:r>
             <a:r>
+              <a:rPr sz="1500" b="1" i="0">
+                <a:solidFill>
+                  <a:srgbClr val="F97316"/>
+                </a:solidFill>
+                <a:latin typeface="Montserrat"/>
+              </a:rPr>
+              <a:t>Criar um painel novo:</a:t>
+            </a:r>
+          </a:p>
+          <a:p>
+            <a:pPr>
+              <a:spcAft>
+                <a:spcPts val="400"/>
+              </a:spcAft>
+            </a:pPr>
+            <a:r>
+              <a:rPr sz="1350" b="1" i="0">
+                <a:solidFill>
+                  <a:srgbClr val="64748B"/>
+                </a:solidFill>
+                <a:latin typeface="Montserrat"/>
+              </a:rPr>
+              <a:t>      –  </a:t>
+            </a:r>
+            <a:r>
+              <a:rPr sz="1350" b="0" i="0">
+                <a:solidFill>
+                  <a:srgbClr val="F1F5F9"/>
+                </a:solidFill>
+                <a:latin typeface="Montserrat"/>
+              </a:rPr>
+              <a:t>copiar visao-financeira/index.html (ou _template/) p/ nova pasta · ajustar título/fonte de dados</a:t>
+            </a:r>
+          </a:p>
+          <a:p>
+            <a:pPr>
+              <a:spcAft>
+                <a:spcPts val="400"/>
+              </a:spcAft>
+            </a:pPr>
+            <a:r>
+              <a:rPr sz="1350" b="1" i="0">
+                <a:solidFill>
+                  <a:srgbClr val="64748B"/>
+                </a:solidFill>
+                <a:latin typeface="Montserrat"/>
+              </a:rPr>
+              <a:t>      –  </a:t>
+            </a:r>
+            <a:r>
+              <a:rPr sz="1350" b="0" i="0">
+                <a:solidFill>
+                  <a:srgbClr val="F1F5F9"/>
+                </a:solidFill>
+                <a:latin typeface="Montserrat"/>
+              </a:rPr>
+              <a:t>adicionar o card no hub (index.html raiz, cluster certo) · push em main</a:t>
+            </a:r>
+          </a:p>
+          <a:p>
+            <a:pPr>
+              <a:spcAft>
+                <a:spcPts val="700"/>
+              </a:spcAft>
+            </a:pPr>
+            <a:r>
+              <a:rPr sz="1500" b="1" i="0">
+                <a:solidFill>
+                  <a:srgbClr val="F97316"/>
+                </a:solidFill>
+                <a:latin typeface="Montserrat"/>
+              </a:rPr>
+              <a:t>▪  </a:t>
+            </a:r>
+            <a:r>
               <a:rPr sz="1500" b="0" i="0">
                 <a:solidFill>
                   <a:srgbClr val="F1F5F9"/>
                 </a:solidFill>
                 <a:latin typeface="Montserrat"/>
               </a:rPr>
-              <a:t>Produção: https://fortesindicadores-byte.github.io/gestao-em-movimento/</a:t>
+              <a:t>Virada de mês (FCA): admin clica Gerar Custos + Gerar RPM. Aditivo — sem risco de duplicar.</a:t>
             </a:r>
           </a:p>
           <a:p>
@@ -6051,7 +6222,7 @@
                 </a:solidFill>
                 <a:latin typeface="Montserrat"/>
               </a:rPr>
-              <a:t>Repositório: github.com/fortesindicadores-byte/gestao-em-movimento</a:t>
+              <a:t>Novo usuário: cadastro no hub → admin aprova em Gerenciar Acessos → definir unidade/is_admin.</a:t>
             </a:r>
           </a:p>
           <a:p>
@@ -6076,7 +6247,7 @@
                 </a:solidFill>
                 <a:latin typeface="Montserrat"/>
               </a:rPr>
-              <a:t>Docs no repo: DOCUMENTACAO-TI.md (completo) · CLAUDE.md · PAINEIS.md · HANDOFF.md</a:t>
+              <a:t>Nova unidade na RPM: incluir no RPM_UNIT_MAP (fca-preenchimento/index.html) e no DEPARA.</a:t>
             </a:r>
           </a:p>
           <a:p>
@@ -6101,7 +6272,7 @@
                 </a:solidFill>
                 <a:latin typeface="Montserrat"/>
               </a:rPr>
-              <a:t>Supabase (auth/FCA): lozwipoeacpvplgkrxkq.supabase.co · Conlog (Pneus): ewbzeqsneeylwkxtcpme.supabase.co</a:t>
+              <a:t>Painel Pneus sem dados: checar execução do workflow “Pneus Loader (Conlog)” na aba Actions.</a:t>
             </a:r>
           </a:p>
           <a:p>
@@ -6120,138 +6291,38 @@
               <a:t>▪  </a:t>
             </a:r>
             <a:r>
+              <a:rPr sz="1500" b="0" i="0">
+                <a:solidFill>
+                  <a:srgbClr val="F1F5F9"/>
+                </a:solidFill>
+                <a:latin typeface="Montserrat"/>
+              </a:rPr>
+              <a:t>Site “não atualizou”: conferir se o build do Pages concluiu + Ctrl+Shift+R.</a:t>
+            </a:r>
+          </a:p>
+          <a:p>
+            <a:pPr>
+              <a:spcAft>
+                <a:spcPts val="700"/>
+              </a:spcAft>
+            </a:pPr>
+            <a:r>
               <a:rPr sz="1500" b="1" i="0">
                 <a:solidFill>
                   <a:srgbClr val="F97316"/>
                 </a:solidFill>
                 <a:latin typeface="Montserrat"/>
               </a:rPr>
-              <a:t>Rotina mensal em 5 passos:</a:t>
-            </a:r>
-          </a:p>
-          <a:p>
-            <a:pPr>
-              <a:spcAft>
-                <a:spcPts val="400"/>
-              </a:spcAft>
-            </a:pPr>
-            <a:r>
-              <a:rPr sz="1350" b="1" i="0">
-                <a:solidFill>
-                  <a:srgbClr val="64748B"/>
-                </a:solidFill>
-                <a:latin typeface="Montserrat"/>
-              </a:rPr>
-              <a:t>      –  </a:t>
-            </a:r>
-            <a:r>
-              <a:rPr sz="1350" b="0" i="0">
+              <a:t>▪  </a:t>
+            </a:r>
+            <a:r>
+              <a:rPr sz="1500" b="0" i="0">
                 <a:solidFill>
                   <a:srgbClr val="F1F5F9"/>
                 </a:solidFill>
                 <a:latin typeface="Montserrat"/>
               </a:rPr>
-              <a:t>1. Mês fecha → planilhas de origem atualizadas (DRE, Base RPM, termômetro)</a:t>
-            </a:r>
-          </a:p>
-          <a:p>
-            <a:pPr>
-              <a:spcAft>
-                <a:spcPts val="400"/>
-              </a:spcAft>
-            </a:pPr>
-            <a:r>
-              <a:rPr sz="1350" b="1" i="0">
-                <a:solidFill>
-                  <a:srgbClr val="64748B"/>
-                </a:solidFill>
-                <a:latin typeface="Montserrat"/>
-              </a:rPr>
-              <a:t>      –  </a:t>
-            </a:r>
-            <a:r>
-              <a:rPr sz="1350" b="0" i="0">
-                <a:solidFill>
-                  <a:srgbClr val="F1F5F9"/>
-                </a:solidFill>
-                <a:latin typeface="Montserrat"/>
-              </a:rPr>
-              <a:t>2. Admin: FCA · Admin → Gerar Custos + Gerar RPM</a:t>
-            </a:r>
-          </a:p>
-          <a:p>
-            <a:pPr>
-              <a:spcAft>
-                <a:spcPts val="400"/>
-              </a:spcAft>
-            </a:pPr>
-            <a:r>
-              <a:rPr sz="1350" b="1" i="0">
-                <a:solidFill>
-                  <a:srgbClr val="64748B"/>
-                </a:solidFill>
-                <a:latin typeface="Montserrat"/>
-              </a:rPr>
-              <a:t>      –  </a:t>
-            </a:r>
-            <a:r>
-              <a:rPr sz="1350" b="0" i="0">
-                <a:solidFill>
-                  <a:srgbClr val="F1F5F9"/>
-                </a:solidFill>
-                <a:latin typeface="Montserrat"/>
-              </a:rPr>
-              <a:t>3. Unidades: FCA · Preenchimento → tratar desvios → SALVAR</a:t>
-            </a:r>
-          </a:p>
-          <a:p>
-            <a:pPr>
-              <a:spcAft>
-                <a:spcPts val="400"/>
-              </a:spcAft>
-            </a:pPr>
-            <a:r>
-              <a:rPr sz="1350" b="1" i="0">
-                <a:solidFill>
-                  <a:srgbClr val="64748B"/>
-                </a:solidFill>
-                <a:latin typeface="Montserrat"/>
-              </a:rPr>
-              <a:t>      –  </a:t>
-            </a:r>
-            <a:r>
-              <a:rPr sz="1350" b="0" i="0">
-                <a:solidFill>
-                  <a:srgbClr val="F1F5F9"/>
-                </a:solidFill>
-                <a:latin typeface="Montserrat"/>
-              </a:rPr>
-              <a:t>4. Gestão: FCA consolidado · Aderência · Termômetro · MPR</a:t>
-            </a:r>
-          </a:p>
-          <a:p>
-            <a:pPr>
-              <a:spcAft>
-                <a:spcPts val="400"/>
-              </a:spcAft>
-            </a:pPr>
-            <a:r>
-              <a:rPr sz="1350" b="1" i="0">
-                <a:solidFill>
-                  <a:srgbClr val="64748B"/>
-                </a:solidFill>
-                <a:latin typeface="Montserrat"/>
-              </a:rPr>
-              <a:t>      –  </a:t>
-            </a:r>
-            <a:r>
-              <a:rPr sz="1350" b="0" i="0">
-                <a:solidFill>
-                  <a:srgbClr val="F1F5F9"/>
-                </a:solidFill>
-                <a:latin typeface="Montserrat"/>
-              </a:rPr>
-              <a:t>5. Pneus atualiza sozinho (Actions 2×/dia); demais painéis leem as fontes ao abrir</a:t>
+              <a:t>Antes de mexer no visual: ler CLAUDE.md (paleta, componentes, mobile).</a:t>
             </a:r>
           </a:p>
         </p:txBody>
@@ -6287,6 +6358,471 @@
                 <a:latin typeface="Montserrat"/>
               </a:rPr>
               <a:t>Handoff Técnico — TI  ·  15</a:t>
+            </a:r>
+          </a:p>
+        </p:txBody>
+      </p:sp>
+    </p:spTree>
+  </p:cSld>
+  <p:clrMapOvr>
+    <a:masterClrMapping/>
+  </p:clrMapOvr>
+</p:sld>
+</file>
+
+<file path=ppt/slides/slide16.xml><?xml version="1.0" encoding="utf-8"?>
+<p:sld xmlns:a="http://schemas.openxmlformats.org/drawingml/2006/main" xmlns:p="http://schemas.openxmlformats.org/presentationml/2006/main" xmlns:r="http://schemas.openxmlformats.org/officeDocument/2006/relationships">
+  <p:cSld>
+    <p:bg>
+      <p:bgPr>
+        <a:solidFill>
+          <a:srgbClr val="0C1017"/>
+        </a:solidFill>
+        <a:effectLst/>
+      </p:bgPr>
+    </p:bg>
+    <p:spTree>
+      <p:nvGrpSpPr>
+        <p:cNvPr id="1" name=""/>
+        <p:cNvGrpSpPr/>
+        <p:nvPr/>
+      </p:nvGrpSpPr>
+      <p:grpSpPr/>
+      <p:sp>
+        <p:nvSpPr>
+          <p:cNvPr id="2" name="Rectangle 1"/>
+          <p:cNvSpPr/>
+          <p:nvPr/>
+        </p:nvSpPr>
+        <p:spPr>
+          <a:xfrm>
+            <a:off x="0" y="0"/>
+            <a:ext cx="12191695" cy="1170432"/>
+          </a:xfrm>
+          <a:prstGeom prst="rect">
+            <a:avLst/>
+          </a:prstGeom>
+          <a:solidFill>
+            <a:srgbClr val="141B26"/>
+          </a:solidFill>
+          <a:ln>
+            <a:noFill/>
+          </a:ln>
+        </p:spPr>
+        <p:style>
+          <a:lnRef idx="1">
+            <a:schemeClr val="accent1"/>
+          </a:lnRef>
+          <a:fillRef idx="3">
+            <a:schemeClr val="accent1"/>
+          </a:fillRef>
+          <a:effectRef idx="2">
+            <a:schemeClr val="accent1"/>
+          </a:effectRef>
+          <a:fontRef idx="minor">
+            <a:schemeClr val="lt1"/>
+          </a:fontRef>
+        </p:style>
+        <p:txBody>
+          <a:bodyPr rtlCol="0" anchor="ctr"/>
+          <a:lstStyle/>
+          <a:p>
+            <a:pPr algn="ctr"/>
+          </a:p>
+        </p:txBody>
+      </p:sp>
+      <p:sp>
+        <p:nvSpPr>
+          <p:cNvPr id="3" name="Rectangle 2"/>
+          <p:cNvSpPr/>
+          <p:nvPr/>
+        </p:nvSpPr>
+        <p:spPr>
+          <a:xfrm>
+            <a:off x="0" y="1170432"/>
+            <a:ext cx="12191695" cy="27940"/>
+          </a:xfrm>
+          <a:prstGeom prst="rect">
+            <a:avLst/>
+          </a:prstGeom>
+          <a:solidFill>
+            <a:srgbClr val="F97316"/>
+          </a:solidFill>
+          <a:ln>
+            <a:noFill/>
+          </a:ln>
+        </p:spPr>
+        <p:style>
+          <a:lnRef idx="1">
+            <a:schemeClr val="accent1"/>
+          </a:lnRef>
+          <a:fillRef idx="3">
+            <a:schemeClr val="accent1"/>
+          </a:fillRef>
+          <a:effectRef idx="2">
+            <a:schemeClr val="accent1"/>
+          </a:effectRef>
+          <a:fontRef idx="minor">
+            <a:schemeClr val="lt1"/>
+          </a:fontRef>
+        </p:style>
+        <p:txBody>
+          <a:bodyPr rtlCol="0" anchor="ctr"/>
+          <a:lstStyle/>
+          <a:p>
+            <a:pPr algn="ctr"/>
+          </a:p>
+        </p:txBody>
+      </p:sp>
+      <p:sp>
+        <p:nvSpPr>
+          <p:cNvPr id="4" name="TextBox 3"/>
+          <p:cNvSpPr txBox="1"/>
+          <p:nvPr/>
+        </p:nvSpPr>
+        <p:spPr>
+          <a:xfrm>
+            <a:off x="548640" y="109728"/>
+            <a:ext cx="11064240" cy="1005840"/>
+          </a:xfrm>
+          <a:prstGeom prst="rect">
+            <a:avLst/>
+          </a:prstGeom>
+          <a:noFill/>
+        </p:spPr>
+        <p:txBody>
+          <a:bodyPr wrap="square">
+            <a:spAutoFit/>
+          </a:bodyPr>
+          <a:lstStyle/>
+          <a:p>
+            <a:r>
+              <a:rPr sz="1000" b="1" i="0">
+                <a:solidFill>
+                  <a:srgbClr val="64748B"/>
+                </a:solidFill>
+                <a:latin typeface="Montserrat"/>
+              </a:rPr>
+              <a:t>GESTÃO EM MOVIMENTO · BI FROTA</a:t>
+            </a:r>
+          </a:p>
+          <a:p>
+            <a:r>
+              <a:rPr sz="2600" b="1" i="0">
+                <a:solidFill>
+                  <a:srgbClr val="F97316"/>
+                </a:solidFill>
+                <a:latin typeface="Montserrat"/>
+              </a:rPr>
+              <a:t>Links e rotina operacional</a:t>
+            </a:r>
+          </a:p>
+        </p:txBody>
+      </p:sp>
+      <p:sp>
+        <p:nvSpPr>
+          <p:cNvPr id="5" name="TextBox 4"/>
+          <p:cNvSpPr txBox="1"/>
+          <p:nvPr/>
+        </p:nvSpPr>
+        <p:spPr>
+          <a:xfrm>
+            <a:off x="548640" y="1417320"/>
+            <a:ext cx="11064240" cy="5120640"/>
+          </a:xfrm>
+          <a:prstGeom prst="rect">
+            <a:avLst/>
+          </a:prstGeom>
+          <a:noFill/>
+        </p:spPr>
+        <p:txBody>
+          <a:bodyPr wrap="square">
+            <a:spAutoFit/>
+          </a:bodyPr>
+          <a:lstStyle/>
+          <a:p>
+            <a:pPr>
+              <a:spcAft>
+                <a:spcPts val="700"/>
+              </a:spcAft>
+            </a:pPr>
+            <a:r>
+              <a:rPr sz="1500" b="1" i="0">
+                <a:solidFill>
+                  <a:srgbClr val="F97316"/>
+                </a:solidFill>
+                <a:latin typeface="Montserrat"/>
+              </a:rPr>
+              <a:t>▪  </a:t>
+            </a:r>
+            <a:r>
+              <a:rPr sz="1500" b="0" i="0">
+                <a:solidFill>
+                  <a:srgbClr val="F1F5F9"/>
+                </a:solidFill>
+                <a:latin typeface="Montserrat"/>
+              </a:rPr>
+              <a:t>Produção: https://fortesindicadores-byte.github.io/gestao-em-movimento/</a:t>
+            </a:r>
+          </a:p>
+          <a:p>
+            <a:pPr>
+              <a:spcAft>
+                <a:spcPts val="700"/>
+              </a:spcAft>
+            </a:pPr>
+            <a:r>
+              <a:rPr sz="1500" b="1" i="0">
+                <a:solidFill>
+                  <a:srgbClr val="F97316"/>
+                </a:solidFill>
+                <a:latin typeface="Montserrat"/>
+              </a:rPr>
+              <a:t>▪  </a:t>
+            </a:r>
+            <a:r>
+              <a:rPr sz="1500" b="0" i="0">
+                <a:solidFill>
+                  <a:srgbClr val="F1F5F9"/>
+                </a:solidFill>
+                <a:latin typeface="Montserrat"/>
+              </a:rPr>
+              <a:t>Repositório: github.com/fortesindicadores-byte/gestao-em-movimento</a:t>
+            </a:r>
+          </a:p>
+          <a:p>
+            <a:pPr>
+              <a:spcAft>
+                <a:spcPts val="700"/>
+              </a:spcAft>
+            </a:pPr>
+            <a:r>
+              <a:rPr sz="1500" b="1" i="0">
+                <a:solidFill>
+                  <a:srgbClr val="F97316"/>
+                </a:solidFill>
+                <a:latin typeface="Montserrat"/>
+              </a:rPr>
+              <a:t>▪  </a:t>
+            </a:r>
+            <a:r>
+              <a:rPr sz="1500" b="0" i="0">
+                <a:solidFill>
+                  <a:srgbClr val="F1F5F9"/>
+                </a:solidFill>
+                <a:latin typeface="Montserrat"/>
+              </a:rPr>
+              <a:t>Docs no repo: DOCUMENTACAO-TI.md (completo) · CLAUDE.md · PAINEIS.md · HANDOFF.md</a:t>
+            </a:r>
+          </a:p>
+          <a:p>
+            <a:pPr>
+              <a:spcAft>
+                <a:spcPts val="700"/>
+              </a:spcAft>
+            </a:pPr>
+            <a:r>
+              <a:rPr sz="1500" b="1" i="0">
+                <a:solidFill>
+                  <a:srgbClr val="F97316"/>
+                </a:solidFill>
+                <a:latin typeface="Montserrat"/>
+              </a:rPr>
+              <a:t>▪  </a:t>
+            </a:r>
+            <a:r>
+              <a:rPr sz="1500" b="0" i="0">
+                <a:solidFill>
+                  <a:srgbClr val="F1F5F9"/>
+                </a:solidFill>
+                <a:latin typeface="Montserrat"/>
+              </a:rPr>
+              <a:t>Supabase (auth/FCA): lozwipoeacpvplgkrxkq.supabase.co · Conlog (Pneus): ewbzeqsneeylwkxtcpme.supabase.co</a:t>
+            </a:r>
+          </a:p>
+          <a:p>
+            <a:pPr>
+              <a:spcAft>
+                <a:spcPts val="700"/>
+              </a:spcAft>
+            </a:pPr>
+            <a:r>
+              <a:rPr sz="1500" b="1" i="0">
+                <a:solidFill>
+                  <a:srgbClr val="F97316"/>
+                </a:solidFill>
+                <a:latin typeface="Montserrat"/>
+              </a:rPr>
+              <a:t>▪  </a:t>
+            </a:r>
+            <a:r>
+              <a:rPr sz="1500" b="1" i="0">
+                <a:solidFill>
+                  <a:srgbClr val="F97316"/>
+                </a:solidFill>
+                <a:latin typeface="Montserrat"/>
+              </a:rPr>
+              <a:t>Rotina mensal em 5 passos:</a:t>
+            </a:r>
+          </a:p>
+          <a:p>
+            <a:pPr>
+              <a:spcAft>
+                <a:spcPts val="400"/>
+              </a:spcAft>
+            </a:pPr>
+            <a:r>
+              <a:rPr sz="1350" b="1" i="0">
+                <a:solidFill>
+                  <a:srgbClr val="64748B"/>
+                </a:solidFill>
+                <a:latin typeface="Montserrat"/>
+              </a:rPr>
+              <a:t>      –  </a:t>
+            </a:r>
+            <a:r>
+              <a:rPr sz="1350" b="0" i="0">
+                <a:solidFill>
+                  <a:srgbClr val="F1F5F9"/>
+                </a:solidFill>
+                <a:latin typeface="Montserrat"/>
+              </a:rPr>
+              <a:t>1. Mês fecha → planilhas de origem atualizadas (DRE, Base RPM, termômetro)</a:t>
+            </a:r>
+          </a:p>
+          <a:p>
+            <a:pPr>
+              <a:spcAft>
+                <a:spcPts val="400"/>
+              </a:spcAft>
+            </a:pPr>
+            <a:r>
+              <a:rPr sz="1350" b="1" i="0">
+                <a:solidFill>
+                  <a:srgbClr val="64748B"/>
+                </a:solidFill>
+                <a:latin typeface="Montserrat"/>
+              </a:rPr>
+              <a:t>      –  </a:t>
+            </a:r>
+            <a:r>
+              <a:rPr sz="1350" b="0" i="0">
+                <a:solidFill>
+                  <a:srgbClr val="F1F5F9"/>
+                </a:solidFill>
+                <a:latin typeface="Montserrat"/>
+              </a:rPr>
+              <a:t>2. Admin: FCA · Admin → Gerar Custos + Gerar RPM</a:t>
+            </a:r>
+          </a:p>
+          <a:p>
+            <a:pPr>
+              <a:spcAft>
+                <a:spcPts val="400"/>
+              </a:spcAft>
+            </a:pPr>
+            <a:r>
+              <a:rPr sz="1350" b="1" i="0">
+                <a:solidFill>
+                  <a:srgbClr val="64748B"/>
+                </a:solidFill>
+                <a:latin typeface="Montserrat"/>
+              </a:rPr>
+              <a:t>      –  </a:t>
+            </a:r>
+            <a:r>
+              <a:rPr sz="1350" b="0" i="0">
+                <a:solidFill>
+                  <a:srgbClr val="F1F5F9"/>
+                </a:solidFill>
+                <a:latin typeface="Montserrat"/>
+              </a:rPr>
+              <a:t>3. Unidades: FCA · Preenchimento → tratar desvios → SALVAR</a:t>
+            </a:r>
+          </a:p>
+          <a:p>
+            <a:pPr>
+              <a:spcAft>
+                <a:spcPts val="400"/>
+              </a:spcAft>
+            </a:pPr>
+            <a:r>
+              <a:rPr sz="1350" b="1" i="0">
+                <a:solidFill>
+                  <a:srgbClr val="64748B"/>
+                </a:solidFill>
+                <a:latin typeface="Montserrat"/>
+              </a:rPr>
+              <a:t>      –  </a:t>
+            </a:r>
+            <a:r>
+              <a:rPr sz="1350" b="0" i="0">
+                <a:solidFill>
+                  <a:srgbClr val="F1F5F9"/>
+                </a:solidFill>
+                <a:latin typeface="Montserrat"/>
+              </a:rPr>
+              <a:t>4. Gestão: FCA consolidado · Aderência · Termômetro · MPR</a:t>
+            </a:r>
+          </a:p>
+          <a:p>
+            <a:pPr>
+              <a:spcAft>
+                <a:spcPts val="400"/>
+              </a:spcAft>
+            </a:pPr>
+            <a:r>
+              <a:rPr sz="1350" b="1" i="0">
+                <a:solidFill>
+                  <a:srgbClr val="64748B"/>
+                </a:solidFill>
+                <a:latin typeface="Montserrat"/>
+              </a:rPr>
+              <a:t>      –  </a:t>
+            </a:r>
+            <a:r>
+              <a:rPr sz="1350" b="0" i="0">
+                <a:solidFill>
+                  <a:srgbClr val="F1F5F9"/>
+                </a:solidFill>
+                <a:latin typeface="Montserrat"/>
+              </a:rPr>
+              <a:t>5. Pneus atualiza sozinho (Actions 2×/dia); demais painéis leem as fontes ao abrir</a:t>
+            </a:r>
+          </a:p>
+        </p:txBody>
+      </p:sp>
+      <p:sp>
+        <p:nvSpPr>
+          <p:cNvPr id="6" name="TextBox 5"/>
+          <p:cNvSpPr txBox="1"/>
+          <p:nvPr/>
+        </p:nvSpPr>
+        <p:spPr>
+          <a:xfrm>
+            <a:off x="548640" y="6473952"/>
+            <a:ext cx="11064240" cy="320040"/>
+          </a:xfrm>
+          <a:prstGeom prst="rect">
+            <a:avLst/>
+          </a:prstGeom>
+          <a:noFill/>
+        </p:spPr>
+        <p:txBody>
+          <a:bodyPr wrap="square">
+            <a:spAutoFit/>
+          </a:bodyPr>
+          <a:lstStyle/>
+          <a:p>
+            <a:pPr algn="r"/>
+            <a:r>
+              <a:rPr sz="900" b="0" i="0">
+                <a:solidFill>
+                  <a:srgbClr val="64748B"/>
+                </a:solidFill>
+                <a:latin typeface="Montserrat"/>
+              </a:rPr>
+              <a:t>Handoff Técnico — TI  ·  16</a:t>
             </a:r>
           </a:p>
         </p:txBody>
@@ -10187,7 +10723,7 @@
                 </a:solidFill>
                 <a:latin typeface="Montserrat"/>
               </a:rPr>
-              <a:t>tabela snapshot: PK endpoint+branch_id, payload jsonb (vehicles, tires, inspections)</a:t>
+              <a:t>tabela snapshot: 1 linha por (endpoint, filial), payload jsonb já transformado</a:t>
             </a:r>
           </a:p>
           <a:p>
@@ -10212,32 +10748,7 @@
                 </a:solidFill>
                 <a:latin typeface="Montserrat"/>
               </a:rPr>
-              <a:t>carga: GitHub Actions pneus-loader.yml → scripts/pneus-loader.mjs (Prolog API), 2×/dia</a:t>
-            </a:r>
-          </a:p>
-          <a:p>
-            <a:pPr>
-              <a:spcAft>
-                <a:spcPts val="400"/>
-              </a:spcAft>
-            </a:pPr>
-            <a:r>
-              <a:rPr sz="1350" b="1" i="0">
-                <a:solidFill>
-                  <a:srgbClr val="64748B"/>
-                </a:solidFill>
-                <a:latin typeface="Montserrat"/>
-              </a:rPr>
-              <a:t>      –  </a:t>
-            </a:r>
-            <a:r>
-              <a:rPr sz="1350" b="0" i="0">
-                <a:solidFill>
-                  <a:srgbClr val="F1F5F9"/>
-                </a:solidFill>
-                <a:latin typeface="Montserrat"/>
-              </a:rPr>
-              <a:t>credenciais só em secrets do Actions</a:t>
+              <a:t>front lê com chave anon; carga é feita pelo loader (próximo slide)</a:t>
             </a:r>
           </a:p>
           <a:p>
@@ -10454,7 +10965,7 @@
                 </a:solidFill>
                 <a:latin typeface="Montserrat"/>
               </a:rPr>
-              <a:t>Módulo FCA — geração dos desvios</a:t>
+              <a:t>Integração Conlog — leitura da API Prolog</a:t>
             </a:r>
           </a:p>
           <a:p>
@@ -10465,297 +10976,21 @@
                 </a:solidFill>
                 <a:latin typeface="Montserrat"/>
               </a:rPr>
-              <a:t>O banco é o dono; planilhas só entram na geração (admin)</a:t>
-            </a:r>
-          </a:p>
-        </p:txBody>
-      </p:sp>
-      <p:sp>
-        <p:nvSpPr>
-          <p:cNvPr id="5" name="Rounded Rectangle 4"/>
-          <p:cNvSpPr/>
-          <p:nvPr/>
-        </p:nvSpPr>
-        <p:spPr>
-          <a:xfrm>
-            <a:off x="548640" y="1508760"/>
-            <a:ext cx="5394960" cy="2286000"/>
-          </a:xfrm>
-          <a:prstGeom prst="roundRect">
-            <a:avLst/>
-          </a:prstGeom>
-          <a:solidFill>
-            <a:srgbClr val="141B26"/>
-          </a:solidFill>
-          <a:ln w="12700">
-            <a:solidFill>
-              <a:srgbClr val="1E2D40"/>
-            </a:solidFill>
-          </a:ln>
-        </p:spPr>
-        <p:style>
-          <a:lnRef idx="1">
-            <a:schemeClr val="accent1"/>
-          </a:lnRef>
-          <a:fillRef idx="3">
-            <a:schemeClr val="accent1"/>
-          </a:fillRef>
-          <a:effectRef idx="2">
-            <a:schemeClr val="accent1"/>
-          </a:effectRef>
-          <a:fontRef idx="minor">
-            <a:schemeClr val="lt1"/>
-          </a:fontRef>
-        </p:style>
-        <p:txBody>
-          <a:bodyPr rtlCol="0" anchor="t" wrap="square" lIns="146304" rIns="128016" tIns="91440" bIns="73152"/>
-          <a:lstStyle/>
-          <a:p>
-            <a:pPr algn="ctr">
-              <a:spcAft>
-                <a:spcPts val="400"/>
-              </a:spcAft>
-            </a:pPr>
-            <a:r>
-              <a:rPr sz="1300" b="1" i="0">
-                <a:solidFill>
-                  <a:srgbClr val="F97316"/>
-                </a:solidFill>
-                <a:latin typeface="Montserrat"/>
-              </a:rPr>
-              <a:t>GERAR CUSTOS  (?gen=all)</a:t>
-            </a:r>
-          </a:p>
-          <a:p>
-            <a:pPr>
-              <a:spcAft>
-                <a:spcPts val="200"/>
-              </a:spcAft>
-            </a:pPr>
-            <a:r>
-              <a:rPr sz="1100" b="0" i="0">
-                <a:solidFill>
-                  <a:srgbClr val="94A3B8"/>
-                </a:solidFill>
-                <a:latin typeface="Montserrat"/>
-              </a:rPr>
-              <a:t>Lê a DRE do último mês fechado (todas as unidades)</a:t>
-            </a:r>
-          </a:p>
-          <a:p>
-            <a:pPr>
-              <a:spcAft>
-                <a:spcPts val="200"/>
-              </a:spcAft>
-            </a:pPr>
-            <a:r>
-              <a:rPr sz="1100" b="0" i="0">
-                <a:solidFill>
-                  <a:srgbClr val="94A3B8"/>
-                </a:solidFill>
-                <a:latin typeface="Montserrat"/>
-              </a:rPr>
-              <a:t>Desvio = gasto acima do remunerado (custos são negativos na DRE)</a:t>
-            </a:r>
-          </a:p>
-          <a:p>
-            <a:pPr>
-              <a:spcAft>
-                <a:spcPts val="200"/>
-              </a:spcAft>
-            </a:pPr>
-            <a:r>
-              <a:rPr sz="1100" b="0" i="0">
-                <a:solidFill>
-                  <a:srgbClr val="94A3B8"/>
-                </a:solidFill>
-                <a:latin typeface="Montserrat"/>
-              </a:rPr>
-              <a:t>Cria fatos VAZIOS p/ as unidades preencherem</a:t>
-            </a:r>
-          </a:p>
-          <a:p>
-            <a:pPr>
-              <a:spcAft>
-                <a:spcPts val="200"/>
-              </a:spcAft>
-            </a:pPr>
-            <a:r>
-              <a:rPr sz="1100" b="0" i="0">
-                <a:solidFill>
-                  <a:srgbClr val="94A3B8"/>
-                </a:solidFill>
-                <a:latin typeface="Montserrat"/>
-              </a:rPr>
-              <a:t>Km/L e R$/L não viram fato — entram como causa do Combustível</a:t>
-            </a:r>
-          </a:p>
-          <a:p>
-            <a:pPr>
-              <a:spcAft>
-                <a:spcPts val="200"/>
-              </a:spcAft>
-            </a:pPr>
-            <a:r>
-              <a:rPr sz="1100" b="0" i="0">
-                <a:solidFill>
-                  <a:srgbClr val="94A3B8"/>
-                </a:solidFill>
-                <a:latin typeface="Montserrat"/>
-              </a:rPr>
-              <a:t>Causas automáticas: piores placas, dispersão de km</a:t>
-            </a:r>
-          </a:p>
-        </p:txBody>
-      </p:sp>
-      <p:sp>
-        <p:nvSpPr>
-          <p:cNvPr id="6" name="Rounded Rectangle 5"/>
-          <p:cNvSpPr/>
-          <p:nvPr/>
-        </p:nvSpPr>
-        <p:spPr>
-          <a:xfrm>
-            <a:off x="6217920" y="1508760"/>
-            <a:ext cx="5394960" cy="2286000"/>
-          </a:xfrm>
-          <a:prstGeom prst="roundRect">
-            <a:avLst/>
-          </a:prstGeom>
-          <a:solidFill>
-            <a:srgbClr val="141B26"/>
-          </a:solidFill>
-          <a:ln w="12700">
-            <a:solidFill>
-              <a:srgbClr val="1E2D40"/>
-            </a:solidFill>
-          </a:ln>
-        </p:spPr>
-        <p:style>
-          <a:lnRef idx="1">
-            <a:schemeClr val="accent1"/>
-          </a:lnRef>
-          <a:fillRef idx="3">
-            <a:schemeClr val="accent1"/>
-          </a:fillRef>
-          <a:effectRef idx="2">
-            <a:schemeClr val="accent1"/>
-          </a:effectRef>
-          <a:fontRef idx="minor">
-            <a:schemeClr val="lt1"/>
-          </a:fontRef>
-        </p:style>
-        <p:txBody>
-          <a:bodyPr rtlCol="0" anchor="t" wrap="square" lIns="146304" rIns="128016" tIns="91440" bIns="73152"/>
-          <a:lstStyle/>
-          <a:p>
-            <a:pPr algn="ctr">
-              <a:spcAft>
-                <a:spcPts val="400"/>
-              </a:spcAft>
-            </a:pPr>
-            <a:r>
-              <a:rPr sz="1300" b="1" i="0">
-                <a:solidFill>
-                  <a:srgbClr val="F97316"/>
-                </a:solidFill>
-                <a:latin typeface="Montserrat"/>
-              </a:rPr>
-              <a:t>GERAR RPM  (?sync=rpm)</a:t>
-            </a:r>
-          </a:p>
-          <a:p>
-            <a:pPr>
-              <a:spcAft>
-                <a:spcPts val="200"/>
-              </a:spcAft>
-            </a:pPr>
-            <a:r>
-              <a:rPr sz="1100" b="0" i="0">
-                <a:solidFill>
-                  <a:srgbClr val="94A3B8"/>
-                </a:solidFill>
-                <a:latin typeface="Montserrat"/>
-              </a:rPr>
-              <a:t>Lê a aba Base RPM do Gerot POR NOME de coluna</a:t>
-            </a:r>
-          </a:p>
-          <a:p>
-            <a:pPr>
-              <a:spcAft>
-                <a:spcPts val="200"/>
-              </a:spcAft>
-            </a:pPr>
-            <a:r>
-              <a:rPr sz="1100" b="0" i="0">
-                <a:solidFill>
-                  <a:srgbClr val="94A3B8"/>
-                </a:solidFill>
-                <a:latin typeface="Montserrat"/>
-              </a:rPr>
-              <a:t>IC/IV com atingimento &lt; 100% viram fato (desvio Meta|Real|Ating)</a:t>
-            </a:r>
-          </a:p>
-          <a:p>
-            <a:pPr>
-              <a:spcAft>
-                <a:spcPts val="200"/>
-              </a:spcAft>
-            </a:pPr>
-            <a:r>
-              <a:rPr sz="1100" b="0" i="0">
-                <a:solidFill>
-                  <a:srgbClr val="94A3B8"/>
-                </a:solidFill>
-                <a:latin typeface="Montserrat"/>
-              </a:rPr>
-              <a:t>Unidade→(código, projeto) fixo no código: RPM_UNIT_MAP</a:t>
-            </a:r>
-          </a:p>
-          <a:p>
-            <a:pPr>
-              <a:spcAft>
-                <a:spcPts val="200"/>
-              </a:spcAft>
-            </a:pPr>
-            <a:r>
-              <a:rPr sz="1100" b="0" i="0">
-                <a:solidFill>
-                  <a:srgbClr val="94A3B8"/>
-                </a:solidFill>
-                <a:latin typeface="Montserrat"/>
-              </a:rPr>
-              <a:t>Corte FILL_UNTIL=202604: ≤mai/26 veio preenchido da aba;</a:t>
-            </a:r>
-          </a:p>
-          <a:p>
-            <a:pPr>
-              <a:spcAft>
-                <a:spcPts val="200"/>
-              </a:spcAft>
-            </a:pPr>
-            <a:r>
-              <a:rPr sz="1100" b="0" i="0">
-                <a:solidFill>
-                  <a:srgbClr val="94A3B8"/>
-                </a:solidFill>
-                <a:latin typeface="Montserrat"/>
-              </a:rPr>
-              <a:t>de jun/26 em diante nasce vazio (preenchimento é no painel)</a:t>
-            </a:r>
-          </a:p>
-        </p:txBody>
-      </p:sp>
-      <p:sp>
-        <p:nvSpPr>
-          <p:cNvPr id="7" name="TextBox 6"/>
+              <a:t>Único ETL do projeto: scripts/pneus-loader.mjs (Node) via GitHub Actions</a:t>
+            </a:r>
+          </a:p>
+        </p:txBody>
+      </p:sp>
+      <p:sp>
+        <p:nvSpPr>
+          <p:cNvPr id="5" name="TextBox 4"/>
           <p:cNvSpPr txBox="1"/>
           <p:nvPr/>
         </p:nvSpPr>
         <p:spPr>
           <a:xfrm>
-            <a:off x="548640" y="4069080"/>
-            <a:ext cx="11064240" cy="1828800"/>
+            <a:off x="548640" y="1417320"/>
+            <a:ext cx="11064240" cy="5120640"/>
           </a:xfrm>
           <a:prstGeom prst="rect">
             <a:avLst/>
@@ -10768,43 +11003,260 @@
           </a:bodyPr>
           <a:lstStyle/>
           <a:p>
+            <a:pPr>
+              <a:spcAft>
+                <a:spcPts val="700"/>
+              </a:spcAft>
+            </a:pPr>
             <a:r>
               <a:rPr sz="1500" b="1" i="0">
                 <a:solidFill>
-                  <a:srgbClr val="3BB33B"/>
-                </a:solidFill>
-                <a:latin typeface="Montserrat"/>
-              </a:rPr>
-              <a:t>As duas rotinas são ADITIVAS e IDEMPOTENTES:</a:t>
-            </a:r>
-          </a:p>
-          <a:p>
-            <a:r>
-              <a:rPr sz="1300" b="0" i="0">
-                <a:solidFill>
-                  <a:srgbClr val="94A3B8"/>
-                </a:solidFill>
-                <a:latin typeface="Montserrat"/>
-              </a:rPr>
-              <a:t>só inserem o que não existe (chave = vigência+origem+projeto+fato). Nunca apagam nem sobrescrevem o que a unidade preencheu. Clicar 2× não duplica.</a:t>
-            </a:r>
-          </a:p>
-          <a:p>
-            <a:r>
-              <a:rPr sz="1200" b="0" i="0">
+                  <a:srgbClr val="F97316"/>
+                </a:solidFill>
+                <a:latin typeface="Montserrat"/>
+              </a:rPr>
+              <a:t>▪  </a:t>
+            </a:r>
+            <a:r>
+              <a:rPr sz="1500" b="0" i="0">
+                <a:solidFill>
+                  <a:srgbClr val="F1F5F9"/>
+                </a:solidFill>
+                <a:latin typeface="Montserrat"/>
+              </a:rPr>
+              <a:t>API: https://prologapp.com/prolog/api/v3 · auth por header x-prolog-api-token (secret PROLOG_TOKEN).</a:t>
+            </a:r>
+          </a:p>
+          <a:p>
+            <a:pPr>
+              <a:spcAft>
+                <a:spcPts val="700"/>
+              </a:spcAft>
+            </a:pPr>
+            <a:r>
+              <a:rPr sz="1500" b="1" i="0">
+                <a:solidFill>
+                  <a:srgbClr val="F97316"/>
+                </a:solidFill>
+                <a:latin typeface="Montserrat"/>
+              </a:rPr>
+              <a:t>▪  </a:t>
+            </a:r>
+            <a:r>
+              <a:rPr sz="1500" b="0" i="0">
+                <a:solidFill>
+                  <a:srgbClr val="F1F5F9"/>
+                </a:solidFill>
+                <a:latin typeface="Montserrat"/>
+              </a:rPr>
+              <a:t>Endpoints lidos por unidade (branchOfficesId — 14 filiais fixas no script):</a:t>
+            </a:r>
+          </a:p>
+          <a:p>
+            <a:pPr>
+              <a:spcAft>
+                <a:spcPts val="400"/>
+              </a:spcAft>
+            </a:pPr>
+            <a:r>
+              <a:rPr sz="1350" b="1" i="0">
                 <a:solidFill>
                   <a:srgbClr val="64748B"/>
                 </a:solidFill>
                 <a:latin typeface="Montserrat"/>
               </a:rPr>
-              <a:t>Cutover: o histórico foi importado uma única vez do “FCA Total” (rotina já removida da UI). A planilha FCA Total é LEGADO — não é mais fonte.</a:t>
-            </a:r>
-          </a:p>
-        </p:txBody>
-      </p:sp>
-      <p:sp>
-        <p:nvSpPr>
-          <p:cNvPr id="8" name="TextBox 7"/>
+              <a:t>      –  </a:t>
+            </a:r>
+            <a:r>
+              <a:rPr sz="1350" b="0" i="0">
+                <a:solidFill>
+                  <a:srgbClr val="F1F5F9"/>
+                </a:solidFill>
+                <a:latin typeface="Montserrat"/>
+              </a:rPr>
+              <a:t>GET /vehicles (includeInactive=false) → frota ativa</a:t>
+            </a:r>
+          </a:p>
+          <a:p>
+            <a:pPr>
+              <a:spcAft>
+                <a:spcPts val="400"/>
+              </a:spcAft>
+            </a:pPr>
+            <a:r>
+              <a:rPr sz="1350" b="1" i="0">
+                <a:solidFill>
+                  <a:srgbClr val="64748B"/>
+                </a:solidFill>
+                <a:latin typeface="Montserrat"/>
+              </a:rPr>
+              <a:t>      –  </a:t>
+            </a:r>
+            <a:r>
+              <a:rPr sz="1350" b="0" i="0">
+                <a:solidFill>
+                  <a:srgbClr val="F1F5F9"/>
+                </a:solidFill>
+                <a:latin typeface="Montserrat"/>
+              </a:rPr>
+              <a:t>GET /tires → sulcos, menor sulco, amplitude, pressão atual × recomendada (% desvio), recapagens</a:t>
+            </a:r>
+          </a:p>
+          <a:p>
+            <a:pPr>
+              <a:spcAft>
+                <a:spcPts val="400"/>
+              </a:spcAft>
+            </a:pPr>
+            <a:r>
+              <a:rPr sz="1350" b="1" i="0">
+                <a:solidFill>
+                  <a:srgbClr val="64748B"/>
+                </a:solidFill>
+                <a:latin typeface="Montserrat"/>
+              </a:rPr>
+              <a:t>      –  </a:t>
+            </a:r>
+            <a:r>
+              <a:rPr sz="1350" b="0" i="0">
+                <a:solidFill>
+                  <a:srgbClr val="F1F5F9"/>
+                </a:solidFill>
+                <a:latin typeface="Montserrat"/>
+              </a:rPr>
+              <a:t>GET /tire-inspections/vehicles → aferições, janela de 01/01 do ano corrente até hoje</a:t>
+            </a:r>
+          </a:p>
+          <a:p>
+            <a:pPr>
+              <a:spcAft>
+                <a:spcPts val="700"/>
+              </a:spcAft>
+            </a:pPr>
+            <a:r>
+              <a:rPr sz="1500" b="1" i="0">
+                <a:solidFill>
+                  <a:srgbClr val="F97316"/>
+                </a:solidFill>
+                <a:latin typeface="Montserrat"/>
+              </a:rPr>
+              <a:t>▪  </a:t>
+            </a:r>
+            <a:r>
+              <a:rPr sz="1500" b="0" i="0">
+                <a:solidFill>
+                  <a:srgbClr val="F1F5F9"/>
+                </a:solidFill>
+                <a:latin typeface="Montserrat"/>
+              </a:rPr>
+              <a:t>Paginação pageSize=100 · rate limit ~10 req/min → 6,5 s entre chamadas; 429 → espera 61 s; até 6 retries/página.</a:t>
+            </a:r>
+          </a:p>
+          <a:p>
+            <a:pPr>
+              <a:spcAft>
+                <a:spcPts val="700"/>
+              </a:spcAft>
+            </a:pPr>
+            <a:r>
+              <a:rPr sz="1500" b="1" i="0">
+                <a:solidFill>
+                  <a:srgbClr val="F97316"/>
+                </a:solidFill>
+                <a:latin typeface="Montserrat"/>
+              </a:rPr>
+              <a:t>▪  </a:t>
+            </a:r>
+            <a:r>
+              <a:rPr sz="1500" b="0" i="0">
+                <a:solidFill>
+                  <a:srgbClr val="F1F5F9"/>
+                </a:solidFill>
+                <a:latin typeface="Montserrat"/>
+              </a:rPr>
+              <a:t>Proteção: unidade com 0 veículos é PULADA (mantém o snapshot anterior — nunca grava vazio).</a:t>
+            </a:r>
+          </a:p>
+          <a:p>
+            <a:pPr>
+              <a:spcAft>
+                <a:spcPts val="700"/>
+              </a:spcAft>
+            </a:pPr>
+            <a:r>
+              <a:rPr sz="1500" b="1" i="0">
+                <a:solidFill>
+                  <a:srgbClr val="F97316"/>
+                </a:solidFill>
+                <a:latin typeface="Montserrat"/>
+              </a:rPr>
+              <a:t>▪  </a:t>
+            </a:r>
+            <a:r>
+              <a:rPr sz="1500" b="0" i="0">
+                <a:solidFill>
+                  <a:srgbClr val="F1F5F9"/>
+                </a:solidFill>
+                <a:latin typeface="Montserrat"/>
+              </a:rPr>
+              <a:t>Gravação: upsert REST no Supabase Conlog (on_conflict=endpoint,branch_id) com service key — só no Actions.</a:t>
+            </a:r>
+          </a:p>
+          <a:p>
+            <a:pPr>
+              <a:spcAft>
+                <a:spcPts val="700"/>
+              </a:spcAft>
+            </a:pPr>
+            <a:r>
+              <a:rPr sz="1500" b="1" i="0">
+                <a:solidFill>
+                  <a:srgbClr val="F97316"/>
+                </a:solidFill>
+                <a:latin typeface="Montserrat"/>
+              </a:rPr>
+              <a:t>▪  </a:t>
+            </a:r>
+            <a:r>
+              <a:rPr sz="1500" b="0" i="0">
+                <a:solidFill>
+                  <a:srgbClr val="F1F5F9"/>
+                </a:solidFill>
+                <a:latin typeface="Montserrat"/>
+              </a:rPr>
+              <a:t>Agendamento: cron 06h/18h BRT + botão Run workflow · concurrency (1 carga por vez) · timeout 350 min.</a:t>
+            </a:r>
+          </a:p>
+          <a:p>
+            <a:pPr>
+              <a:spcAft>
+                <a:spcPts val="700"/>
+              </a:spcAft>
+            </a:pPr>
+            <a:r>
+              <a:rPr sz="1500" b="1" i="0">
+                <a:solidFill>
+                  <a:srgbClr val="F97316"/>
+                </a:solidFill>
+                <a:latin typeface="Montserrat"/>
+              </a:rPr>
+              <a:t>▪  </a:t>
+            </a:r>
+            <a:r>
+              <a:rPr sz="1500" b="1" i="0">
+                <a:solidFill>
+                  <a:srgbClr val="EAB308"/>
+                </a:solidFill>
+                <a:latin typeface="Montserrat"/>
+              </a:rPr>
+              <a:t>Diagnóstico “Pneus sem dados”: aba Actions → Pneus Loader (Conlog) → logs do último run.</a:t>
+            </a:r>
+          </a:p>
+        </p:txBody>
+      </p:sp>
+      <p:sp>
+        <p:nvSpPr>
+          <p:cNvPr id="6" name="TextBox 5"/>
           <p:cNvSpPr txBox="1"/>
           <p:nvPr/>
         </p:nvSpPr>

</xml_diff>